<commit_message>
Fair baseline comparison: fix stand-in pseudonym cycling, add results
- stub_auth (shared by the ECDSA and central-authority baselines) rotated
  its pseudonym right after the 3rd session; a car ping-ponging between
  RSUs cycled pseudonyms every few BSMs and was flagged and revoked as a
  sybil. It now rotates at the next full authentication and renews its
  ticket every 30 s, like the real protocol. Logs which checks fired.
- collector counts the baselines' accepted handovers (":ok")
- presentation_schemes.json: ours vs ECDSA vs central authority; results
  in docs/results/presentation_schemes and a slide in the deck
- docs/results/README.md: what is real vs simulated, where every output
  is, how to read the baseline comparison

Co-Authored-By: Claude Opus 5.5 <noreply@anthropic.com>
Claude-Session: https://claude.ai/code/session_01RhJ9dStThAs6ZjKvaWLus4
</commit_message>
<xml_diff>
--- a/docs/presentation/vanet_results.pptx
+++ b/docs/presentation/vanet_results.pptx
@@ -18,9 +18,10 @@
     <p:sldId id="266" r:id="rId12"/>
     <p:sldId id="267" r:id="rId13"/>
     <p:sldId id="268" r:id="rId14"/>
+    <p:sldId id="269" r:id="rId15"/>
   </p:sldIdLst>
   <p:notesMasterIdLst>
-    <p:notesMasterId r:id="rId15"/>
+    <p:notesMasterId r:id="rId16"/>
   </p:notesMasterIdLst>
   <p:sldSz cx="12192000" cy="6858000"/>
   <p:notesSz cx="6858000" cy="12192000"/>
@@ -2557,6 +2558,378 @@
 </c:chartSpace>
 </file>
 
+<file path=ppt/charts/chart8.xml><?xml version="1.0" encoding="utf-8"?>
+<c:chartSpace xmlns:c="http://schemas.openxmlformats.org/drawingml/2006/chart" xmlns:a="http://schemas.openxmlformats.org/drawingml/2006/main" xmlns:r="http://schemas.openxmlformats.org/officeDocument/2006/relationships">
+  <c:date1904 val="0"/>
+  <c:roundedCorners val="1"/>
+  <c:chart>
+    <c:title>
+      <c:tx>
+        <c:rich>
+          <a:bodyPr/>
+          <a:lstStyle/>
+          <a:p>
+            <a:pPr>
+              <a:defRPr sz="1400" b="0" i="0" u="none" strike="noStrike">
+                <a:solidFill>
+                  <a:srgbClr val="1F2A36"/>
+                </a:solidFill>
+                <a:latin typeface="Calibri"/>
+              </a:defRPr>
+            </a:pPr>
+            <a:r>
+              <a:rPr sz="1400" b="0" i="0" u="none" strike="noStrike">
+                <a:solidFill>
+                  <a:srgbClr val="1F2A36"/>
+                </a:solidFill>
+                <a:latin typeface="Calibri"/>
+              </a:rPr>
+              <a:t>Latency at 60 vehicles (ms)</a:t>
+            </a:r>
+          </a:p>
+        </c:rich>
+      </c:tx>
+      <c:layout/>
+      <c:overlay val="0"/>
+    </c:title>
+    <c:autoTitleDeleted val="0"/>
+    <c:plotArea>
+      <c:layout/>
+      <c:barChart>
+        <c:barDir val="col"/>
+        <c:grouping val="clustered"/>
+        <c:varyColors val="0"/>
+        <c:ser>
+          <c:idx val="0"/>
+          <c:order val="0"/>
+          <c:tx>
+            <c:strRef>
+              <c:f>Sheet1!$B$1</c:f>
+              <c:strCache>
+                <c:ptCount val="1"/>
+                <c:pt idx="0">
+                  <c:v>auth median (ms)</c:v>
+                </c:pt>
+              </c:strCache>
+            </c:strRef>
+          </c:tx>
+          <c:spPr>
+            <a:solidFill>
+              <a:srgbClr val="1F9E8F"/>
+            </a:solidFill>
+            <a:effectLst/>
+          </c:spPr>
+          <c:invertIfNegative val="0"/>
+          <c:dLbls>
+            <c:numFmt formatCode="0.0" sourceLinked="0"/>
+            <c:txPr>
+              <a:bodyPr/>
+              <a:lstStyle/>
+              <a:p>
+                <a:pPr>
+                  <a:defRPr b="0" i="0" strike="noStrike" sz="1100" u="none">
+                    <a:solidFill>
+                      <a:srgbClr val="1F2A36"/>
+                    </a:solidFill>
+                    <a:latin typeface="Calibri"/>
+                  </a:defRPr>
+                </a:pPr>
+              </a:p>
+            </c:txPr>
+            <c:showLegendKey val="0"/>
+            <c:showVal val="1"/>
+            <c:showCatName val="0"/>
+            <c:showSerName val="0"/>
+            <c:showPercent val="0"/>
+            <c:showBubbleSize val="0"/>
+            <c:showLeaderLines val="0"/>
+          </c:dLbls>
+          <c:cat>
+            <c:multiLvlStrRef>
+              <c:f>Sheet1!$A$2:$A$4</c:f>
+              <c:multiLvlStrCache>
+                <c:ptCount val="3"/>
+                <c:lvl>
+                  <c:pt idx="0">
+                    <c:v>Ours (ZKP + ledger)</c:v>
+                  </c:pt>
+                  <c:pt idx="1">
+                    <c:v>ECDSA certificates</c:v>
+                  </c:pt>
+                  <c:pt idx="2">
+                    <c:v>Central authority</c:v>
+                  </c:pt>
+                </c:lvl>
+              </c:multiLvlStrCache>
+            </c:multiLvlStrRef>
+          </c:cat>
+          <c:val>
+            <c:numRef>
+              <c:f>Sheet1!$B$2:$B$4</c:f>
+              <c:numCache>
+                <c:formatCode>General</c:formatCode>
+                <c:ptCount val="3"/>
+                <c:pt idx="0">
+                  <c:v>1.9639999999999997</c:v>
+                </c:pt>
+                <c:pt idx="1">
+                  <c:v>1.2751666666666666</c:v>
+                </c:pt>
+                <c:pt idx="2">
+                  <c:v>22.247</c:v>
+                </c:pt>
+              </c:numCache>
+            </c:numRef>
+          </c:val>
+        </c:ser>
+        <c:ser>
+          <c:idx val="1"/>
+          <c:order val="1"/>
+          <c:tx>
+            <c:strRef>
+              <c:f>Sheet1!$C$1</c:f>
+              <c:strCache>
+                <c:ptCount val="1"/>
+                <c:pt idx="0">
+                  <c:v>handover median (ms)</c:v>
+                </c:pt>
+              </c:strCache>
+            </c:strRef>
+          </c:tx>
+          <c:spPr>
+            <a:solidFill>
+              <a:srgbClr val="1F2A36"/>
+            </a:solidFill>
+            <a:effectLst/>
+          </c:spPr>
+          <c:invertIfNegative val="0"/>
+          <c:dLbls>
+            <c:numFmt formatCode="0.0" sourceLinked="0"/>
+            <c:txPr>
+              <a:bodyPr/>
+              <a:lstStyle/>
+              <a:p>
+                <a:pPr>
+                  <a:defRPr b="0" i="0" strike="noStrike" sz="1100" u="none">
+                    <a:solidFill>
+                      <a:srgbClr val="1F2A36"/>
+                    </a:solidFill>
+                    <a:latin typeface="Calibri"/>
+                  </a:defRPr>
+                </a:pPr>
+              </a:p>
+            </c:txPr>
+            <c:showLegendKey val="0"/>
+            <c:showVal val="1"/>
+            <c:showCatName val="0"/>
+            <c:showSerName val="0"/>
+            <c:showPercent val="0"/>
+            <c:showBubbleSize val="0"/>
+            <c:showLeaderLines val="0"/>
+          </c:dLbls>
+          <c:cat>
+            <c:multiLvlStrRef>
+              <c:f>Sheet1!$A$2:$A$4</c:f>
+              <c:multiLvlStrCache>
+                <c:ptCount val="3"/>
+                <c:lvl>
+                  <c:pt idx="0">
+                    <c:v>Ours (ZKP + ledger)</c:v>
+                  </c:pt>
+                  <c:pt idx="1">
+                    <c:v>ECDSA certificates</c:v>
+                  </c:pt>
+                  <c:pt idx="2">
+                    <c:v>Central authority</c:v>
+                  </c:pt>
+                </c:lvl>
+              </c:multiLvlStrCache>
+            </c:multiLvlStrRef>
+          </c:cat>
+          <c:val>
+            <c:numRef>
+              <c:f>Sheet1!$C$2:$C$4</c:f>
+              <c:numCache>
+                <c:formatCode>General</c:formatCode>
+                <c:ptCount val="3"/>
+                <c:pt idx="0">
+                  <c:v>1.5913333333333333</c:v>
+                </c:pt>
+                <c:pt idx="1">
+                  <c:v>1.2163333333333333</c:v>
+                </c:pt>
+                <c:pt idx="2">
+                  <c:v>22.203333333333333</c:v>
+                </c:pt>
+              </c:numCache>
+            </c:numRef>
+          </c:val>
+        </c:ser>
+        <c:dLbls>
+          <c:numFmt formatCode="0.0" sourceLinked="0"/>
+          <c:txPr>
+            <a:bodyPr/>
+            <a:lstStyle/>
+            <a:p>
+              <a:pPr>
+                <a:defRPr b="0" i="0" strike="noStrike" sz="1100" u="none">
+                  <a:solidFill>
+                    <a:srgbClr val="1F2A36"/>
+                  </a:solidFill>
+                  <a:latin typeface="Calibri"/>
+                </a:defRPr>
+              </a:pPr>
+            </a:p>
+          </c:txPr>
+          <c:showLegendKey val="0"/>
+          <c:showVal val="1"/>
+          <c:showCatName val="0"/>
+          <c:showSerName val="0"/>
+          <c:showPercent val="0"/>
+          <c:showBubbleSize val="0"/>
+          <c:showLeaderLines val="0"/>
+        </c:dLbls>
+        <c:gapWidth val="150"/>
+        <c:overlap val="0"/>
+        <c:axId val="2094734554"/>
+        <c:axId val="2094734552"/>
+        <c:axId val="2094734556"/>
+      </c:barChart>
+      <c:catAx>
+        <c:axId val="2094734554"/>
+        <c:scaling>
+          <c:orientation val="minMax"/>
+        </c:scaling>
+        <c:delete val="0"/>
+        <c:axPos val="b"/>
+        <c:numFmt formatCode="General" sourceLinked="1"/>
+        <c:majorTickMark val="out"/>
+        <c:minorTickMark val="none"/>
+        <c:tickLblPos val="low"/>
+        <c:spPr>
+          <a:ln w="12700" cap="flat">
+            <a:solidFill>
+              <a:srgbClr val="888888"/>
+            </a:solidFill>
+            <a:prstDash val="solid"/>
+            <a:round/>
+          </a:ln>
+        </c:spPr>
+        <c:txPr>
+          <a:bodyPr/>
+          <a:lstStyle/>
+          <a:p>
+            <a:pPr>
+              <a:defRPr sz="1200" b="0" i="0" u="none" strike="noStrike">
+                <a:solidFill>
+                  <a:srgbClr val="5B6B7A"/>
+                </a:solidFill>
+                <a:latin typeface="Calibri"/>
+              </a:defRPr>
+            </a:pPr>
+            <a:endParaRPr lang="en-US"/>
+          </a:p>
+        </c:txPr>
+        <c:crossAx val="2094734552"/>
+        <c:crosses val="autoZero"/>
+        <c:auto val="1"/>
+        <c:lblAlgn val="ctr"/>
+        <c:noMultiLvlLbl val="1"/>
+      </c:catAx>
+      <c:valAx>
+        <c:axId val="2094734552"/>
+        <c:scaling>
+          <c:orientation val="minMax"/>
+        </c:scaling>
+        <c:delete val="0"/>
+        <c:axPos val="l"/>
+        <c:majorGridlines>
+          <c:spPr>
+            <a:ln w="6350" cap="flat">
+              <a:solidFill>
+                <a:srgbClr val="D5DCE3"/>
+              </a:solidFill>
+              <a:prstDash val="solid"/>
+              <a:round/>
+            </a:ln>
+          </c:spPr>
+        </c:majorGridlines>
+        <c:numFmt formatCode="General" sourceLinked="0"/>
+        <c:majorTickMark val="out"/>
+        <c:minorTickMark val="none"/>
+        <c:tickLblPos val="nextTo"/>
+        <c:spPr>
+          <a:ln w="12700" cap="flat">
+            <a:solidFill>
+              <a:srgbClr val="888888"/>
+            </a:solidFill>
+            <a:prstDash val="solid"/>
+            <a:round/>
+          </a:ln>
+        </c:spPr>
+        <c:txPr>
+          <a:bodyPr/>
+          <a:lstStyle/>
+          <a:p>
+            <a:pPr>
+              <a:defRPr sz="1100" b="0" i="0" u="none" strike="noStrike">
+                <a:solidFill>
+                  <a:srgbClr val="5B6B7A"/>
+                </a:solidFill>
+                <a:latin typeface="Calibri"/>
+              </a:defRPr>
+            </a:pPr>
+            <a:endParaRPr lang="en-US"/>
+          </a:p>
+        </c:txPr>
+        <c:crossAx val="2094734554"/>
+        <c:crosses val="autoZero"/>
+        <c:crossBetween val="between"/>
+      </c:valAx>
+      <c:spPr>
+        <a:noFill/>
+        <a:ln>
+          <a:noFill/>
+        </a:ln>
+        <a:effectLst/>
+      </c:spPr>
+    </c:plotArea>
+    <c:legend>
+      <c:legendPos val="b"/>
+      <c:overlay val="0"/>
+      <c:txPr>
+        <a:bodyPr/>
+        <a:lstStyle/>
+        <a:p>
+          <a:pPr>
+            <a:defRPr sz="1200">
+              <a:solidFill>
+                <a:srgbClr val="1F2A36"/>
+              </a:solidFill>
+              <a:latin typeface="Calibri"/>
+              <a:cs typeface="Calibri"/>
+            </a:defRPr>
+          </a:pPr>
+          <a:endParaRPr lang="en-US"/>
+        </a:p>
+      </c:txPr>
+    </c:legend>
+    <c:plotVisOnly val="1"/>
+    <c:dispBlanksAs val="span"/>
+  </c:chart>
+  <c:spPr>
+    <a:noFill/>
+    <a:ln>
+      <a:noFill/>
+    </a:ln>
+    <a:effectLst/>
+  </c:spPr>
+  <c:externalData r:id="rId1">
+    <c:autoUpdate val="0"/>
+  </c:externalData>
+</c:chartSpace>
+</file>
+
 <file path=ppt/notesMasters/notesMaster1.xml><?xml version="1.0" encoding="utf-8"?>
 <p:notesMaster xmlns:a="http://schemas.openxmlformats.org/drawingml/2006/main" xmlns:r="http://schemas.openxmlformats.org/officeDocument/2006/relationships" xmlns:p="http://schemas.openxmlformats.org/presentationml/2006/main">
   <p:cSld>
@@ -3328,6 +3701,94 @@
             <a:fld id="{F7021451-1387-4CA6-816F-3879F97B5CBC}" type="slidenum">
               <a:rPr lang="en-US"/>
               <a:t>13</a:t>
+            </a:fld>
+            <a:endParaRPr lang="en-US"/>
+          </a:p>
+        </p:txBody>
+      </p:sp>
+    </p:spTree>
+    <p:extLst>
+      <p:ext uri="{BB962C8B-B14F-4D97-AF65-F5344CB8AC3E}">
+        <p14:creationId xmlns:p14="http://schemas.microsoft.com/office/powerpoint/2010/main" val="1024086991"/>
+      </p:ext>
+    </p:extLst>
+  </p:cSld>
+  <p:clrMapOvr>
+    <a:masterClrMapping/>
+  </p:clrMapOvr>
+</p:notes>
+</file>
+
+<file path=ppt/notesSlides/notesSlide14.xml><?xml version="1.0" encoding="utf-8"?>
+<p:notes xmlns:a="http://schemas.openxmlformats.org/drawingml/2006/main" xmlns:r="http://schemas.openxmlformats.org/officeDocument/2006/relationships" xmlns:p="http://schemas.openxmlformats.org/presentationml/2006/main">
+  <p:cSld>
+    <p:spTree>
+      <p:nvGrpSpPr>
+        <p:cNvPr id="1" name=""/>
+        <p:cNvGrpSpPr/>
+        <p:nvPr/>
+      </p:nvGrpSpPr>
+      <p:grpSpPr>
+        <a:xfrm>
+          <a:off x="0" y="0"/>
+          <a:ext cx="0" cy="0"/>
+          <a:chOff x="0" y="0"/>
+          <a:chExt cx="0" cy="0"/>
+        </a:xfrm>
+      </p:grpSpPr>
+      <p:sp>
+        <p:nvSpPr>
+          <p:cNvPr id="2" name="Slide Image Placeholder 1"/>
+          <p:cNvSpPr>
+            <a:spLocks noGrp="1" noRot="1" noChangeAspect="1"/>
+          </p:cNvSpPr>
+          <p:nvPr>
+            <p:ph type="sldImg"/>
+          </p:nvPr>
+        </p:nvSpPr>
+        <p:spPr/>
+      </p:sp>
+      <p:sp>
+        <p:nvSpPr>
+          <p:cNvPr id="3" name="Notes Placeholder 2"/>
+          <p:cNvSpPr>
+            <a:spLocks noGrp="1"/>
+          </p:cNvSpPr>
+          <p:nvPr>
+            <p:ph type="body" idx="1"/>
+          </p:nvPr>
+        </p:nvSpPr>
+        <p:spPr/>
+        <p:txBody>
+          <a:bodyPr/>
+          <a:lstStyle/>
+          <a:p>
+            <a:r>
+              <a:rPr lang="en-US" dirty="0"/>
+              <a:t/>
+            </a:r>
+            <a:endParaRPr lang="en-US" dirty="0"/>
+          </a:p>
+        </p:txBody>
+      </p:sp>
+      <p:sp>
+        <p:nvSpPr>
+          <p:cNvPr id="4" name="Slide Number Placeholder 3"/>
+          <p:cNvSpPr>
+            <a:spLocks noGrp="1"/>
+          </p:cNvSpPr>
+          <p:nvPr>
+            <p:ph type="sldNum" sz="quarter" idx="10"/>
+          </p:nvPr>
+        </p:nvSpPr>
+        <p:spPr/>
+        <p:txBody>
+          <a:bodyPr/>
+          <a:lstStyle/>
+          <a:p>
+            <a:fld id="{F7021451-1387-4CA6-816F-3879F97B5CBC}" type="slidenum">
+              <a:rPr lang="en-US"/>
+              <a:t>14</a:t>
             </a:fld>
             <a:endParaRPr lang="en-US"/>
           </a:p>
@@ -4951,15 +5412,1882 @@
                 <a:ea typeface="Cambria" pitchFamily="34" charset="-122"/>
                 <a:cs typeface="Cambria" pitchFamily="34" charset="-120"/>
               </a:rPr>
-              <a:t>What we fixed to get trustworthy numbers</a:t>
+              <a:t>Against the baselines: privacy and accountability for ~1 ms</a:t>
             </a:r>
             <a:endParaRPr lang="en-US" sz="3200" dirty="0"/>
           </a:p>
         </p:txBody>
       </p:sp>
+      <p:graphicFrame>
+        <p:nvGraphicFramePr>
+          <p:cNvPr id="3" name="Chart 0" descr=""/>
+          <p:cNvGraphicFramePr/>
+          <p:nvPr/>
+        </p:nvGraphicFramePr>
+        <p:xfrm>
+          <a:off x="548640" y="1325880"/>
+          <a:ext cx="5120640" cy="3291840"/>
+        </p:xfrm>
+        <a:graphic xmlns:a="http://schemas.openxmlformats.org/drawingml/2006/main">
+          <a:graphicData uri="http://schemas.openxmlformats.org/drawingml/2006/chart">
+            <c:chart xmlns:c="http://schemas.openxmlformats.org/drawingml/2006/chart" r:id="rId1"/>
+          </a:graphicData>
+        </a:graphic>
+      </p:graphicFrame>
       <p:graphicFrame>
         <p:nvGraphicFramePr>
           <p:cNvPr id="12" name="Table 0"/>
+          <p:cNvGraphicFramePr>
+            <a:graphicFrameLocks noGrp="1"/>
+          </p:cNvGraphicFramePr>
+          <p:nvPr>
+            <p:extLst>
+              <p:ext uri="{D42A27DB-BD31-4B8C-83A1-F6EECF244321}">
+                <p14:modId xmlns:p14="http://schemas.microsoft.com/office/powerpoint/2010/main" val="1579011935"/>
+              </p:ext>
+            </p:extLst>
+          </p:nvPr>
+        </p:nvGraphicFramePr>
+        <p:xfrm>
+          <a:off x="5943600" y="1371600"/>
+          <a:ext cx="5669280" cy="914400"/>
+        </p:xfrm>
+        <a:graphic>
+          <a:graphicData uri="http://schemas.openxmlformats.org/drawingml/2006/table">
+            <a:tbl>
+              <a:tblPr/>
+              <a:tblGrid>
+                <a:gridCol w="2468880"/>
+                <a:gridCol w="914400"/>
+                <a:gridCol w="1371600"/>
+                <a:gridCol w="914400"/>
+              </a:tblGrid>
+              <a:tr h="438912">
+                <a:tc>
+                  <a:txBody>
+                    <a:bodyPr/>
+                    <a:lstStyle/>
+                    <a:p>
+                      <a:pPr indent="0" marL="0">
+                        <a:buNone/>
+                      </a:pPr>
+                      <a:endParaRPr lang="en-US" sz="1300" dirty="0">
+                        <a:latin typeface="Calibri" charset="0"/>
+                        <a:ea typeface="Calibri" charset="0"/>
+                        <a:cs typeface="Calibri" charset="0"/>
+                      </a:endParaRPr>
+                    </a:p>
+                  </a:txBody>
+                  <a:tcPr marL="91440" marR="91440" marT="45720" marB="45720" anchor="ctr">
+                    <a:lnL w="9525" cap="flat" cmpd="sng" algn="ctr">
+                      <a:solidFill>
+                        <a:srgbClr val="D5DCE3"/>
+                      </a:solidFill>
+                      <a:prstDash val="solid"/>
+                      <a:round/>
+                      <a:headEnd type="none" w="med" len="med"/>
+                      <a:tailEnd type="none" w="med" len="med"/>
+                    </a:lnL>
+                    <a:lnR w="9525" cap="flat" cmpd="sng" algn="ctr">
+                      <a:solidFill>
+                        <a:srgbClr val="D5DCE3"/>
+                      </a:solidFill>
+                      <a:prstDash val="solid"/>
+                      <a:round/>
+                      <a:headEnd type="none" w="med" len="med"/>
+                      <a:tailEnd type="none" w="med" len="med"/>
+                    </a:lnR>
+                    <a:lnT w="9525" cap="flat" cmpd="sng" algn="ctr">
+                      <a:solidFill>
+                        <a:srgbClr val="D5DCE3"/>
+                      </a:solidFill>
+                      <a:prstDash val="solid"/>
+                      <a:round/>
+                      <a:headEnd type="none" w="med" len="med"/>
+                      <a:tailEnd type="none" w="med" len="med"/>
+                    </a:lnT>
+                    <a:lnB w="9525" cap="flat" cmpd="sng" algn="ctr">
+                      <a:solidFill>
+                        <a:srgbClr val="D5DCE3"/>
+                      </a:solidFill>
+                      <a:prstDash val="solid"/>
+                      <a:round/>
+                      <a:headEnd type="none" w="med" len="med"/>
+                      <a:tailEnd type="none" w="med" len="med"/>
+                    </a:lnB>
+                    <a:solidFill>
+                      <a:srgbClr val="1F2A36"/>
+                    </a:solidFill>
+                  </a:tcPr>
+                </a:tc>
+                <a:tc>
+                  <a:txBody>
+                    <a:bodyPr/>
+                    <a:lstStyle/>
+                    <a:p>
+                      <a:pPr indent="0" marL="0">
+                        <a:buNone/>
+                      </a:pPr>
+                      <a:r>
+                        <a:rPr lang="en-US" sz="1300" b="1" dirty="0">
+                          <a:solidFill>
+                            <a:srgbClr val="FFFFFF"/>
+                          </a:solidFill>
+                          <a:latin typeface="Calibri" pitchFamily="34" charset="0"/>
+                          <a:ea typeface="Calibri" pitchFamily="34" charset="-122"/>
+                          <a:cs typeface="Calibri" pitchFamily="34" charset="-120"/>
+                        </a:rPr>
+                        <a:t>Ours</a:t>
+                      </a:r>
+                      <a:endParaRPr lang="en-US" sz="1300" dirty="0">
+                        <a:latin typeface="Calibri" charset="0"/>
+                        <a:ea typeface="Calibri" charset="0"/>
+                        <a:cs typeface="Calibri" charset="0"/>
+                      </a:endParaRPr>
+                    </a:p>
+                  </a:txBody>
+                  <a:tcPr marL="91440" marR="91440" marT="45720" marB="45720" anchor="ctr">
+                    <a:lnL w="9525" cap="flat" cmpd="sng" algn="ctr">
+                      <a:solidFill>
+                        <a:srgbClr val="D5DCE3"/>
+                      </a:solidFill>
+                      <a:prstDash val="solid"/>
+                      <a:round/>
+                      <a:headEnd type="none" w="med" len="med"/>
+                      <a:tailEnd type="none" w="med" len="med"/>
+                    </a:lnL>
+                    <a:lnR w="9525" cap="flat" cmpd="sng" algn="ctr">
+                      <a:solidFill>
+                        <a:srgbClr val="D5DCE3"/>
+                      </a:solidFill>
+                      <a:prstDash val="solid"/>
+                      <a:round/>
+                      <a:headEnd type="none" w="med" len="med"/>
+                      <a:tailEnd type="none" w="med" len="med"/>
+                    </a:lnR>
+                    <a:lnT w="9525" cap="flat" cmpd="sng" algn="ctr">
+                      <a:solidFill>
+                        <a:srgbClr val="D5DCE3"/>
+                      </a:solidFill>
+                      <a:prstDash val="solid"/>
+                      <a:round/>
+                      <a:headEnd type="none" w="med" len="med"/>
+                      <a:tailEnd type="none" w="med" len="med"/>
+                    </a:lnT>
+                    <a:lnB w="9525" cap="flat" cmpd="sng" algn="ctr">
+                      <a:solidFill>
+                        <a:srgbClr val="D5DCE3"/>
+                      </a:solidFill>
+                      <a:prstDash val="solid"/>
+                      <a:round/>
+                      <a:headEnd type="none" w="med" len="med"/>
+                      <a:tailEnd type="none" w="med" len="med"/>
+                    </a:lnB>
+                    <a:solidFill>
+                      <a:srgbClr val="1F2A36"/>
+                    </a:solidFill>
+                  </a:tcPr>
+                </a:tc>
+                <a:tc>
+                  <a:txBody>
+                    <a:bodyPr/>
+                    <a:lstStyle/>
+                    <a:p>
+                      <a:pPr indent="0" marL="0">
+                        <a:buNone/>
+                      </a:pPr>
+                      <a:r>
+                        <a:rPr lang="en-US" sz="1300" b="1" dirty="0">
+                          <a:solidFill>
+                            <a:srgbClr val="FFFFFF"/>
+                          </a:solidFill>
+                          <a:latin typeface="Calibri" pitchFamily="34" charset="0"/>
+                          <a:ea typeface="Calibri" pitchFamily="34" charset="-122"/>
+                          <a:cs typeface="Calibri" pitchFamily="34" charset="-120"/>
+                        </a:rPr>
+                        <a:t>Basic ECDSA PKI</a:t>
+                      </a:r>
+                      <a:endParaRPr lang="en-US" sz="1300" dirty="0">
+                        <a:latin typeface="Calibri" charset="0"/>
+                        <a:ea typeface="Calibri" charset="0"/>
+                        <a:cs typeface="Calibri" charset="0"/>
+                      </a:endParaRPr>
+                    </a:p>
+                  </a:txBody>
+                  <a:tcPr marL="91440" marR="91440" marT="45720" marB="45720" anchor="ctr">
+                    <a:lnL w="9525" cap="flat" cmpd="sng" algn="ctr">
+                      <a:solidFill>
+                        <a:srgbClr val="D5DCE3"/>
+                      </a:solidFill>
+                      <a:prstDash val="solid"/>
+                      <a:round/>
+                      <a:headEnd type="none" w="med" len="med"/>
+                      <a:tailEnd type="none" w="med" len="med"/>
+                    </a:lnL>
+                    <a:lnR w="9525" cap="flat" cmpd="sng" algn="ctr">
+                      <a:solidFill>
+                        <a:srgbClr val="D5DCE3"/>
+                      </a:solidFill>
+                      <a:prstDash val="solid"/>
+                      <a:round/>
+                      <a:headEnd type="none" w="med" len="med"/>
+                      <a:tailEnd type="none" w="med" len="med"/>
+                    </a:lnR>
+                    <a:lnT w="9525" cap="flat" cmpd="sng" algn="ctr">
+                      <a:solidFill>
+                        <a:srgbClr val="D5DCE3"/>
+                      </a:solidFill>
+                      <a:prstDash val="solid"/>
+                      <a:round/>
+                      <a:headEnd type="none" w="med" len="med"/>
+                      <a:tailEnd type="none" w="med" len="med"/>
+                    </a:lnT>
+                    <a:lnB w="9525" cap="flat" cmpd="sng" algn="ctr">
+                      <a:solidFill>
+                        <a:srgbClr val="D5DCE3"/>
+                      </a:solidFill>
+                      <a:prstDash val="solid"/>
+                      <a:round/>
+                      <a:headEnd type="none" w="med" len="med"/>
+                      <a:tailEnd type="none" w="med" len="med"/>
+                    </a:lnB>
+                    <a:solidFill>
+                      <a:srgbClr val="1F2A36"/>
+                    </a:solidFill>
+                  </a:tcPr>
+                </a:tc>
+                <a:tc>
+                  <a:txBody>
+                    <a:bodyPr/>
+                    <a:lstStyle/>
+                    <a:p>
+                      <a:pPr indent="0" marL="0">
+                        <a:buNone/>
+                      </a:pPr>
+                      <a:r>
+                        <a:rPr lang="en-US" sz="1300" b="1" dirty="0">
+                          <a:solidFill>
+                            <a:srgbClr val="FFFFFF"/>
+                          </a:solidFill>
+                          <a:latin typeface="Calibri" pitchFamily="34" charset="0"/>
+                          <a:ea typeface="Calibri" pitchFamily="34" charset="-122"/>
+                          <a:cs typeface="Calibri" pitchFamily="34" charset="-120"/>
+                        </a:rPr>
+                        <a:t>Central</a:t>
+                      </a:r>
+                      <a:endParaRPr lang="en-US" sz="1300" dirty="0">
+                        <a:latin typeface="Calibri" charset="0"/>
+                        <a:ea typeface="Calibri" charset="0"/>
+                        <a:cs typeface="Calibri" charset="0"/>
+                      </a:endParaRPr>
+                    </a:p>
+                  </a:txBody>
+                  <a:tcPr marL="91440" marR="91440" marT="45720" marB="45720" anchor="ctr">
+                    <a:lnL w="9525" cap="flat" cmpd="sng" algn="ctr">
+                      <a:solidFill>
+                        <a:srgbClr val="D5DCE3"/>
+                      </a:solidFill>
+                      <a:prstDash val="solid"/>
+                      <a:round/>
+                      <a:headEnd type="none" w="med" len="med"/>
+                      <a:tailEnd type="none" w="med" len="med"/>
+                    </a:lnL>
+                    <a:lnR w="9525" cap="flat" cmpd="sng" algn="ctr">
+                      <a:solidFill>
+                        <a:srgbClr val="D5DCE3"/>
+                      </a:solidFill>
+                      <a:prstDash val="solid"/>
+                      <a:round/>
+                      <a:headEnd type="none" w="med" len="med"/>
+                      <a:tailEnd type="none" w="med" len="med"/>
+                    </a:lnR>
+                    <a:lnT w="9525" cap="flat" cmpd="sng" algn="ctr">
+                      <a:solidFill>
+                        <a:srgbClr val="D5DCE3"/>
+                      </a:solidFill>
+                      <a:prstDash val="solid"/>
+                      <a:round/>
+                      <a:headEnd type="none" w="med" len="med"/>
+                      <a:tailEnd type="none" w="med" len="med"/>
+                    </a:lnT>
+                    <a:lnB w="9525" cap="flat" cmpd="sng" algn="ctr">
+                      <a:solidFill>
+                        <a:srgbClr val="D5DCE3"/>
+                      </a:solidFill>
+                      <a:prstDash val="solid"/>
+                      <a:round/>
+                      <a:headEnd type="none" w="med" len="med"/>
+                      <a:tailEnd type="none" w="med" len="med"/>
+                    </a:lnB>
+                    <a:solidFill>
+                      <a:srgbClr val="1F2A36"/>
+                    </a:solidFill>
+                  </a:tcPr>
+                </a:tc>
+              </a:tr>
+              <a:tr h="438912">
+                <a:tc>
+                  <a:txBody>
+                    <a:bodyPr/>
+                    <a:lstStyle/>
+                    <a:p>
+                      <a:pPr indent="0" marL="0">
+                        <a:buNone/>
+                      </a:pPr>
+                      <a:r>
+                        <a:rPr lang="en-US" sz="1300" dirty="0">
+                          <a:solidFill>
+                            <a:srgbClr val="1F2A36"/>
+                          </a:solidFill>
+                          <a:latin typeface="Calibri" pitchFamily="34" charset="0"/>
+                          <a:ea typeface="Calibri" pitchFamily="34" charset="-122"/>
+                          <a:cs typeface="Calibri" pitchFamily="34" charset="-120"/>
+                        </a:rPr>
+                        <a:t>Security bytes / BSM</a:t>
+                      </a:r>
+                      <a:endParaRPr lang="en-US" sz="1300" dirty="0">
+                        <a:latin typeface="Calibri" charset="0"/>
+                        <a:ea typeface="Calibri" charset="0"/>
+                        <a:cs typeface="Calibri" charset="0"/>
+                      </a:endParaRPr>
+                    </a:p>
+                  </a:txBody>
+                  <a:tcPr marL="91440" marR="91440" marT="45720" marB="45720" anchor="ctr">
+                    <a:lnL w="9525" cap="flat" cmpd="sng" algn="ctr">
+                      <a:solidFill>
+                        <a:srgbClr val="D5DCE3"/>
+                      </a:solidFill>
+                      <a:prstDash val="solid"/>
+                      <a:round/>
+                      <a:headEnd type="none" w="med" len="med"/>
+                      <a:tailEnd type="none" w="med" len="med"/>
+                    </a:lnL>
+                    <a:lnR w="9525" cap="flat" cmpd="sng" algn="ctr">
+                      <a:solidFill>
+                        <a:srgbClr val="D5DCE3"/>
+                      </a:solidFill>
+                      <a:prstDash val="solid"/>
+                      <a:round/>
+                      <a:headEnd type="none" w="med" len="med"/>
+                      <a:tailEnd type="none" w="med" len="med"/>
+                    </a:lnR>
+                    <a:lnT w="9525" cap="flat" cmpd="sng" algn="ctr">
+                      <a:solidFill>
+                        <a:srgbClr val="D5DCE3"/>
+                      </a:solidFill>
+                      <a:prstDash val="solid"/>
+                      <a:round/>
+                      <a:headEnd type="none" w="med" len="med"/>
+                      <a:tailEnd type="none" w="med" len="med"/>
+                    </a:lnT>
+                    <a:lnB w="9525" cap="flat" cmpd="sng" algn="ctr">
+                      <a:solidFill>
+                        <a:srgbClr val="D5DCE3"/>
+                      </a:solidFill>
+                      <a:prstDash val="solid"/>
+                      <a:round/>
+                      <a:headEnd type="none" w="med" len="med"/>
+                      <a:tailEnd type="none" w="med" len="med"/>
+                    </a:lnB>
+                    <a:solidFill>
+                      <a:srgbClr val="FFFFFF"/>
+                    </a:solidFill>
+                  </a:tcPr>
+                </a:tc>
+                <a:tc>
+                  <a:txBody>
+                    <a:bodyPr/>
+                    <a:lstStyle/>
+                    <a:p>
+                      <a:pPr indent="0" marL="0">
+                        <a:buNone/>
+                      </a:pPr>
+                      <a:r>
+                        <a:rPr lang="en-US" sz="1300" dirty="0">
+                          <a:solidFill>
+                            <a:srgbClr val="1F2A36"/>
+                          </a:solidFill>
+                          <a:latin typeface="Calibri" pitchFamily="34" charset="0"/>
+                          <a:ea typeface="Calibri" pitchFamily="34" charset="-122"/>
+                          <a:cs typeface="Calibri" pitchFamily="34" charset="-120"/>
+                        </a:rPr>
+                        <a:t>145</a:t>
+                      </a:r>
+                      <a:endParaRPr lang="en-US" sz="1300" dirty="0">
+                        <a:latin typeface="Calibri" charset="0"/>
+                        <a:ea typeface="Calibri" charset="0"/>
+                        <a:cs typeface="Calibri" charset="0"/>
+                      </a:endParaRPr>
+                    </a:p>
+                  </a:txBody>
+                  <a:tcPr marL="91440" marR="91440" marT="45720" marB="45720" anchor="ctr">
+                    <a:lnL w="9525" cap="flat" cmpd="sng" algn="ctr">
+                      <a:solidFill>
+                        <a:srgbClr val="D5DCE3"/>
+                      </a:solidFill>
+                      <a:prstDash val="solid"/>
+                      <a:round/>
+                      <a:headEnd type="none" w="med" len="med"/>
+                      <a:tailEnd type="none" w="med" len="med"/>
+                    </a:lnL>
+                    <a:lnR w="9525" cap="flat" cmpd="sng" algn="ctr">
+                      <a:solidFill>
+                        <a:srgbClr val="D5DCE3"/>
+                      </a:solidFill>
+                      <a:prstDash val="solid"/>
+                      <a:round/>
+                      <a:headEnd type="none" w="med" len="med"/>
+                      <a:tailEnd type="none" w="med" len="med"/>
+                    </a:lnR>
+                    <a:lnT w="9525" cap="flat" cmpd="sng" algn="ctr">
+                      <a:solidFill>
+                        <a:srgbClr val="D5DCE3"/>
+                      </a:solidFill>
+                      <a:prstDash val="solid"/>
+                      <a:round/>
+                      <a:headEnd type="none" w="med" len="med"/>
+                      <a:tailEnd type="none" w="med" len="med"/>
+                    </a:lnT>
+                    <a:lnB w="9525" cap="flat" cmpd="sng" algn="ctr">
+                      <a:solidFill>
+                        <a:srgbClr val="D5DCE3"/>
+                      </a:solidFill>
+                      <a:prstDash val="solid"/>
+                      <a:round/>
+                      <a:headEnd type="none" w="med" len="med"/>
+                      <a:tailEnd type="none" w="med" len="med"/>
+                    </a:lnB>
+                    <a:solidFill>
+                      <a:srgbClr val="FFFFFF"/>
+                    </a:solidFill>
+                  </a:tcPr>
+                </a:tc>
+                <a:tc>
+                  <a:txBody>
+                    <a:bodyPr/>
+                    <a:lstStyle/>
+                    <a:p>
+                      <a:pPr indent="0" marL="0">
+                        <a:buNone/>
+                      </a:pPr>
+                      <a:r>
+                        <a:rPr lang="en-US" sz="1300" dirty="0">
+                          <a:solidFill>
+                            <a:srgbClr val="1F2A36"/>
+                          </a:solidFill>
+                          <a:latin typeface="Calibri" pitchFamily="34" charset="0"/>
+                          <a:ea typeface="Calibri" pitchFamily="34" charset="-122"/>
+                          <a:cs typeface="Calibri" pitchFamily="34" charset="-120"/>
+                        </a:rPr>
+                        <a:t>72</a:t>
+                      </a:r>
+                      <a:endParaRPr lang="en-US" sz="1300" dirty="0">
+                        <a:latin typeface="Calibri" charset="0"/>
+                        <a:ea typeface="Calibri" charset="0"/>
+                        <a:cs typeface="Calibri" charset="0"/>
+                      </a:endParaRPr>
+                    </a:p>
+                  </a:txBody>
+                  <a:tcPr marL="91440" marR="91440" marT="45720" marB="45720" anchor="ctr">
+                    <a:lnL w="9525" cap="flat" cmpd="sng" algn="ctr">
+                      <a:solidFill>
+                        <a:srgbClr val="D5DCE3"/>
+                      </a:solidFill>
+                      <a:prstDash val="solid"/>
+                      <a:round/>
+                      <a:headEnd type="none" w="med" len="med"/>
+                      <a:tailEnd type="none" w="med" len="med"/>
+                    </a:lnL>
+                    <a:lnR w="9525" cap="flat" cmpd="sng" algn="ctr">
+                      <a:solidFill>
+                        <a:srgbClr val="D5DCE3"/>
+                      </a:solidFill>
+                      <a:prstDash val="solid"/>
+                      <a:round/>
+                      <a:headEnd type="none" w="med" len="med"/>
+                      <a:tailEnd type="none" w="med" len="med"/>
+                    </a:lnR>
+                    <a:lnT w="9525" cap="flat" cmpd="sng" algn="ctr">
+                      <a:solidFill>
+                        <a:srgbClr val="D5DCE3"/>
+                      </a:solidFill>
+                      <a:prstDash val="solid"/>
+                      <a:round/>
+                      <a:headEnd type="none" w="med" len="med"/>
+                      <a:tailEnd type="none" w="med" len="med"/>
+                    </a:lnT>
+                    <a:lnB w="9525" cap="flat" cmpd="sng" algn="ctr">
+                      <a:solidFill>
+                        <a:srgbClr val="D5DCE3"/>
+                      </a:solidFill>
+                      <a:prstDash val="solid"/>
+                      <a:round/>
+                      <a:headEnd type="none" w="med" len="med"/>
+                      <a:tailEnd type="none" w="med" len="med"/>
+                    </a:lnB>
+                    <a:solidFill>
+                      <a:srgbClr val="FFFFFF"/>
+                    </a:solidFill>
+                  </a:tcPr>
+                </a:tc>
+                <a:tc>
+                  <a:txBody>
+                    <a:bodyPr/>
+                    <a:lstStyle/>
+                    <a:p>
+                      <a:pPr indent="0" marL="0">
+                        <a:buNone/>
+                      </a:pPr>
+                      <a:r>
+                        <a:rPr lang="en-US" sz="1300" dirty="0">
+                          <a:solidFill>
+                            <a:srgbClr val="1F2A36"/>
+                          </a:solidFill>
+                          <a:latin typeface="Calibri" pitchFamily="34" charset="0"/>
+                          <a:ea typeface="Calibri" pitchFamily="34" charset="-122"/>
+                          <a:cs typeface="Calibri" pitchFamily="34" charset="-120"/>
+                        </a:rPr>
+                        <a:t>72</a:t>
+                      </a:r>
+                      <a:endParaRPr lang="en-US" sz="1300" dirty="0">
+                        <a:latin typeface="Calibri" charset="0"/>
+                        <a:ea typeface="Calibri" charset="0"/>
+                        <a:cs typeface="Calibri" charset="0"/>
+                      </a:endParaRPr>
+                    </a:p>
+                  </a:txBody>
+                  <a:tcPr marL="91440" marR="91440" marT="45720" marB="45720" anchor="ctr">
+                    <a:lnL w="9525" cap="flat" cmpd="sng" algn="ctr">
+                      <a:solidFill>
+                        <a:srgbClr val="D5DCE3"/>
+                      </a:solidFill>
+                      <a:prstDash val="solid"/>
+                      <a:round/>
+                      <a:headEnd type="none" w="med" len="med"/>
+                      <a:tailEnd type="none" w="med" len="med"/>
+                    </a:lnL>
+                    <a:lnR w="9525" cap="flat" cmpd="sng" algn="ctr">
+                      <a:solidFill>
+                        <a:srgbClr val="D5DCE3"/>
+                      </a:solidFill>
+                      <a:prstDash val="solid"/>
+                      <a:round/>
+                      <a:headEnd type="none" w="med" len="med"/>
+                      <a:tailEnd type="none" w="med" len="med"/>
+                    </a:lnR>
+                    <a:lnT w="9525" cap="flat" cmpd="sng" algn="ctr">
+                      <a:solidFill>
+                        <a:srgbClr val="D5DCE3"/>
+                      </a:solidFill>
+                      <a:prstDash val="solid"/>
+                      <a:round/>
+                      <a:headEnd type="none" w="med" len="med"/>
+                      <a:tailEnd type="none" w="med" len="med"/>
+                    </a:lnT>
+                    <a:lnB w="9525" cap="flat" cmpd="sng" algn="ctr">
+                      <a:solidFill>
+                        <a:srgbClr val="D5DCE3"/>
+                      </a:solidFill>
+                      <a:prstDash val="solid"/>
+                      <a:round/>
+                      <a:headEnd type="none" w="med" len="med"/>
+                      <a:tailEnd type="none" w="med" len="med"/>
+                    </a:lnB>
+                    <a:solidFill>
+                      <a:srgbClr val="FFFFFF"/>
+                    </a:solidFill>
+                  </a:tcPr>
+                </a:tc>
+              </a:tr>
+              <a:tr h="438912">
+                <a:tc>
+                  <a:txBody>
+                    <a:bodyPr/>
+                    <a:lstStyle/>
+                    <a:p>
+                      <a:pPr indent="0" marL="0">
+                        <a:buNone/>
+                      </a:pPr>
+                      <a:r>
+                        <a:rPr lang="en-US" sz="1300" dirty="0">
+                          <a:solidFill>
+                            <a:srgbClr val="1F2A36"/>
+                          </a:solidFill>
+                          <a:latin typeface="Calibri" pitchFamily="34" charset="0"/>
+                          <a:ea typeface="Calibri" pitchFamily="34" charset="-122"/>
+                          <a:cs typeface="Calibri" pitchFamily="34" charset="-120"/>
+                        </a:rPr>
+                        <a:t>Channel busy at RSUs</a:t>
+                      </a:r>
+                      <a:endParaRPr lang="en-US" sz="1300" dirty="0">
+                        <a:latin typeface="Calibri" charset="0"/>
+                        <a:ea typeface="Calibri" charset="0"/>
+                        <a:cs typeface="Calibri" charset="0"/>
+                      </a:endParaRPr>
+                    </a:p>
+                  </a:txBody>
+                  <a:tcPr marL="91440" marR="91440" marT="45720" marB="45720" anchor="ctr">
+                    <a:lnL w="9525" cap="flat" cmpd="sng" algn="ctr">
+                      <a:solidFill>
+                        <a:srgbClr val="D5DCE3"/>
+                      </a:solidFill>
+                      <a:prstDash val="solid"/>
+                      <a:round/>
+                      <a:headEnd type="none" w="med" len="med"/>
+                      <a:tailEnd type="none" w="med" len="med"/>
+                    </a:lnL>
+                    <a:lnR w="9525" cap="flat" cmpd="sng" algn="ctr">
+                      <a:solidFill>
+                        <a:srgbClr val="D5DCE3"/>
+                      </a:solidFill>
+                      <a:prstDash val="solid"/>
+                      <a:round/>
+                      <a:headEnd type="none" w="med" len="med"/>
+                      <a:tailEnd type="none" w="med" len="med"/>
+                    </a:lnR>
+                    <a:lnT w="9525" cap="flat" cmpd="sng" algn="ctr">
+                      <a:solidFill>
+                        <a:srgbClr val="D5DCE3"/>
+                      </a:solidFill>
+                      <a:prstDash val="solid"/>
+                      <a:round/>
+                      <a:headEnd type="none" w="med" len="med"/>
+                      <a:tailEnd type="none" w="med" len="med"/>
+                    </a:lnT>
+                    <a:lnB w="9525" cap="flat" cmpd="sng" algn="ctr">
+                      <a:solidFill>
+                        <a:srgbClr val="D5DCE3"/>
+                      </a:solidFill>
+                      <a:prstDash val="solid"/>
+                      <a:round/>
+                      <a:headEnd type="none" w="med" len="med"/>
+                      <a:tailEnd type="none" w="med" len="med"/>
+                    </a:lnB>
+                    <a:solidFill>
+                      <a:srgbClr val="FFFFFF"/>
+                    </a:solidFill>
+                  </a:tcPr>
+                </a:tc>
+                <a:tc>
+                  <a:txBody>
+                    <a:bodyPr/>
+                    <a:lstStyle/>
+                    <a:p>
+                      <a:pPr indent="0" marL="0">
+                        <a:buNone/>
+                      </a:pPr>
+                      <a:r>
+                        <a:rPr lang="en-US" sz="1300" dirty="0">
+                          <a:solidFill>
+                            <a:srgbClr val="1F2A36"/>
+                          </a:solidFill>
+                          <a:latin typeface="Calibri" pitchFamily="34" charset="0"/>
+                          <a:ea typeface="Calibri" pitchFamily="34" charset="-122"/>
+                          <a:cs typeface="Calibri" pitchFamily="34" charset="-120"/>
+                        </a:rPr>
+                        <a:t>4.1 %</a:t>
+                      </a:r>
+                      <a:endParaRPr lang="en-US" sz="1300" dirty="0">
+                        <a:latin typeface="Calibri" charset="0"/>
+                        <a:ea typeface="Calibri" charset="0"/>
+                        <a:cs typeface="Calibri" charset="0"/>
+                      </a:endParaRPr>
+                    </a:p>
+                  </a:txBody>
+                  <a:tcPr marL="91440" marR="91440" marT="45720" marB="45720" anchor="ctr">
+                    <a:lnL w="9525" cap="flat" cmpd="sng" algn="ctr">
+                      <a:solidFill>
+                        <a:srgbClr val="D5DCE3"/>
+                      </a:solidFill>
+                      <a:prstDash val="solid"/>
+                      <a:round/>
+                      <a:headEnd type="none" w="med" len="med"/>
+                      <a:tailEnd type="none" w="med" len="med"/>
+                    </a:lnL>
+                    <a:lnR w="9525" cap="flat" cmpd="sng" algn="ctr">
+                      <a:solidFill>
+                        <a:srgbClr val="D5DCE3"/>
+                      </a:solidFill>
+                      <a:prstDash val="solid"/>
+                      <a:round/>
+                      <a:headEnd type="none" w="med" len="med"/>
+                      <a:tailEnd type="none" w="med" len="med"/>
+                    </a:lnR>
+                    <a:lnT w="9525" cap="flat" cmpd="sng" algn="ctr">
+                      <a:solidFill>
+                        <a:srgbClr val="D5DCE3"/>
+                      </a:solidFill>
+                      <a:prstDash val="solid"/>
+                      <a:round/>
+                      <a:headEnd type="none" w="med" len="med"/>
+                      <a:tailEnd type="none" w="med" len="med"/>
+                    </a:lnT>
+                    <a:lnB w="9525" cap="flat" cmpd="sng" algn="ctr">
+                      <a:solidFill>
+                        <a:srgbClr val="D5DCE3"/>
+                      </a:solidFill>
+                      <a:prstDash val="solid"/>
+                      <a:round/>
+                      <a:headEnd type="none" w="med" len="med"/>
+                      <a:tailEnd type="none" w="med" len="med"/>
+                    </a:lnB>
+                    <a:solidFill>
+                      <a:srgbClr val="FFFFFF"/>
+                    </a:solidFill>
+                  </a:tcPr>
+                </a:tc>
+                <a:tc>
+                  <a:txBody>
+                    <a:bodyPr/>
+                    <a:lstStyle/>
+                    <a:p>
+                      <a:pPr indent="0" marL="0">
+                        <a:buNone/>
+                      </a:pPr>
+                      <a:r>
+                        <a:rPr lang="en-US" sz="1300" dirty="0">
+                          <a:solidFill>
+                            <a:srgbClr val="1F2A36"/>
+                          </a:solidFill>
+                          <a:latin typeface="Calibri" pitchFamily="34" charset="0"/>
+                          <a:ea typeface="Calibri" pitchFamily="34" charset="-122"/>
+                          <a:cs typeface="Calibri" pitchFamily="34" charset="-120"/>
+                        </a:rPr>
+                        <a:t>3.3 %</a:t>
+                      </a:r>
+                      <a:endParaRPr lang="en-US" sz="1300" dirty="0">
+                        <a:latin typeface="Calibri" charset="0"/>
+                        <a:ea typeface="Calibri" charset="0"/>
+                        <a:cs typeface="Calibri" charset="0"/>
+                      </a:endParaRPr>
+                    </a:p>
+                  </a:txBody>
+                  <a:tcPr marL="91440" marR="91440" marT="45720" marB="45720" anchor="ctr">
+                    <a:lnL w="9525" cap="flat" cmpd="sng" algn="ctr">
+                      <a:solidFill>
+                        <a:srgbClr val="D5DCE3"/>
+                      </a:solidFill>
+                      <a:prstDash val="solid"/>
+                      <a:round/>
+                      <a:headEnd type="none" w="med" len="med"/>
+                      <a:tailEnd type="none" w="med" len="med"/>
+                    </a:lnL>
+                    <a:lnR w="9525" cap="flat" cmpd="sng" algn="ctr">
+                      <a:solidFill>
+                        <a:srgbClr val="D5DCE3"/>
+                      </a:solidFill>
+                      <a:prstDash val="solid"/>
+                      <a:round/>
+                      <a:headEnd type="none" w="med" len="med"/>
+                      <a:tailEnd type="none" w="med" len="med"/>
+                    </a:lnR>
+                    <a:lnT w="9525" cap="flat" cmpd="sng" algn="ctr">
+                      <a:solidFill>
+                        <a:srgbClr val="D5DCE3"/>
+                      </a:solidFill>
+                      <a:prstDash val="solid"/>
+                      <a:round/>
+                      <a:headEnd type="none" w="med" len="med"/>
+                      <a:tailEnd type="none" w="med" len="med"/>
+                    </a:lnT>
+                    <a:lnB w="9525" cap="flat" cmpd="sng" algn="ctr">
+                      <a:solidFill>
+                        <a:srgbClr val="D5DCE3"/>
+                      </a:solidFill>
+                      <a:prstDash val="solid"/>
+                      <a:round/>
+                      <a:headEnd type="none" w="med" len="med"/>
+                      <a:tailEnd type="none" w="med" len="med"/>
+                    </a:lnB>
+                    <a:solidFill>
+                      <a:srgbClr val="FFFFFF"/>
+                    </a:solidFill>
+                  </a:tcPr>
+                </a:tc>
+                <a:tc>
+                  <a:txBody>
+                    <a:bodyPr/>
+                    <a:lstStyle/>
+                    <a:p>
+                      <a:pPr indent="0" marL="0">
+                        <a:buNone/>
+                      </a:pPr>
+                      <a:r>
+                        <a:rPr lang="en-US" sz="1300" dirty="0">
+                          <a:solidFill>
+                            <a:srgbClr val="1F2A36"/>
+                          </a:solidFill>
+                          <a:latin typeface="Calibri" pitchFamily="34" charset="0"/>
+                          <a:ea typeface="Calibri" pitchFamily="34" charset="-122"/>
+                          <a:cs typeface="Calibri" pitchFamily="34" charset="-120"/>
+                        </a:rPr>
+                        <a:t>3.3 %</a:t>
+                      </a:r>
+                      <a:endParaRPr lang="en-US" sz="1300" dirty="0">
+                        <a:latin typeface="Calibri" charset="0"/>
+                        <a:ea typeface="Calibri" charset="0"/>
+                        <a:cs typeface="Calibri" charset="0"/>
+                      </a:endParaRPr>
+                    </a:p>
+                  </a:txBody>
+                  <a:tcPr marL="91440" marR="91440" marT="45720" marB="45720" anchor="ctr">
+                    <a:lnL w="9525" cap="flat" cmpd="sng" algn="ctr">
+                      <a:solidFill>
+                        <a:srgbClr val="D5DCE3"/>
+                      </a:solidFill>
+                      <a:prstDash val="solid"/>
+                      <a:round/>
+                      <a:headEnd type="none" w="med" len="med"/>
+                      <a:tailEnd type="none" w="med" len="med"/>
+                    </a:lnL>
+                    <a:lnR w="9525" cap="flat" cmpd="sng" algn="ctr">
+                      <a:solidFill>
+                        <a:srgbClr val="D5DCE3"/>
+                      </a:solidFill>
+                      <a:prstDash val="solid"/>
+                      <a:round/>
+                      <a:headEnd type="none" w="med" len="med"/>
+                      <a:tailEnd type="none" w="med" len="med"/>
+                    </a:lnR>
+                    <a:lnT w="9525" cap="flat" cmpd="sng" algn="ctr">
+                      <a:solidFill>
+                        <a:srgbClr val="D5DCE3"/>
+                      </a:solidFill>
+                      <a:prstDash val="solid"/>
+                      <a:round/>
+                      <a:headEnd type="none" w="med" len="med"/>
+                      <a:tailEnd type="none" w="med" len="med"/>
+                    </a:lnT>
+                    <a:lnB w="9525" cap="flat" cmpd="sng" algn="ctr">
+                      <a:solidFill>
+                        <a:srgbClr val="D5DCE3"/>
+                      </a:solidFill>
+                      <a:prstDash val="solid"/>
+                      <a:round/>
+                      <a:headEnd type="none" w="med" len="med"/>
+                      <a:tailEnd type="none" w="med" len="med"/>
+                    </a:lnB>
+                    <a:solidFill>
+                      <a:srgbClr val="FFFFFF"/>
+                    </a:solidFill>
+                  </a:tcPr>
+                </a:tc>
+              </a:tr>
+              <a:tr h="438912">
+                <a:tc>
+                  <a:txBody>
+                    <a:bodyPr/>
+                    <a:lstStyle/>
+                    <a:p>
+                      <a:pPr indent="0" marL="0">
+                        <a:buNone/>
+                      </a:pPr>
+                      <a:r>
+                        <a:rPr lang="en-US" sz="1300" dirty="0">
+                          <a:solidFill>
+                            <a:srgbClr val="1F2A36"/>
+                          </a:solidFill>
+                          <a:latin typeface="Calibri" pitchFamily="34" charset="0"/>
+                          <a:ea typeface="Calibri" pitchFamily="34" charset="-122"/>
+                          <a:cs typeface="Calibri" pitchFamily="34" charset="-120"/>
+                        </a:rPr>
+                        <a:t>Issuer cannot link pseudonyms</a:t>
+                      </a:r>
+                      <a:endParaRPr lang="en-US" sz="1300" dirty="0">
+                        <a:latin typeface="Calibri" charset="0"/>
+                        <a:ea typeface="Calibri" charset="0"/>
+                        <a:cs typeface="Calibri" charset="0"/>
+                      </a:endParaRPr>
+                    </a:p>
+                  </a:txBody>
+                  <a:tcPr marL="91440" marR="91440" marT="45720" marB="45720" anchor="ctr">
+                    <a:lnL w="9525" cap="flat" cmpd="sng" algn="ctr">
+                      <a:solidFill>
+                        <a:srgbClr val="D5DCE3"/>
+                      </a:solidFill>
+                      <a:prstDash val="solid"/>
+                      <a:round/>
+                      <a:headEnd type="none" w="med" len="med"/>
+                      <a:tailEnd type="none" w="med" len="med"/>
+                    </a:lnL>
+                    <a:lnR w="9525" cap="flat" cmpd="sng" algn="ctr">
+                      <a:solidFill>
+                        <a:srgbClr val="D5DCE3"/>
+                      </a:solidFill>
+                      <a:prstDash val="solid"/>
+                      <a:round/>
+                      <a:headEnd type="none" w="med" len="med"/>
+                      <a:tailEnd type="none" w="med" len="med"/>
+                    </a:lnR>
+                    <a:lnT w="9525" cap="flat" cmpd="sng" algn="ctr">
+                      <a:solidFill>
+                        <a:srgbClr val="D5DCE3"/>
+                      </a:solidFill>
+                      <a:prstDash val="solid"/>
+                      <a:round/>
+                      <a:headEnd type="none" w="med" len="med"/>
+                      <a:tailEnd type="none" w="med" len="med"/>
+                    </a:lnT>
+                    <a:lnB w="9525" cap="flat" cmpd="sng" algn="ctr">
+                      <a:solidFill>
+                        <a:srgbClr val="D5DCE3"/>
+                      </a:solidFill>
+                      <a:prstDash val="solid"/>
+                      <a:round/>
+                      <a:headEnd type="none" w="med" len="med"/>
+                      <a:tailEnd type="none" w="med" len="med"/>
+                    </a:lnB>
+                    <a:solidFill>
+                      <a:srgbClr val="FFFFFF"/>
+                    </a:solidFill>
+                  </a:tcPr>
+                </a:tc>
+                <a:tc>
+                  <a:txBody>
+                    <a:bodyPr/>
+                    <a:lstStyle/>
+                    <a:p>
+                      <a:pPr indent="0" marL="0">
+                        <a:buNone/>
+                      </a:pPr>
+                      <a:r>
+                        <a:rPr lang="en-US" sz="1300" b="1" dirty="0">
+                          <a:solidFill>
+                            <a:srgbClr val="1F9E8F"/>
+                          </a:solidFill>
+                          <a:latin typeface="Calibri" pitchFamily="34" charset="0"/>
+                          <a:ea typeface="Calibri" pitchFamily="34" charset="-122"/>
+                          <a:cs typeface="Calibri" pitchFamily="34" charset="-120"/>
+                        </a:rPr>
+                        <a:t>yes</a:t>
+                      </a:r>
+                      <a:endParaRPr lang="en-US" sz="1300" dirty="0">
+                        <a:latin typeface="Calibri" charset="0"/>
+                        <a:ea typeface="Calibri" charset="0"/>
+                        <a:cs typeface="Calibri" charset="0"/>
+                      </a:endParaRPr>
+                    </a:p>
+                  </a:txBody>
+                  <a:tcPr marL="91440" marR="91440" marT="45720" marB="45720" anchor="ctr">
+                    <a:lnL w="9525" cap="flat" cmpd="sng" algn="ctr">
+                      <a:solidFill>
+                        <a:srgbClr val="D5DCE3"/>
+                      </a:solidFill>
+                      <a:prstDash val="solid"/>
+                      <a:round/>
+                      <a:headEnd type="none" w="med" len="med"/>
+                      <a:tailEnd type="none" w="med" len="med"/>
+                    </a:lnL>
+                    <a:lnR w="9525" cap="flat" cmpd="sng" algn="ctr">
+                      <a:solidFill>
+                        <a:srgbClr val="D5DCE3"/>
+                      </a:solidFill>
+                      <a:prstDash val="solid"/>
+                      <a:round/>
+                      <a:headEnd type="none" w="med" len="med"/>
+                      <a:tailEnd type="none" w="med" len="med"/>
+                    </a:lnR>
+                    <a:lnT w="9525" cap="flat" cmpd="sng" algn="ctr">
+                      <a:solidFill>
+                        <a:srgbClr val="D5DCE3"/>
+                      </a:solidFill>
+                      <a:prstDash val="solid"/>
+                      <a:round/>
+                      <a:headEnd type="none" w="med" len="med"/>
+                      <a:tailEnd type="none" w="med" len="med"/>
+                    </a:lnT>
+                    <a:lnB w="9525" cap="flat" cmpd="sng" algn="ctr">
+                      <a:solidFill>
+                        <a:srgbClr val="D5DCE3"/>
+                      </a:solidFill>
+                      <a:prstDash val="solid"/>
+                      <a:round/>
+                      <a:headEnd type="none" w="med" len="med"/>
+                      <a:tailEnd type="none" w="med" len="med"/>
+                    </a:lnB>
+                    <a:solidFill>
+                      <a:srgbClr val="FFFFFF"/>
+                    </a:solidFill>
+                  </a:tcPr>
+                </a:tc>
+                <a:tc>
+                  <a:txBody>
+                    <a:bodyPr/>
+                    <a:lstStyle/>
+                    <a:p>
+                      <a:pPr indent="0" marL="0">
+                        <a:buNone/>
+                      </a:pPr>
+                      <a:r>
+                        <a:rPr lang="en-US" sz="1300" b="1" dirty="0">
+                          <a:solidFill>
+                            <a:srgbClr val="C8463D"/>
+                          </a:solidFill>
+                          <a:latin typeface="Calibri" pitchFamily="34" charset="0"/>
+                          <a:ea typeface="Calibri" pitchFamily="34" charset="-122"/>
+                          <a:cs typeface="Calibri" pitchFamily="34" charset="-120"/>
+                        </a:rPr>
+                        <a:t>no</a:t>
+                      </a:r>
+                      <a:endParaRPr lang="en-US" sz="1300" dirty="0">
+                        <a:latin typeface="Calibri" charset="0"/>
+                        <a:ea typeface="Calibri" charset="0"/>
+                        <a:cs typeface="Calibri" charset="0"/>
+                      </a:endParaRPr>
+                    </a:p>
+                  </a:txBody>
+                  <a:tcPr marL="91440" marR="91440" marT="45720" marB="45720" anchor="ctr">
+                    <a:lnL w="9525" cap="flat" cmpd="sng" algn="ctr">
+                      <a:solidFill>
+                        <a:srgbClr val="D5DCE3"/>
+                      </a:solidFill>
+                      <a:prstDash val="solid"/>
+                      <a:round/>
+                      <a:headEnd type="none" w="med" len="med"/>
+                      <a:tailEnd type="none" w="med" len="med"/>
+                    </a:lnL>
+                    <a:lnR w="9525" cap="flat" cmpd="sng" algn="ctr">
+                      <a:solidFill>
+                        <a:srgbClr val="D5DCE3"/>
+                      </a:solidFill>
+                      <a:prstDash val="solid"/>
+                      <a:round/>
+                      <a:headEnd type="none" w="med" len="med"/>
+                      <a:tailEnd type="none" w="med" len="med"/>
+                    </a:lnR>
+                    <a:lnT w="9525" cap="flat" cmpd="sng" algn="ctr">
+                      <a:solidFill>
+                        <a:srgbClr val="D5DCE3"/>
+                      </a:solidFill>
+                      <a:prstDash val="solid"/>
+                      <a:round/>
+                      <a:headEnd type="none" w="med" len="med"/>
+                      <a:tailEnd type="none" w="med" len="med"/>
+                    </a:lnT>
+                    <a:lnB w="9525" cap="flat" cmpd="sng" algn="ctr">
+                      <a:solidFill>
+                        <a:srgbClr val="D5DCE3"/>
+                      </a:solidFill>
+                      <a:prstDash val="solid"/>
+                      <a:round/>
+                      <a:headEnd type="none" w="med" len="med"/>
+                      <a:tailEnd type="none" w="med" len="med"/>
+                    </a:lnB>
+                    <a:solidFill>
+                      <a:srgbClr val="FFFFFF"/>
+                    </a:solidFill>
+                  </a:tcPr>
+                </a:tc>
+                <a:tc>
+                  <a:txBody>
+                    <a:bodyPr/>
+                    <a:lstStyle/>
+                    <a:p>
+                      <a:pPr indent="0" marL="0">
+                        <a:buNone/>
+                      </a:pPr>
+                      <a:r>
+                        <a:rPr lang="en-US" sz="1300" b="1" dirty="0">
+                          <a:solidFill>
+                            <a:srgbClr val="C8463D"/>
+                          </a:solidFill>
+                          <a:latin typeface="Calibri" pitchFamily="34" charset="0"/>
+                          <a:ea typeface="Calibri" pitchFamily="34" charset="-122"/>
+                          <a:cs typeface="Calibri" pitchFamily="34" charset="-120"/>
+                        </a:rPr>
+                        <a:t>no</a:t>
+                      </a:r>
+                      <a:endParaRPr lang="en-US" sz="1300" dirty="0">
+                        <a:latin typeface="Calibri" charset="0"/>
+                        <a:ea typeface="Calibri" charset="0"/>
+                        <a:cs typeface="Calibri" charset="0"/>
+                      </a:endParaRPr>
+                    </a:p>
+                  </a:txBody>
+                  <a:tcPr marL="91440" marR="91440" marT="45720" marB="45720" anchor="ctr">
+                    <a:lnL w="9525" cap="flat" cmpd="sng" algn="ctr">
+                      <a:solidFill>
+                        <a:srgbClr val="D5DCE3"/>
+                      </a:solidFill>
+                      <a:prstDash val="solid"/>
+                      <a:round/>
+                      <a:headEnd type="none" w="med" len="med"/>
+                      <a:tailEnd type="none" w="med" len="med"/>
+                    </a:lnL>
+                    <a:lnR w="9525" cap="flat" cmpd="sng" algn="ctr">
+                      <a:solidFill>
+                        <a:srgbClr val="D5DCE3"/>
+                      </a:solidFill>
+                      <a:prstDash val="solid"/>
+                      <a:round/>
+                      <a:headEnd type="none" w="med" len="med"/>
+                      <a:tailEnd type="none" w="med" len="med"/>
+                    </a:lnR>
+                    <a:lnT w="9525" cap="flat" cmpd="sng" algn="ctr">
+                      <a:solidFill>
+                        <a:srgbClr val="D5DCE3"/>
+                      </a:solidFill>
+                      <a:prstDash val="solid"/>
+                      <a:round/>
+                      <a:headEnd type="none" w="med" len="med"/>
+                      <a:tailEnd type="none" w="med" len="med"/>
+                    </a:lnT>
+                    <a:lnB w="9525" cap="flat" cmpd="sng" algn="ctr">
+                      <a:solidFill>
+                        <a:srgbClr val="D5DCE3"/>
+                      </a:solidFill>
+                      <a:prstDash val="solid"/>
+                      <a:round/>
+                      <a:headEnd type="none" w="med" len="med"/>
+                      <a:tailEnd type="none" w="med" len="med"/>
+                    </a:lnB>
+                    <a:solidFill>
+                      <a:srgbClr val="FFFFFF"/>
+                    </a:solidFill>
+                  </a:tcPr>
+                </a:tc>
+              </a:tr>
+              <a:tr h="438912">
+                <a:tc>
+                  <a:txBody>
+                    <a:bodyPr/>
+                    <a:lstStyle/>
+                    <a:p>
+                      <a:pPr indent="0" marL="0">
+                        <a:buNone/>
+                      </a:pPr>
+                      <a:r>
+                        <a:rPr lang="en-US" sz="1300" dirty="0">
+                          <a:solidFill>
+                            <a:srgbClr val="1F2A36"/>
+                          </a:solidFill>
+                          <a:latin typeface="Calibri" pitchFamily="34" charset="0"/>
+                          <a:ea typeface="Calibri" pitchFamily="34" charset="-122"/>
+                          <a:cs typeface="Calibri" pitchFamily="34" charset="-120"/>
+                        </a:rPr>
+                        <a:t>No single party can unmask</a:t>
+                      </a:r>
+                      <a:endParaRPr lang="en-US" sz="1300" dirty="0">
+                        <a:latin typeface="Calibri" charset="0"/>
+                        <a:ea typeface="Calibri" charset="0"/>
+                        <a:cs typeface="Calibri" charset="0"/>
+                      </a:endParaRPr>
+                    </a:p>
+                  </a:txBody>
+                  <a:tcPr marL="91440" marR="91440" marT="45720" marB="45720" anchor="ctr">
+                    <a:lnL w="9525" cap="flat" cmpd="sng" algn="ctr">
+                      <a:solidFill>
+                        <a:srgbClr val="D5DCE3"/>
+                      </a:solidFill>
+                      <a:prstDash val="solid"/>
+                      <a:round/>
+                      <a:headEnd type="none" w="med" len="med"/>
+                      <a:tailEnd type="none" w="med" len="med"/>
+                    </a:lnL>
+                    <a:lnR w="9525" cap="flat" cmpd="sng" algn="ctr">
+                      <a:solidFill>
+                        <a:srgbClr val="D5DCE3"/>
+                      </a:solidFill>
+                      <a:prstDash val="solid"/>
+                      <a:round/>
+                      <a:headEnd type="none" w="med" len="med"/>
+                      <a:tailEnd type="none" w="med" len="med"/>
+                    </a:lnR>
+                    <a:lnT w="9525" cap="flat" cmpd="sng" algn="ctr">
+                      <a:solidFill>
+                        <a:srgbClr val="D5DCE3"/>
+                      </a:solidFill>
+                      <a:prstDash val="solid"/>
+                      <a:round/>
+                      <a:headEnd type="none" w="med" len="med"/>
+                      <a:tailEnd type="none" w="med" len="med"/>
+                    </a:lnT>
+                    <a:lnB w="9525" cap="flat" cmpd="sng" algn="ctr">
+                      <a:solidFill>
+                        <a:srgbClr val="D5DCE3"/>
+                      </a:solidFill>
+                      <a:prstDash val="solid"/>
+                      <a:round/>
+                      <a:headEnd type="none" w="med" len="med"/>
+                      <a:tailEnd type="none" w="med" len="med"/>
+                    </a:lnB>
+                    <a:solidFill>
+                      <a:srgbClr val="FFFFFF"/>
+                    </a:solidFill>
+                  </a:tcPr>
+                </a:tc>
+                <a:tc>
+                  <a:txBody>
+                    <a:bodyPr/>
+                    <a:lstStyle/>
+                    <a:p>
+                      <a:pPr indent="0" marL="0">
+                        <a:buNone/>
+                      </a:pPr>
+                      <a:r>
+                        <a:rPr lang="en-US" sz="1300" b="1" dirty="0">
+                          <a:solidFill>
+                            <a:srgbClr val="1F9E8F"/>
+                          </a:solidFill>
+                          <a:latin typeface="Calibri" pitchFamily="34" charset="0"/>
+                          <a:ea typeface="Calibri" pitchFamily="34" charset="-122"/>
+                          <a:cs typeface="Calibri" pitchFamily="34" charset="-120"/>
+                        </a:rPr>
+                        <a:t>yes</a:t>
+                      </a:r>
+                      <a:endParaRPr lang="en-US" sz="1300" dirty="0">
+                        <a:latin typeface="Calibri" charset="0"/>
+                        <a:ea typeface="Calibri" charset="0"/>
+                        <a:cs typeface="Calibri" charset="0"/>
+                      </a:endParaRPr>
+                    </a:p>
+                  </a:txBody>
+                  <a:tcPr marL="91440" marR="91440" marT="45720" marB="45720" anchor="ctr">
+                    <a:lnL w="9525" cap="flat" cmpd="sng" algn="ctr">
+                      <a:solidFill>
+                        <a:srgbClr val="D5DCE3"/>
+                      </a:solidFill>
+                      <a:prstDash val="solid"/>
+                      <a:round/>
+                      <a:headEnd type="none" w="med" len="med"/>
+                      <a:tailEnd type="none" w="med" len="med"/>
+                    </a:lnL>
+                    <a:lnR w="9525" cap="flat" cmpd="sng" algn="ctr">
+                      <a:solidFill>
+                        <a:srgbClr val="D5DCE3"/>
+                      </a:solidFill>
+                      <a:prstDash val="solid"/>
+                      <a:round/>
+                      <a:headEnd type="none" w="med" len="med"/>
+                      <a:tailEnd type="none" w="med" len="med"/>
+                    </a:lnR>
+                    <a:lnT w="9525" cap="flat" cmpd="sng" algn="ctr">
+                      <a:solidFill>
+                        <a:srgbClr val="D5DCE3"/>
+                      </a:solidFill>
+                      <a:prstDash val="solid"/>
+                      <a:round/>
+                      <a:headEnd type="none" w="med" len="med"/>
+                      <a:tailEnd type="none" w="med" len="med"/>
+                    </a:lnT>
+                    <a:lnB w="9525" cap="flat" cmpd="sng" algn="ctr">
+                      <a:solidFill>
+                        <a:srgbClr val="D5DCE3"/>
+                      </a:solidFill>
+                      <a:prstDash val="solid"/>
+                      <a:round/>
+                      <a:headEnd type="none" w="med" len="med"/>
+                      <a:tailEnd type="none" w="med" len="med"/>
+                    </a:lnB>
+                    <a:solidFill>
+                      <a:srgbClr val="FFFFFF"/>
+                    </a:solidFill>
+                  </a:tcPr>
+                </a:tc>
+                <a:tc>
+                  <a:txBody>
+                    <a:bodyPr/>
+                    <a:lstStyle/>
+                    <a:p>
+                      <a:pPr indent="0" marL="0">
+                        <a:buNone/>
+                      </a:pPr>
+                      <a:r>
+                        <a:rPr lang="en-US" sz="1300" b="1" dirty="0">
+                          <a:solidFill>
+                            <a:srgbClr val="C8463D"/>
+                          </a:solidFill>
+                          <a:latin typeface="Calibri" pitchFamily="34" charset="0"/>
+                          <a:ea typeface="Calibri" pitchFamily="34" charset="-122"/>
+                          <a:cs typeface="Calibri" pitchFamily="34" charset="-120"/>
+                        </a:rPr>
+                        <a:t>no</a:t>
+                      </a:r>
+                      <a:endParaRPr lang="en-US" sz="1300" dirty="0">
+                        <a:latin typeface="Calibri" charset="0"/>
+                        <a:ea typeface="Calibri" charset="0"/>
+                        <a:cs typeface="Calibri" charset="0"/>
+                      </a:endParaRPr>
+                    </a:p>
+                  </a:txBody>
+                  <a:tcPr marL="91440" marR="91440" marT="45720" marB="45720" anchor="ctr">
+                    <a:lnL w="9525" cap="flat" cmpd="sng" algn="ctr">
+                      <a:solidFill>
+                        <a:srgbClr val="D5DCE3"/>
+                      </a:solidFill>
+                      <a:prstDash val="solid"/>
+                      <a:round/>
+                      <a:headEnd type="none" w="med" len="med"/>
+                      <a:tailEnd type="none" w="med" len="med"/>
+                    </a:lnL>
+                    <a:lnR w="9525" cap="flat" cmpd="sng" algn="ctr">
+                      <a:solidFill>
+                        <a:srgbClr val="D5DCE3"/>
+                      </a:solidFill>
+                      <a:prstDash val="solid"/>
+                      <a:round/>
+                      <a:headEnd type="none" w="med" len="med"/>
+                      <a:tailEnd type="none" w="med" len="med"/>
+                    </a:lnR>
+                    <a:lnT w="9525" cap="flat" cmpd="sng" algn="ctr">
+                      <a:solidFill>
+                        <a:srgbClr val="D5DCE3"/>
+                      </a:solidFill>
+                      <a:prstDash val="solid"/>
+                      <a:round/>
+                      <a:headEnd type="none" w="med" len="med"/>
+                      <a:tailEnd type="none" w="med" len="med"/>
+                    </a:lnT>
+                    <a:lnB w="9525" cap="flat" cmpd="sng" algn="ctr">
+                      <a:solidFill>
+                        <a:srgbClr val="D5DCE3"/>
+                      </a:solidFill>
+                      <a:prstDash val="solid"/>
+                      <a:round/>
+                      <a:headEnd type="none" w="med" len="med"/>
+                      <a:tailEnd type="none" w="med" len="med"/>
+                    </a:lnB>
+                    <a:solidFill>
+                      <a:srgbClr val="FFFFFF"/>
+                    </a:solidFill>
+                  </a:tcPr>
+                </a:tc>
+                <a:tc>
+                  <a:txBody>
+                    <a:bodyPr/>
+                    <a:lstStyle/>
+                    <a:p>
+                      <a:pPr indent="0" marL="0">
+                        <a:buNone/>
+                      </a:pPr>
+                      <a:r>
+                        <a:rPr lang="en-US" sz="1300" b="1" dirty="0">
+                          <a:solidFill>
+                            <a:srgbClr val="C8463D"/>
+                          </a:solidFill>
+                          <a:latin typeface="Calibri" pitchFamily="34" charset="0"/>
+                          <a:ea typeface="Calibri" pitchFamily="34" charset="-122"/>
+                          <a:cs typeface="Calibri" pitchFamily="34" charset="-120"/>
+                        </a:rPr>
+                        <a:t>no</a:t>
+                      </a:r>
+                      <a:endParaRPr lang="en-US" sz="1300" dirty="0">
+                        <a:latin typeface="Calibri" charset="0"/>
+                        <a:ea typeface="Calibri" charset="0"/>
+                        <a:cs typeface="Calibri" charset="0"/>
+                      </a:endParaRPr>
+                    </a:p>
+                  </a:txBody>
+                  <a:tcPr marL="91440" marR="91440" marT="45720" marB="45720" anchor="ctr">
+                    <a:lnL w="9525" cap="flat" cmpd="sng" algn="ctr">
+                      <a:solidFill>
+                        <a:srgbClr val="D5DCE3"/>
+                      </a:solidFill>
+                      <a:prstDash val="solid"/>
+                      <a:round/>
+                      <a:headEnd type="none" w="med" len="med"/>
+                      <a:tailEnd type="none" w="med" len="med"/>
+                    </a:lnL>
+                    <a:lnR w="9525" cap="flat" cmpd="sng" algn="ctr">
+                      <a:solidFill>
+                        <a:srgbClr val="D5DCE3"/>
+                      </a:solidFill>
+                      <a:prstDash val="solid"/>
+                      <a:round/>
+                      <a:headEnd type="none" w="med" len="med"/>
+                      <a:tailEnd type="none" w="med" len="med"/>
+                    </a:lnR>
+                    <a:lnT w="9525" cap="flat" cmpd="sng" algn="ctr">
+                      <a:solidFill>
+                        <a:srgbClr val="D5DCE3"/>
+                      </a:solidFill>
+                      <a:prstDash val="solid"/>
+                      <a:round/>
+                      <a:headEnd type="none" w="med" len="med"/>
+                      <a:tailEnd type="none" w="med" len="med"/>
+                    </a:lnT>
+                    <a:lnB w="9525" cap="flat" cmpd="sng" algn="ctr">
+                      <a:solidFill>
+                        <a:srgbClr val="D5DCE3"/>
+                      </a:solidFill>
+                      <a:prstDash val="solid"/>
+                      <a:round/>
+                      <a:headEnd type="none" w="med" len="med"/>
+                      <a:tailEnd type="none" w="med" len="med"/>
+                    </a:lnB>
+                    <a:solidFill>
+                      <a:srgbClr val="FFFFFF"/>
+                    </a:solidFill>
+                  </a:tcPr>
+                </a:tc>
+              </a:tr>
+              <a:tr h="438912">
+                <a:tc>
+                  <a:txBody>
+                    <a:bodyPr/>
+                    <a:lstStyle/>
+                    <a:p>
+                      <a:pPr indent="0" marL="0">
+                        <a:buNone/>
+                      </a:pPr>
+                      <a:r>
+                        <a:rPr lang="en-US" sz="1300" dirty="0">
+                          <a:solidFill>
+                            <a:srgbClr val="1F2A36"/>
+                          </a:solidFill>
+                          <a:latin typeface="Calibri" pitchFamily="34" charset="0"/>
+                          <a:ea typeface="Calibri" pitchFamily="34" charset="-122"/>
+                          <a:cs typeface="Calibri" pitchFamily="34" charset="-120"/>
+                        </a:rPr>
+                        <a:t>No online authority per request</a:t>
+                      </a:r>
+                      <a:endParaRPr lang="en-US" sz="1300" dirty="0">
+                        <a:latin typeface="Calibri" charset="0"/>
+                        <a:ea typeface="Calibri" charset="0"/>
+                        <a:cs typeface="Calibri" charset="0"/>
+                      </a:endParaRPr>
+                    </a:p>
+                  </a:txBody>
+                  <a:tcPr marL="91440" marR="91440" marT="45720" marB="45720" anchor="ctr">
+                    <a:lnL w="9525" cap="flat" cmpd="sng" algn="ctr">
+                      <a:solidFill>
+                        <a:srgbClr val="D5DCE3"/>
+                      </a:solidFill>
+                      <a:prstDash val="solid"/>
+                      <a:round/>
+                      <a:headEnd type="none" w="med" len="med"/>
+                      <a:tailEnd type="none" w="med" len="med"/>
+                    </a:lnL>
+                    <a:lnR w="9525" cap="flat" cmpd="sng" algn="ctr">
+                      <a:solidFill>
+                        <a:srgbClr val="D5DCE3"/>
+                      </a:solidFill>
+                      <a:prstDash val="solid"/>
+                      <a:round/>
+                      <a:headEnd type="none" w="med" len="med"/>
+                      <a:tailEnd type="none" w="med" len="med"/>
+                    </a:lnR>
+                    <a:lnT w="9525" cap="flat" cmpd="sng" algn="ctr">
+                      <a:solidFill>
+                        <a:srgbClr val="D5DCE3"/>
+                      </a:solidFill>
+                      <a:prstDash val="solid"/>
+                      <a:round/>
+                      <a:headEnd type="none" w="med" len="med"/>
+                      <a:tailEnd type="none" w="med" len="med"/>
+                    </a:lnT>
+                    <a:lnB w="9525" cap="flat" cmpd="sng" algn="ctr">
+                      <a:solidFill>
+                        <a:srgbClr val="D5DCE3"/>
+                      </a:solidFill>
+                      <a:prstDash val="solid"/>
+                      <a:round/>
+                      <a:headEnd type="none" w="med" len="med"/>
+                      <a:tailEnd type="none" w="med" len="med"/>
+                    </a:lnB>
+                    <a:solidFill>
+                      <a:srgbClr val="FFFFFF"/>
+                    </a:solidFill>
+                  </a:tcPr>
+                </a:tc>
+                <a:tc>
+                  <a:txBody>
+                    <a:bodyPr/>
+                    <a:lstStyle/>
+                    <a:p>
+                      <a:pPr indent="0" marL="0">
+                        <a:buNone/>
+                      </a:pPr>
+                      <a:r>
+                        <a:rPr lang="en-US" sz="1300" b="1" dirty="0">
+                          <a:solidFill>
+                            <a:srgbClr val="1F9E8F"/>
+                          </a:solidFill>
+                          <a:latin typeface="Calibri" pitchFamily="34" charset="0"/>
+                          <a:ea typeface="Calibri" pitchFamily="34" charset="-122"/>
+                          <a:cs typeface="Calibri" pitchFamily="34" charset="-120"/>
+                        </a:rPr>
+                        <a:t>yes</a:t>
+                      </a:r>
+                      <a:endParaRPr lang="en-US" sz="1300" dirty="0">
+                        <a:latin typeface="Calibri" charset="0"/>
+                        <a:ea typeface="Calibri" charset="0"/>
+                        <a:cs typeface="Calibri" charset="0"/>
+                      </a:endParaRPr>
+                    </a:p>
+                  </a:txBody>
+                  <a:tcPr marL="91440" marR="91440" marT="45720" marB="45720" anchor="ctr">
+                    <a:lnL w="9525" cap="flat" cmpd="sng" algn="ctr">
+                      <a:solidFill>
+                        <a:srgbClr val="D5DCE3"/>
+                      </a:solidFill>
+                      <a:prstDash val="solid"/>
+                      <a:round/>
+                      <a:headEnd type="none" w="med" len="med"/>
+                      <a:tailEnd type="none" w="med" len="med"/>
+                    </a:lnL>
+                    <a:lnR w="9525" cap="flat" cmpd="sng" algn="ctr">
+                      <a:solidFill>
+                        <a:srgbClr val="D5DCE3"/>
+                      </a:solidFill>
+                      <a:prstDash val="solid"/>
+                      <a:round/>
+                      <a:headEnd type="none" w="med" len="med"/>
+                      <a:tailEnd type="none" w="med" len="med"/>
+                    </a:lnR>
+                    <a:lnT w="9525" cap="flat" cmpd="sng" algn="ctr">
+                      <a:solidFill>
+                        <a:srgbClr val="D5DCE3"/>
+                      </a:solidFill>
+                      <a:prstDash val="solid"/>
+                      <a:round/>
+                      <a:headEnd type="none" w="med" len="med"/>
+                      <a:tailEnd type="none" w="med" len="med"/>
+                    </a:lnT>
+                    <a:lnB w="9525" cap="flat" cmpd="sng" algn="ctr">
+                      <a:solidFill>
+                        <a:srgbClr val="D5DCE3"/>
+                      </a:solidFill>
+                      <a:prstDash val="solid"/>
+                      <a:round/>
+                      <a:headEnd type="none" w="med" len="med"/>
+                      <a:tailEnd type="none" w="med" len="med"/>
+                    </a:lnB>
+                    <a:solidFill>
+                      <a:srgbClr val="FFFFFF"/>
+                    </a:solidFill>
+                  </a:tcPr>
+                </a:tc>
+                <a:tc>
+                  <a:txBody>
+                    <a:bodyPr/>
+                    <a:lstStyle/>
+                    <a:p>
+                      <a:pPr indent="0" marL="0">
+                        <a:buNone/>
+                      </a:pPr>
+                      <a:r>
+                        <a:rPr lang="en-US" sz="1300" b="1" dirty="0">
+                          <a:solidFill>
+                            <a:srgbClr val="1F9E8F"/>
+                          </a:solidFill>
+                          <a:latin typeface="Calibri" pitchFamily="34" charset="0"/>
+                          <a:ea typeface="Calibri" pitchFamily="34" charset="-122"/>
+                          <a:cs typeface="Calibri" pitchFamily="34" charset="-120"/>
+                        </a:rPr>
+                        <a:t>yes</a:t>
+                      </a:r>
+                      <a:endParaRPr lang="en-US" sz="1300" dirty="0">
+                        <a:latin typeface="Calibri" charset="0"/>
+                        <a:ea typeface="Calibri" charset="0"/>
+                        <a:cs typeface="Calibri" charset="0"/>
+                      </a:endParaRPr>
+                    </a:p>
+                  </a:txBody>
+                  <a:tcPr marL="91440" marR="91440" marT="45720" marB="45720" anchor="ctr">
+                    <a:lnL w="9525" cap="flat" cmpd="sng" algn="ctr">
+                      <a:solidFill>
+                        <a:srgbClr val="D5DCE3"/>
+                      </a:solidFill>
+                      <a:prstDash val="solid"/>
+                      <a:round/>
+                      <a:headEnd type="none" w="med" len="med"/>
+                      <a:tailEnd type="none" w="med" len="med"/>
+                    </a:lnL>
+                    <a:lnR w="9525" cap="flat" cmpd="sng" algn="ctr">
+                      <a:solidFill>
+                        <a:srgbClr val="D5DCE3"/>
+                      </a:solidFill>
+                      <a:prstDash val="solid"/>
+                      <a:round/>
+                      <a:headEnd type="none" w="med" len="med"/>
+                      <a:tailEnd type="none" w="med" len="med"/>
+                    </a:lnR>
+                    <a:lnT w="9525" cap="flat" cmpd="sng" algn="ctr">
+                      <a:solidFill>
+                        <a:srgbClr val="D5DCE3"/>
+                      </a:solidFill>
+                      <a:prstDash val="solid"/>
+                      <a:round/>
+                      <a:headEnd type="none" w="med" len="med"/>
+                      <a:tailEnd type="none" w="med" len="med"/>
+                    </a:lnT>
+                    <a:lnB w="9525" cap="flat" cmpd="sng" algn="ctr">
+                      <a:solidFill>
+                        <a:srgbClr val="D5DCE3"/>
+                      </a:solidFill>
+                      <a:prstDash val="solid"/>
+                      <a:round/>
+                      <a:headEnd type="none" w="med" len="med"/>
+                      <a:tailEnd type="none" w="med" len="med"/>
+                    </a:lnB>
+                    <a:solidFill>
+                      <a:srgbClr val="FFFFFF"/>
+                    </a:solidFill>
+                  </a:tcPr>
+                </a:tc>
+                <a:tc>
+                  <a:txBody>
+                    <a:bodyPr/>
+                    <a:lstStyle/>
+                    <a:p>
+                      <a:pPr indent="0" marL="0">
+                        <a:buNone/>
+                      </a:pPr>
+                      <a:r>
+                        <a:rPr lang="en-US" sz="1300" b="1" dirty="0">
+                          <a:solidFill>
+                            <a:srgbClr val="C8463D"/>
+                          </a:solidFill>
+                          <a:latin typeface="Calibri" pitchFamily="34" charset="0"/>
+                          <a:ea typeface="Calibri" pitchFamily="34" charset="-122"/>
+                          <a:cs typeface="Calibri" pitchFamily="34" charset="-120"/>
+                        </a:rPr>
+                        <a:t>no</a:t>
+                      </a:r>
+                      <a:endParaRPr lang="en-US" sz="1300" dirty="0">
+                        <a:latin typeface="Calibri" charset="0"/>
+                        <a:ea typeface="Calibri" charset="0"/>
+                        <a:cs typeface="Calibri" charset="0"/>
+                      </a:endParaRPr>
+                    </a:p>
+                  </a:txBody>
+                  <a:tcPr marL="91440" marR="91440" marT="45720" marB="45720" anchor="ctr">
+                    <a:lnL w="9525" cap="flat" cmpd="sng" algn="ctr">
+                      <a:solidFill>
+                        <a:srgbClr val="D5DCE3"/>
+                      </a:solidFill>
+                      <a:prstDash val="solid"/>
+                      <a:round/>
+                      <a:headEnd type="none" w="med" len="med"/>
+                      <a:tailEnd type="none" w="med" len="med"/>
+                    </a:lnL>
+                    <a:lnR w="9525" cap="flat" cmpd="sng" algn="ctr">
+                      <a:solidFill>
+                        <a:srgbClr val="D5DCE3"/>
+                      </a:solidFill>
+                      <a:prstDash val="solid"/>
+                      <a:round/>
+                      <a:headEnd type="none" w="med" len="med"/>
+                      <a:tailEnd type="none" w="med" len="med"/>
+                    </a:lnR>
+                    <a:lnT w="9525" cap="flat" cmpd="sng" algn="ctr">
+                      <a:solidFill>
+                        <a:srgbClr val="D5DCE3"/>
+                      </a:solidFill>
+                      <a:prstDash val="solid"/>
+                      <a:round/>
+                      <a:headEnd type="none" w="med" len="med"/>
+                      <a:tailEnd type="none" w="med" len="med"/>
+                    </a:lnT>
+                    <a:lnB w="9525" cap="flat" cmpd="sng" algn="ctr">
+                      <a:solidFill>
+                        <a:srgbClr val="D5DCE3"/>
+                      </a:solidFill>
+                      <a:prstDash val="solid"/>
+                      <a:round/>
+                      <a:headEnd type="none" w="med" len="med"/>
+                      <a:tailEnd type="none" w="med" len="med"/>
+                    </a:lnB>
+                    <a:solidFill>
+                      <a:srgbClr val="FFFFFF"/>
+                    </a:solidFill>
+                  </a:tcPr>
+                </a:tc>
+              </a:tr>
+            </a:tbl>
+          </a:graphicData>
+        </a:graphic>
+      </p:graphicFrame>
+      <p:sp>
+        <p:nvSpPr>
+          <p:cNvPr id="5" name="Text 1"/>
+          <p:cNvSpPr txBox="1"/>
+          <p:nvPr/>
+        </p:nvSpPr>
+        <p:spPr>
+          <a:xfrm>
+            <a:off x="548640" y="4800600"/>
+            <a:ext cx="11064240" cy="1097280"/>
+          </a:xfrm>
+          <a:prstGeom prst="rect">
+            <a:avLst/>
+          </a:prstGeom>
+          <a:noFill/>
+          <a:ln/>
+        </p:spPr>
+        <p:txBody>
+          <a:bodyPr wrap="square" lIns="0" tIns="0" rIns="0" bIns="0" rtlCol="0" anchor="t"/>
+          <a:lstStyle/>
+          <a:p>
+            <a:pPr indent="0" marL="0">
+              <a:buNone/>
+            </a:pPr>
+            <a:r>
+              <a:rPr lang="en-US" sz="1400" dirty="0">
+                <a:solidFill>
+                  <a:srgbClr val="1F2A36"/>
+                </a:solidFill>
+              </a:rPr>
+              <a:t>Same roads, radio, attackers and detector for all three. ECDSA is ~0.7 ms faster and its BSMs are smaller; the central authority pays a 20 ms backbone round trip on every request. Detection and revocation numbers are equal by construction (same detector and ledger), so they are not a comparison point.</a:t>
+            </a:r>
+            <a:endParaRPr lang="en-US" sz="1400" dirty="0"/>
+          </a:p>
+        </p:txBody>
+      </p:sp>
+      <p:sp>
+        <p:nvSpPr>
+          <p:cNvPr id="6" name="Text 2"/>
+          <p:cNvSpPr txBox="1"/>
+          <p:nvPr/>
+        </p:nvSpPr>
+        <p:spPr>
+          <a:xfrm>
+            <a:off x="548640" y="6263640"/>
+            <a:ext cx="10515600" cy="320040"/>
+          </a:xfrm>
+          <a:prstGeom prst="rect">
+            <a:avLst/>
+          </a:prstGeom>
+          <a:noFill/>
+          <a:ln/>
+        </p:spPr>
+        <p:txBody>
+          <a:bodyPr wrap="square" lIns="0" tIns="0" rIns="0" bIns="0" rtlCol="0" anchor="ctr"/>
+          <a:lstStyle/>
+          <a:p>
+            <a:pPr indent="0" marL="0">
+              <a:buNone/>
+            </a:pPr>
+            <a:r>
+              <a:rPr lang="en-US" sz="1100" i="1" dirty="0">
+                <a:solidFill>
+                  <a:srgbClr val="5B6B7A"/>
+                </a:solidFill>
+              </a:rPr>
+              <a:t>Property rows are design properties, not measurements. Full IEEE 1609.2 SCMS also splits linkage across authorities, at the cost of more online infrastructure.</a:t>
+            </a:r>
+            <a:endParaRPr lang="en-US" sz="1100" dirty="0"/>
+          </a:p>
+        </p:txBody>
+      </p:sp>
+      <p:sp>
+        <p:nvSpPr>
+          <p:cNvPr id="25" name="Slide Number Placeholder 0"/>
+          <p:cNvSpPr>
+            <a:spLocks noGrp="1"/>
+          </p:cNvSpPr>
+          <p:nvPr>
+            <p:ph type="sldNum" sz="quarter" idx="4294967295"/>
+          </p:nvPr>
+        </p:nvSpPr>
+        <p:spPr>
+          <a:xfrm>
+            <a:off x="11247120" y="6400800"/>
+            <a:ext cx="548640" cy="274320"/>
+          </a:xfrm>
+          <a:prstGeom prst="rect">
+            <a:avLst/>
+          </a:prstGeom>
+          <a:extLst>
+            <a:ext uri="{C572A759-6A51-4108-AA02-DFA0A04FC94B}">
+              <ma14:wrappingTextBoxFlag xmlns:ma14="http://schemas.microsoft.com/office/mac/drawingml/2011/main" val="0"/>
+            </a:ext>
+          </a:extLst>
+        </p:spPr>
+        <p:txBody>
+          <a:bodyPr/>
+          <a:lstStyle>
+            <a:lvl1pPr>
+              <a:defRPr sz="1000">
+                <a:solidFill>
+                  <a:srgbClr val="5B6B7A"/>
+                </a:solidFill>
+                <a:latin typeface="Calibri"/>
+                <a:ea typeface="Calibri"/>
+                <a:cs typeface="Calibri"/>
+              </a:defRPr>
+            </a:lvl1pPr>
+          </a:lstStyle>
+          <a:p>
+            <a:pPr algn="l"/>
+            <a:fld id="{F7021451-1387-4CA6-816F-3879F97B5CBC}" type="slidenum">
+              <a:rPr b="0" lang="en-US"/>
+              <a:t>11</a:t>
+            </a:fld>
+            <a:endParaRPr lang="en-US"/>
+          </a:p>
+        </p:txBody>
+      </p:sp>
+    </p:spTree>
+  </p:cSld>
+  <p:clrMapOvr>
+    <a:masterClrMapping/>
+  </p:clrMapOvr>
+</p:sld>
+</file>
+
+<file path=ppt/slides/slide12.xml><?xml version="1.0" encoding="utf-8"?>
+<p:sld xmlns:a="http://schemas.openxmlformats.org/drawingml/2006/main" xmlns:r="http://schemas.openxmlformats.org/officeDocument/2006/relationships" xmlns:p="http://schemas.openxmlformats.org/presentationml/2006/main">
+  <p:cSld name="Slide 12">
+    <p:spTree>
+      <p:nvGrpSpPr>
+        <p:cNvPr id="1" name=""/>
+        <p:cNvGrpSpPr/>
+        <p:nvPr/>
+      </p:nvGrpSpPr>
+      <p:grpSpPr>
+        <a:xfrm>
+          <a:off x="0" y="0"/>
+          <a:ext cx="0" cy="0"/>
+          <a:chOff x="0" y="0"/>
+          <a:chExt cx="0" cy="0"/>
+        </a:xfrm>
+      </p:grpSpPr>
+      <p:sp>
+        <p:nvSpPr>
+          <p:cNvPr id="2" name="Text 0"/>
+          <p:cNvSpPr/>
+          <p:nvPr>
+            <p:ph idx="100" type="title" hasCustomPrompt="1"/>
+          </p:nvPr>
+        </p:nvSpPr>
+        <p:spPr>
+          <a:xfrm>
+            <a:off x="548640" y="320040"/>
+            <a:ext cx="11064240" cy="822960"/>
+          </a:xfrm>
+          <a:prstGeom prst="rect">
+            <a:avLst/>
+          </a:prstGeom>
+          <a:noFill/>
+          <a:ln/>
+        </p:spPr>
+        <p:txBody>
+          <a:bodyPr wrap="square" lIns="0" tIns="0" rIns="0" bIns="0" rtlCol="0" anchor="ctr"/>
+          <a:lstStyle/>
+          <a:p>
+            <a:pPr indent="0" marL="0">
+              <a:buNone/>
+            </a:pPr>
+            <a:r>
+              <a:rPr lang="en-US" sz="3200" b="1" dirty="0">
+                <a:solidFill>
+                  <a:srgbClr val="1F2A36"/>
+                </a:solidFill>
+                <a:latin typeface="Cambria" pitchFamily="34" charset="0"/>
+                <a:ea typeface="Cambria" pitchFamily="34" charset="-122"/>
+                <a:cs typeface="Cambria" pitchFamily="34" charset="-120"/>
+              </a:rPr>
+              <a:t>What we fixed to get trustworthy numbers</a:t>
+            </a:r>
+            <a:endParaRPr lang="en-US" sz="3200" dirty="0"/>
+          </a:p>
+        </p:txBody>
+      </p:sp>
+      <p:graphicFrame>
+        <p:nvGraphicFramePr>
+          <p:cNvPr id="13" name="Table 0"/>
           <p:cNvGraphicFramePr>
             <a:graphicFrameLocks noGrp="1"/>
           </p:cNvGraphicFramePr>
@@ -6508,7 +8836,7 @@
             <a:pPr algn="l"/>
             <a:fld id="{F7021451-1387-4CA6-816F-3879F97B5CBC}" type="slidenum">
               <a:rPr b="0" lang="en-US"/>
-              <a:t>11</a:t>
+              <a:t>12</a:t>
             </a:fld>
             <a:endParaRPr lang="en-US"/>
           </a:p>
@@ -6522,9 +8850,9 @@
 </p:sld>
 </file>
 
-<file path=ppt/slides/slide12.xml><?xml version="1.0" encoding="utf-8"?>
+<file path=ppt/slides/slide13.xml><?xml version="1.0" encoding="utf-8"?>
 <p:sld xmlns:a="http://schemas.openxmlformats.org/drawingml/2006/main" xmlns:r="http://schemas.openxmlformats.org/officeDocument/2006/relationships" xmlns:p="http://schemas.openxmlformats.org/presentationml/2006/main">
-  <p:cSld name="Slide 12">
+  <p:cSld name="Slide 13">
     <p:spTree>
       <p:nvGrpSpPr>
         <p:cNvPr id="1" name=""/>
@@ -6980,7 +9308,7 @@
             <a:pPr algn="l"/>
             <a:fld id="{F7021451-1387-4CA6-816F-3879F97B5CBC}" type="slidenum">
               <a:rPr b="0" lang="en-US"/>
-              <a:t>12</a:t>
+              <a:t>13</a:t>
             </a:fld>
             <a:endParaRPr lang="en-US"/>
           </a:p>
@@ -6994,9 +9322,9 @@
 </p:sld>
 </file>
 
-<file path=ppt/slides/slide13.xml><?xml version="1.0" encoding="utf-8"?>
+<file path=ppt/slides/slide14.xml><?xml version="1.0" encoding="utf-8"?>
 <p:sld xmlns:a="http://schemas.openxmlformats.org/drawingml/2006/main" xmlns:r="http://schemas.openxmlformats.org/officeDocument/2006/relationships" xmlns:p="http://schemas.openxmlformats.org/presentationml/2006/main">
-  <p:cSld name="Slide 13">
+  <p:cSld name="Slide 14">
     <p:spTree>
       <p:nvGrpSpPr>
         <p:cNvPr id="1" name=""/>

</xml_diff>

<commit_message>
Results on a real city map (Monaco) and final rerun of all results
- realmap_schemes / realmap_attacks: the three schemes and all six attacks
  on central Monaco (OSM), 36 runs; 100 % of attackers reported and
  revoked, 0 honest vehicles revoked
- baselines rerun with PID_ASSIGN: on the real map they show the same
  honest flags as ours (heading check at hairpins / U-turns), confirming
  these come from the shared detector and the map, not the protocol
- every grid result rerun on the final code (unchanged within 0.01)
- docs/results/README.md, HOW_IT_WORKS.md, README: real-map section,
  what the real map revealed; Monaco slide in the deck

Co-Authored-By: Claude Opus 5.5 <noreply@anthropic.com>
Claude-Session: https://claude.ai/code/session_01RhJ9dStThAs6ZjKvaWLus4
</commit_message>
<xml_diff>
--- a/docs/presentation/vanet_results.pptx
+++ b/docs/presentation/vanet_results.pptx
@@ -19,9 +19,10 @@
     <p:sldId id="267" r:id="rId13"/>
     <p:sldId id="268" r:id="rId14"/>
     <p:sldId id="269" r:id="rId15"/>
+    <p:sldId id="270" r:id="rId16"/>
   </p:sldIdLst>
   <p:notesMasterIdLst>
-    <p:notesMasterId r:id="rId16"/>
+    <p:notesMasterId r:id="rId17"/>
   </p:notesMasterIdLst>
   <p:sldSz cx="12192000" cy="6858000"/>
   <p:notesSz cx="6858000" cy="12192000"/>
@@ -235,10 +236,10 @@
                   <c:v>1.8798333333333332</c:v>
                 </c:pt>
                 <c:pt idx="1">
-                  <c:v>1.9639999999999997</c:v>
+                  <c:v>1.9683333333333335</c:v>
                 </c:pt>
                 <c:pt idx="2">
-                  <c:v>2.186833333333333</c:v>
+                  <c:v>2.1811666666666665</c:v>
                 </c:pt>
               </c:numCache>
             </c:numRef>
@@ -315,13 +316,13 @@
                 <c:formatCode>General</c:formatCode>
                 <c:ptCount val="3"/>
                 <c:pt idx="0">
-                  <c:v>3.280383333333333</c:v>
+                  <c:v>3.2775666666666665</c:v>
                 </c:pt>
                 <c:pt idx="1">
-                  <c:v>4.379549999999999</c:v>
+                  <c:v>4.377083333333332</c:v>
                 </c:pt>
                 <c:pt idx="2">
-                  <c:v>7.379766666666662</c:v>
+                  <c:v>7.251766666666662</c:v>
                 </c:pt>
               </c:numCache>
             </c:numRef>
@@ -398,13 +399,13 @@
                 <c:formatCode>General</c:formatCode>
                 <c:ptCount val="3"/>
                 <c:pt idx="0">
-                  <c:v>1.4286666666666665</c:v>
+                  <c:v>1.4221666666666668</c:v>
                 </c:pt>
                 <c:pt idx="1">
-                  <c:v>1.5913333333333333</c:v>
+                  <c:v>1.5853333333333335</c:v>
                 </c:pt>
                 <c:pt idx="2">
-                  <c:v>1.9621666666666666</c:v>
+                  <c:v>1.936</c:v>
                 </c:pt>
               </c:numCache>
             </c:numRef>
@@ -770,13 +771,13 @@
                 <c:formatCode>General</c:formatCode>
                 <c:ptCount val="3"/>
                 <c:pt idx="0">
-                  <c:v>189.4353025865573</c:v>
+                  <c:v>189.43753897255752</c:v>
                 </c:pt>
                 <c:pt idx="1">
-                  <c:v>189.51686971508124</c:v>
+                  <c:v>189.5213528366256</c:v>
                 </c:pt>
                 <c:pt idx="2">
-                  <c:v>189.64757632531837</c:v>
+                  <c:v>189.6490814141151</c:v>
                 </c:pt>
               </c:numCache>
             </c:numRef>
@@ -1059,13 +1060,13 @@
                 <c:formatCode>General</c:formatCode>
                 <c:ptCount val="3"/>
                 <c:pt idx="0">
-                  <c:v>3.057084678834104</c:v>
+                  <c:v>3.05711595662528</c:v>
                 </c:pt>
                 <c:pt idx="1">
-                  <c:v>5.837455474993116</c:v>
+                  <c:v>5.837653775118</c:v>
                 </c:pt>
                 <c:pt idx="2">
-                  <c:v>8.621750254015874</c:v>
+                  <c:v>8.621574049839117</c:v>
                 </c:pt>
               </c:numCache>
             </c:numRef>
@@ -1142,13 +1143,13 @@
                 <c:formatCode>General</c:formatCode>
                 <c:ptCount val="3"/>
                 <c:pt idx="0">
-                  <c:v>2.1980446619831886</c:v>
+                  <c:v>2.198208902017163</c:v>
                 </c:pt>
                 <c:pt idx="1">
-                  <c:v>4.103534616874873</c:v>
+                  <c:v>4.103726646718761</c:v>
                 </c:pt>
                 <c:pt idx="2">
-                  <c:v>6.017974451270946</c:v>
+                  <c:v>6.0171812092645</c:v>
                 </c:pt>
               </c:numCache>
             </c:numRef>
@@ -2670,13 +2671,13 @@
                 <c:formatCode>General</c:formatCode>
                 <c:ptCount val="3"/>
                 <c:pt idx="0">
-                  <c:v>1.9639999999999997</c:v>
+                  <c:v>1.9683333333333335</c:v>
                 </c:pt>
                 <c:pt idx="1">
-                  <c:v>1.2751666666666666</c:v>
+                  <c:v>1.2838333333333332</c:v>
                 </c:pt>
                 <c:pt idx="2">
-                  <c:v>22.247</c:v>
+                  <c:v>22.251333333333335</c:v>
                 </c:pt>
               </c:numCache>
             </c:numRef>
@@ -2753,10 +2754,10 @@
                 <c:formatCode>General</c:formatCode>
                 <c:ptCount val="3"/>
                 <c:pt idx="0">
-                  <c:v>1.5913333333333333</c:v>
+                  <c:v>1.5853333333333335</c:v>
                 </c:pt>
                 <c:pt idx="1">
-                  <c:v>1.2163333333333333</c:v>
+                  <c:v>1.2271666666666665</c:v>
                 </c:pt>
                 <c:pt idx="2">
                   <c:v>22.203333333333333</c:v>
@@ -3789,6 +3790,94 @@
             <a:fld id="{F7021451-1387-4CA6-816F-3879F97B5CBC}" type="slidenum">
               <a:rPr lang="en-US"/>
               <a:t>14</a:t>
+            </a:fld>
+            <a:endParaRPr lang="en-US"/>
+          </a:p>
+        </p:txBody>
+      </p:sp>
+    </p:spTree>
+    <p:extLst>
+      <p:ext uri="{BB962C8B-B14F-4D97-AF65-F5344CB8AC3E}">
+        <p14:creationId xmlns:p14="http://schemas.microsoft.com/office/powerpoint/2010/main" val="1024086991"/>
+      </p:ext>
+    </p:extLst>
+  </p:cSld>
+  <p:clrMapOvr>
+    <a:masterClrMapping/>
+  </p:clrMapOvr>
+</p:notes>
+</file>
+
+<file path=ppt/notesSlides/notesSlide15.xml><?xml version="1.0" encoding="utf-8"?>
+<p:notes xmlns:a="http://schemas.openxmlformats.org/drawingml/2006/main" xmlns:r="http://schemas.openxmlformats.org/officeDocument/2006/relationships" xmlns:p="http://schemas.openxmlformats.org/presentationml/2006/main">
+  <p:cSld>
+    <p:spTree>
+      <p:nvGrpSpPr>
+        <p:cNvPr id="1" name=""/>
+        <p:cNvGrpSpPr/>
+        <p:nvPr/>
+      </p:nvGrpSpPr>
+      <p:grpSpPr>
+        <a:xfrm>
+          <a:off x="0" y="0"/>
+          <a:ext cx="0" cy="0"/>
+          <a:chOff x="0" y="0"/>
+          <a:chExt cx="0" cy="0"/>
+        </a:xfrm>
+      </p:grpSpPr>
+      <p:sp>
+        <p:nvSpPr>
+          <p:cNvPr id="2" name="Slide Image Placeholder 1"/>
+          <p:cNvSpPr>
+            <a:spLocks noGrp="1" noRot="1" noChangeAspect="1"/>
+          </p:cNvSpPr>
+          <p:nvPr>
+            <p:ph type="sldImg"/>
+          </p:nvPr>
+        </p:nvSpPr>
+        <p:spPr/>
+      </p:sp>
+      <p:sp>
+        <p:nvSpPr>
+          <p:cNvPr id="3" name="Notes Placeholder 2"/>
+          <p:cNvSpPr>
+            <a:spLocks noGrp="1"/>
+          </p:cNvSpPr>
+          <p:nvPr>
+            <p:ph type="body" idx="1"/>
+          </p:nvPr>
+        </p:nvSpPr>
+        <p:spPr/>
+        <p:txBody>
+          <a:bodyPr/>
+          <a:lstStyle/>
+          <a:p>
+            <a:r>
+              <a:rPr lang="en-US" dirty="0"/>
+              <a:t/>
+            </a:r>
+            <a:endParaRPr lang="en-US" dirty="0"/>
+          </a:p>
+        </p:txBody>
+      </p:sp>
+      <p:sp>
+        <p:nvSpPr>
+          <p:cNvPr id="4" name="Slide Number Placeholder 3"/>
+          <p:cNvSpPr>
+            <a:spLocks noGrp="1"/>
+          </p:cNvSpPr>
+          <p:nvPr>
+            <p:ph type="sldNum" sz="quarter" idx="10"/>
+          </p:nvPr>
+        </p:nvSpPr>
+        <p:spPr/>
+        <p:txBody>
+          <a:bodyPr/>
+          <a:lstStyle/>
+          <a:p>
+            <a:fld id="{F7021451-1387-4CA6-816F-3879F97B5CBC}" type="slidenum">
+              <a:rPr lang="en-US"/>
+              <a:t>15</a:t>
             </a:fld>
             <a:endParaRPr lang="en-US"/>
           </a:p>
@@ -7279,6 +7368,1492 @@
                 <a:ea typeface="Cambria" pitchFamily="34" charset="-122"/>
                 <a:cs typeface="Cambria" pitchFamily="34" charset="-120"/>
               </a:rPr>
+              <a:t>On a real city: central Monaco from OpenStreetMap</a:t>
+            </a:r>
+            <a:endParaRPr lang="en-US" sz="3200" dirty="0"/>
+          </a:p>
+        </p:txBody>
+      </p:sp>
+      <p:pic>
+        <p:nvPicPr>
+          <p:cNvPr id="3" name="Image 0" descr="/home/user/vanet-demo/docs/figures/monaco_snapshot.png">    </p:cNvPr>
+          <p:cNvPicPr>
+            <a:picLocks noChangeAspect="1"/>
+          </p:cNvPicPr>
+          <p:nvPr/>
+        </p:nvPicPr>
+        <p:blipFill>
+          <a:blip r:embed="rId1"/>
+          <a:stretch>
+            <a:fillRect/>
+          </a:stretch>
+        </p:blipFill>
+        <p:spPr>
+          <a:xfrm>
+            <a:off x="548640" y="1234440"/>
+            <a:ext cx="4754880" cy="4754880"/>
+          </a:xfrm>
+          <a:prstGeom prst="rect">
+            <a:avLst/>
+          </a:prstGeom>
+        </p:spPr>
+      </p:pic>
+      <p:graphicFrame>
+        <p:nvGraphicFramePr>
+          <p:cNvPr id="13" name="Table 0"/>
+          <p:cNvGraphicFramePr>
+            <a:graphicFrameLocks noGrp="1"/>
+          </p:cNvGraphicFramePr>
+          <p:nvPr>
+            <p:extLst>
+              <p:ext uri="{D42A27DB-BD31-4B8C-83A1-F6EECF244321}">
+                <p14:modId xmlns:p14="http://schemas.microsoft.com/office/powerpoint/2010/main" val="1579011935"/>
+              </p:ext>
+            </p:extLst>
+          </p:nvPr>
+        </p:nvGraphicFramePr>
+        <p:xfrm>
+          <a:off x="5669280" y="1325880"/>
+          <a:ext cx="5943600" cy="914400"/>
+        </p:xfrm>
+        <a:graphic>
+          <a:graphicData uri="http://schemas.openxmlformats.org/drawingml/2006/table">
+            <a:tbl>
+              <a:tblPr/>
+              <a:tblGrid>
+                <a:gridCol w="2651760"/>
+                <a:gridCol w="1645920"/>
+                <a:gridCol w="1645920"/>
+              </a:tblGrid>
+              <a:tr h="411480">
+                <a:tc>
+                  <a:txBody>
+                    <a:bodyPr/>
+                    <a:lstStyle/>
+                    <a:p>
+                      <a:pPr indent="0" marL="0">
+                        <a:buNone/>
+                      </a:pPr>
+                      <a:endParaRPr lang="en-US" sz="1300" dirty="0">
+                        <a:latin typeface="Calibri" charset="0"/>
+                        <a:ea typeface="Calibri" charset="0"/>
+                        <a:cs typeface="Calibri" charset="0"/>
+                      </a:endParaRPr>
+                    </a:p>
+                  </a:txBody>
+                  <a:tcPr marL="91440" marR="91440" marT="45720" marB="45720" anchor="ctr">
+                    <a:lnL w="9525" cap="flat" cmpd="sng" algn="ctr">
+                      <a:solidFill>
+                        <a:srgbClr val="D5DCE3"/>
+                      </a:solidFill>
+                      <a:prstDash val="solid"/>
+                      <a:round/>
+                      <a:headEnd type="none" w="med" len="med"/>
+                      <a:tailEnd type="none" w="med" len="med"/>
+                    </a:lnL>
+                    <a:lnR w="9525" cap="flat" cmpd="sng" algn="ctr">
+                      <a:solidFill>
+                        <a:srgbClr val="D5DCE3"/>
+                      </a:solidFill>
+                      <a:prstDash val="solid"/>
+                      <a:round/>
+                      <a:headEnd type="none" w="med" len="med"/>
+                      <a:tailEnd type="none" w="med" len="med"/>
+                    </a:lnR>
+                    <a:lnT w="9525" cap="flat" cmpd="sng" algn="ctr">
+                      <a:solidFill>
+                        <a:srgbClr val="D5DCE3"/>
+                      </a:solidFill>
+                      <a:prstDash val="solid"/>
+                      <a:round/>
+                      <a:headEnd type="none" w="med" len="med"/>
+                      <a:tailEnd type="none" w="med" len="med"/>
+                    </a:lnT>
+                    <a:lnB w="9525" cap="flat" cmpd="sng" algn="ctr">
+                      <a:solidFill>
+                        <a:srgbClr val="D5DCE3"/>
+                      </a:solidFill>
+                      <a:prstDash val="solid"/>
+                      <a:round/>
+                      <a:headEnd type="none" w="med" len="med"/>
+                      <a:tailEnd type="none" w="med" len="med"/>
+                    </a:lnB>
+                    <a:solidFill>
+                      <a:srgbClr val="1F2A36"/>
+                    </a:solidFill>
+                  </a:tcPr>
+                </a:tc>
+                <a:tc>
+                  <a:txBody>
+                    <a:bodyPr/>
+                    <a:lstStyle/>
+                    <a:p>
+                      <a:pPr indent="0" marL="0">
+                        <a:buNone/>
+                      </a:pPr>
+                      <a:r>
+                        <a:rPr lang="en-US" sz="1300" b="1" dirty="0">
+                          <a:solidFill>
+                            <a:srgbClr val="FFFFFF"/>
+                          </a:solidFill>
+                          <a:latin typeface="Calibri" pitchFamily="34" charset="0"/>
+                          <a:ea typeface="Calibri" pitchFamily="34" charset="-122"/>
+                          <a:cs typeface="Calibri" pitchFamily="34" charset="-120"/>
+                        </a:rPr>
+                        <a:t>60 veh</a:t>
+                      </a:r>
+                      <a:endParaRPr lang="en-US" sz="1300" dirty="0">
+                        <a:latin typeface="Calibri" charset="0"/>
+                        <a:ea typeface="Calibri" charset="0"/>
+                        <a:cs typeface="Calibri" charset="0"/>
+                      </a:endParaRPr>
+                    </a:p>
+                  </a:txBody>
+                  <a:tcPr marL="91440" marR="91440" marT="45720" marB="45720" anchor="ctr">
+                    <a:lnL w="9525" cap="flat" cmpd="sng" algn="ctr">
+                      <a:solidFill>
+                        <a:srgbClr val="D5DCE3"/>
+                      </a:solidFill>
+                      <a:prstDash val="solid"/>
+                      <a:round/>
+                      <a:headEnd type="none" w="med" len="med"/>
+                      <a:tailEnd type="none" w="med" len="med"/>
+                    </a:lnL>
+                    <a:lnR w="9525" cap="flat" cmpd="sng" algn="ctr">
+                      <a:solidFill>
+                        <a:srgbClr val="D5DCE3"/>
+                      </a:solidFill>
+                      <a:prstDash val="solid"/>
+                      <a:round/>
+                      <a:headEnd type="none" w="med" len="med"/>
+                      <a:tailEnd type="none" w="med" len="med"/>
+                    </a:lnR>
+                    <a:lnT w="9525" cap="flat" cmpd="sng" algn="ctr">
+                      <a:solidFill>
+                        <a:srgbClr val="D5DCE3"/>
+                      </a:solidFill>
+                      <a:prstDash val="solid"/>
+                      <a:round/>
+                      <a:headEnd type="none" w="med" len="med"/>
+                      <a:tailEnd type="none" w="med" len="med"/>
+                    </a:lnT>
+                    <a:lnB w="9525" cap="flat" cmpd="sng" algn="ctr">
+                      <a:solidFill>
+                        <a:srgbClr val="D5DCE3"/>
+                      </a:solidFill>
+                      <a:prstDash val="solid"/>
+                      <a:round/>
+                      <a:headEnd type="none" w="med" len="med"/>
+                      <a:tailEnd type="none" w="med" len="med"/>
+                    </a:lnB>
+                    <a:solidFill>
+                      <a:srgbClr val="1F2A36"/>
+                    </a:solidFill>
+                  </a:tcPr>
+                </a:tc>
+                <a:tc>
+                  <a:txBody>
+                    <a:bodyPr/>
+                    <a:lstStyle/>
+                    <a:p>
+                      <a:pPr indent="0" marL="0">
+                        <a:buNone/>
+                      </a:pPr>
+                      <a:r>
+                        <a:rPr lang="en-US" sz="1300" b="1" dirty="0">
+                          <a:solidFill>
+                            <a:srgbClr val="FFFFFF"/>
+                          </a:solidFill>
+                          <a:latin typeface="Calibri" pitchFamily="34" charset="0"/>
+                          <a:ea typeface="Calibri" pitchFamily="34" charset="-122"/>
+                          <a:cs typeface="Calibri" pitchFamily="34" charset="-120"/>
+                        </a:rPr>
+                        <a:t>120 veh</a:t>
+                      </a:r>
+                      <a:endParaRPr lang="en-US" sz="1300" dirty="0">
+                        <a:latin typeface="Calibri" charset="0"/>
+                        <a:ea typeface="Calibri" charset="0"/>
+                        <a:cs typeface="Calibri" charset="0"/>
+                      </a:endParaRPr>
+                    </a:p>
+                  </a:txBody>
+                  <a:tcPr marL="91440" marR="91440" marT="45720" marB="45720" anchor="ctr">
+                    <a:lnL w="9525" cap="flat" cmpd="sng" algn="ctr">
+                      <a:solidFill>
+                        <a:srgbClr val="D5DCE3"/>
+                      </a:solidFill>
+                      <a:prstDash val="solid"/>
+                      <a:round/>
+                      <a:headEnd type="none" w="med" len="med"/>
+                      <a:tailEnd type="none" w="med" len="med"/>
+                    </a:lnL>
+                    <a:lnR w="9525" cap="flat" cmpd="sng" algn="ctr">
+                      <a:solidFill>
+                        <a:srgbClr val="D5DCE3"/>
+                      </a:solidFill>
+                      <a:prstDash val="solid"/>
+                      <a:round/>
+                      <a:headEnd type="none" w="med" len="med"/>
+                      <a:tailEnd type="none" w="med" len="med"/>
+                    </a:lnR>
+                    <a:lnT w="9525" cap="flat" cmpd="sng" algn="ctr">
+                      <a:solidFill>
+                        <a:srgbClr val="D5DCE3"/>
+                      </a:solidFill>
+                      <a:prstDash val="solid"/>
+                      <a:round/>
+                      <a:headEnd type="none" w="med" len="med"/>
+                      <a:tailEnd type="none" w="med" len="med"/>
+                    </a:lnT>
+                    <a:lnB w="9525" cap="flat" cmpd="sng" algn="ctr">
+                      <a:solidFill>
+                        <a:srgbClr val="D5DCE3"/>
+                      </a:solidFill>
+                      <a:prstDash val="solid"/>
+                      <a:round/>
+                      <a:headEnd type="none" w="med" len="med"/>
+                      <a:tailEnd type="none" w="med" len="med"/>
+                    </a:lnB>
+                    <a:solidFill>
+                      <a:srgbClr val="1F2A36"/>
+                    </a:solidFill>
+                  </a:tcPr>
+                </a:tc>
+              </a:tr>
+              <a:tr h="411480">
+                <a:tc>
+                  <a:txBody>
+                    <a:bodyPr/>
+                    <a:lstStyle/>
+                    <a:p>
+                      <a:pPr indent="0" marL="0">
+                        <a:buNone/>
+                      </a:pPr>
+                      <a:r>
+                        <a:rPr lang="en-US" sz="1300" dirty="0">
+                          <a:solidFill>
+                            <a:srgbClr val="1F2A36"/>
+                          </a:solidFill>
+                          <a:latin typeface="Calibri" pitchFamily="34" charset="0"/>
+                          <a:ea typeface="Calibri" pitchFamily="34" charset="-122"/>
+                          <a:cs typeface="Calibri" pitchFamily="34" charset="-120"/>
+                        </a:rPr>
+                        <a:t>Auth latency, median</a:t>
+                      </a:r>
+                      <a:endParaRPr lang="en-US" sz="1300" dirty="0">
+                        <a:latin typeface="Calibri" charset="0"/>
+                        <a:ea typeface="Calibri" charset="0"/>
+                        <a:cs typeface="Calibri" charset="0"/>
+                      </a:endParaRPr>
+                    </a:p>
+                  </a:txBody>
+                  <a:tcPr marL="91440" marR="91440" marT="45720" marB="45720" anchor="ctr">
+                    <a:lnL w="9525" cap="flat" cmpd="sng" algn="ctr">
+                      <a:solidFill>
+                        <a:srgbClr val="D5DCE3"/>
+                      </a:solidFill>
+                      <a:prstDash val="solid"/>
+                      <a:round/>
+                      <a:headEnd type="none" w="med" len="med"/>
+                      <a:tailEnd type="none" w="med" len="med"/>
+                    </a:lnL>
+                    <a:lnR w="9525" cap="flat" cmpd="sng" algn="ctr">
+                      <a:solidFill>
+                        <a:srgbClr val="D5DCE3"/>
+                      </a:solidFill>
+                      <a:prstDash val="solid"/>
+                      <a:round/>
+                      <a:headEnd type="none" w="med" len="med"/>
+                      <a:tailEnd type="none" w="med" len="med"/>
+                    </a:lnR>
+                    <a:lnT w="9525" cap="flat" cmpd="sng" algn="ctr">
+                      <a:solidFill>
+                        <a:srgbClr val="D5DCE3"/>
+                      </a:solidFill>
+                      <a:prstDash val="solid"/>
+                      <a:round/>
+                      <a:headEnd type="none" w="med" len="med"/>
+                      <a:tailEnd type="none" w="med" len="med"/>
+                    </a:lnT>
+                    <a:lnB w="9525" cap="flat" cmpd="sng" algn="ctr">
+                      <a:solidFill>
+                        <a:srgbClr val="D5DCE3"/>
+                      </a:solidFill>
+                      <a:prstDash val="solid"/>
+                      <a:round/>
+                      <a:headEnd type="none" w="med" len="med"/>
+                      <a:tailEnd type="none" w="med" len="med"/>
+                    </a:lnB>
+                    <a:solidFill>
+                      <a:srgbClr val="FFFFFF"/>
+                    </a:solidFill>
+                  </a:tcPr>
+                </a:tc>
+                <a:tc>
+                  <a:txBody>
+                    <a:bodyPr/>
+                    <a:lstStyle/>
+                    <a:p>
+                      <a:pPr indent="0" marL="0">
+                        <a:buNone/>
+                      </a:pPr>
+                      <a:r>
+                        <a:rPr lang="en-US" sz="1300" dirty="0">
+                          <a:solidFill>
+                            <a:srgbClr val="1F2A36"/>
+                          </a:solidFill>
+                          <a:latin typeface="Calibri" pitchFamily="34" charset="0"/>
+                          <a:ea typeface="Calibri" pitchFamily="34" charset="-122"/>
+                          <a:cs typeface="Calibri" pitchFamily="34" charset="-120"/>
+                        </a:rPr>
+                        <a:t>1.96 ms</a:t>
+                      </a:r>
+                      <a:endParaRPr lang="en-US" sz="1300" dirty="0">
+                        <a:latin typeface="Calibri" charset="0"/>
+                        <a:ea typeface="Calibri" charset="0"/>
+                        <a:cs typeface="Calibri" charset="0"/>
+                      </a:endParaRPr>
+                    </a:p>
+                  </a:txBody>
+                  <a:tcPr marL="91440" marR="91440" marT="45720" marB="45720" anchor="ctr">
+                    <a:lnL w="9525" cap="flat" cmpd="sng" algn="ctr">
+                      <a:solidFill>
+                        <a:srgbClr val="D5DCE3"/>
+                      </a:solidFill>
+                      <a:prstDash val="solid"/>
+                      <a:round/>
+                      <a:headEnd type="none" w="med" len="med"/>
+                      <a:tailEnd type="none" w="med" len="med"/>
+                    </a:lnL>
+                    <a:lnR w="9525" cap="flat" cmpd="sng" algn="ctr">
+                      <a:solidFill>
+                        <a:srgbClr val="D5DCE3"/>
+                      </a:solidFill>
+                      <a:prstDash val="solid"/>
+                      <a:round/>
+                      <a:headEnd type="none" w="med" len="med"/>
+                      <a:tailEnd type="none" w="med" len="med"/>
+                    </a:lnR>
+                    <a:lnT w="9525" cap="flat" cmpd="sng" algn="ctr">
+                      <a:solidFill>
+                        <a:srgbClr val="D5DCE3"/>
+                      </a:solidFill>
+                      <a:prstDash val="solid"/>
+                      <a:round/>
+                      <a:headEnd type="none" w="med" len="med"/>
+                      <a:tailEnd type="none" w="med" len="med"/>
+                    </a:lnT>
+                    <a:lnB w="9525" cap="flat" cmpd="sng" algn="ctr">
+                      <a:solidFill>
+                        <a:srgbClr val="D5DCE3"/>
+                      </a:solidFill>
+                      <a:prstDash val="solid"/>
+                      <a:round/>
+                      <a:headEnd type="none" w="med" len="med"/>
+                      <a:tailEnd type="none" w="med" len="med"/>
+                    </a:lnB>
+                    <a:solidFill>
+                      <a:srgbClr val="FFFFFF"/>
+                    </a:solidFill>
+                  </a:tcPr>
+                </a:tc>
+                <a:tc>
+                  <a:txBody>
+                    <a:bodyPr/>
+                    <a:lstStyle/>
+                    <a:p>
+                      <a:pPr indent="0" marL="0">
+                        <a:buNone/>
+                      </a:pPr>
+                      <a:r>
+                        <a:rPr lang="en-US" sz="1300" dirty="0">
+                          <a:solidFill>
+                            <a:srgbClr val="1F2A36"/>
+                          </a:solidFill>
+                          <a:latin typeface="Calibri" pitchFamily="34" charset="0"/>
+                          <a:ea typeface="Calibri" pitchFamily="34" charset="-122"/>
+                          <a:cs typeface="Calibri" pitchFamily="34" charset="-120"/>
+                        </a:rPr>
+                        <a:t>2.41 ms</a:t>
+                      </a:r>
+                      <a:endParaRPr lang="en-US" sz="1300" dirty="0">
+                        <a:latin typeface="Calibri" charset="0"/>
+                        <a:ea typeface="Calibri" charset="0"/>
+                        <a:cs typeface="Calibri" charset="0"/>
+                      </a:endParaRPr>
+                    </a:p>
+                  </a:txBody>
+                  <a:tcPr marL="91440" marR="91440" marT="45720" marB="45720" anchor="ctr">
+                    <a:lnL w="9525" cap="flat" cmpd="sng" algn="ctr">
+                      <a:solidFill>
+                        <a:srgbClr val="D5DCE3"/>
+                      </a:solidFill>
+                      <a:prstDash val="solid"/>
+                      <a:round/>
+                      <a:headEnd type="none" w="med" len="med"/>
+                      <a:tailEnd type="none" w="med" len="med"/>
+                    </a:lnL>
+                    <a:lnR w="9525" cap="flat" cmpd="sng" algn="ctr">
+                      <a:solidFill>
+                        <a:srgbClr val="D5DCE3"/>
+                      </a:solidFill>
+                      <a:prstDash val="solid"/>
+                      <a:round/>
+                      <a:headEnd type="none" w="med" len="med"/>
+                      <a:tailEnd type="none" w="med" len="med"/>
+                    </a:lnR>
+                    <a:lnT w="9525" cap="flat" cmpd="sng" algn="ctr">
+                      <a:solidFill>
+                        <a:srgbClr val="D5DCE3"/>
+                      </a:solidFill>
+                      <a:prstDash val="solid"/>
+                      <a:round/>
+                      <a:headEnd type="none" w="med" len="med"/>
+                      <a:tailEnd type="none" w="med" len="med"/>
+                    </a:lnT>
+                    <a:lnB w="9525" cap="flat" cmpd="sng" algn="ctr">
+                      <a:solidFill>
+                        <a:srgbClr val="D5DCE3"/>
+                      </a:solidFill>
+                      <a:prstDash val="solid"/>
+                      <a:round/>
+                      <a:headEnd type="none" w="med" len="med"/>
+                      <a:tailEnd type="none" w="med" len="med"/>
+                    </a:lnB>
+                    <a:solidFill>
+                      <a:srgbClr val="FFFFFF"/>
+                    </a:solidFill>
+                  </a:tcPr>
+                </a:tc>
+              </a:tr>
+              <a:tr h="411480">
+                <a:tc>
+                  <a:txBody>
+                    <a:bodyPr/>
+                    <a:lstStyle/>
+                    <a:p>
+                      <a:pPr indent="0" marL="0">
+                        <a:buNone/>
+                      </a:pPr>
+                      <a:r>
+                        <a:rPr lang="en-US" sz="1300" dirty="0">
+                          <a:solidFill>
+                            <a:srgbClr val="1F2A36"/>
+                          </a:solidFill>
+                          <a:latin typeface="Calibri" pitchFamily="34" charset="0"/>
+                          <a:ea typeface="Calibri" pitchFamily="34" charset="-122"/>
+                          <a:cs typeface="Calibri" pitchFamily="34" charset="-120"/>
+                        </a:rPr>
+                        <a:t>  ECDSA / central</a:t>
+                      </a:r>
+                      <a:endParaRPr lang="en-US" sz="1300" dirty="0">
+                        <a:latin typeface="Calibri" charset="0"/>
+                        <a:ea typeface="Calibri" charset="0"/>
+                        <a:cs typeface="Calibri" charset="0"/>
+                      </a:endParaRPr>
+                    </a:p>
+                  </a:txBody>
+                  <a:tcPr marL="91440" marR="91440" marT="45720" marB="45720" anchor="ctr">
+                    <a:lnL w="9525" cap="flat" cmpd="sng" algn="ctr">
+                      <a:solidFill>
+                        <a:srgbClr val="D5DCE3"/>
+                      </a:solidFill>
+                      <a:prstDash val="solid"/>
+                      <a:round/>
+                      <a:headEnd type="none" w="med" len="med"/>
+                      <a:tailEnd type="none" w="med" len="med"/>
+                    </a:lnL>
+                    <a:lnR w="9525" cap="flat" cmpd="sng" algn="ctr">
+                      <a:solidFill>
+                        <a:srgbClr val="D5DCE3"/>
+                      </a:solidFill>
+                      <a:prstDash val="solid"/>
+                      <a:round/>
+                      <a:headEnd type="none" w="med" len="med"/>
+                      <a:tailEnd type="none" w="med" len="med"/>
+                    </a:lnR>
+                    <a:lnT w="9525" cap="flat" cmpd="sng" algn="ctr">
+                      <a:solidFill>
+                        <a:srgbClr val="D5DCE3"/>
+                      </a:solidFill>
+                      <a:prstDash val="solid"/>
+                      <a:round/>
+                      <a:headEnd type="none" w="med" len="med"/>
+                      <a:tailEnd type="none" w="med" len="med"/>
+                    </a:lnT>
+                    <a:lnB w="9525" cap="flat" cmpd="sng" algn="ctr">
+                      <a:solidFill>
+                        <a:srgbClr val="D5DCE3"/>
+                      </a:solidFill>
+                      <a:prstDash val="solid"/>
+                      <a:round/>
+                      <a:headEnd type="none" w="med" len="med"/>
+                      <a:tailEnd type="none" w="med" len="med"/>
+                    </a:lnB>
+                    <a:solidFill>
+                      <a:srgbClr val="FFFFFF"/>
+                    </a:solidFill>
+                  </a:tcPr>
+                </a:tc>
+                <a:tc>
+                  <a:txBody>
+                    <a:bodyPr/>
+                    <a:lstStyle/>
+                    <a:p>
+                      <a:pPr indent="0" marL="0">
+                        <a:buNone/>
+                      </a:pPr>
+                      <a:r>
+                        <a:rPr lang="en-US" sz="1300" dirty="0">
+                          <a:solidFill>
+                            <a:srgbClr val="1F2A36"/>
+                          </a:solidFill>
+                          <a:latin typeface="Calibri" pitchFamily="34" charset="0"/>
+                          <a:ea typeface="Calibri" pitchFamily="34" charset="-122"/>
+                          <a:cs typeface="Calibri" pitchFamily="34" charset="-120"/>
+                        </a:rPr>
+                        <a:t>1.29 / 22.2 ms</a:t>
+                      </a:r>
+                      <a:endParaRPr lang="en-US" sz="1300" dirty="0">
+                        <a:latin typeface="Calibri" charset="0"/>
+                        <a:ea typeface="Calibri" charset="0"/>
+                        <a:cs typeface="Calibri" charset="0"/>
+                      </a:endParaRPr>
+                    </a:p>
+                  </a:txBody>
+                  <a:tcPr marL="91440" marR="91440" marT="45720" marB="45720" anchor="ctr">
+                    <a:lnL w="9525" cap="flat" cmpd="sng" algn="ctr">
+                      <a:solidFill>
+                        <a:srgbClr val="D5DCE3"/>
+                      </a:solidFill>
+                      <a:prstDash val="solid"/>
+                      <a:round/>
+                      <a:headEnd type="none" w="med" len="med"/>
+                      <a:tailEnd type="none" w="med" len="med"/>
+                    </a:lnL>
+                    <a:lnR w="9525" cap="flat" cmpd="sng" algn="ctr">
+                      <a:solidFill>
+                        <a:srgbClr val="D5DCE3"/>
+                      </a:solidFill>
+                      <a:prstDash val="solid"/>
+                      <a:round/>
+                      <a:headEnd type="none" w="med" len="med"/>
+                      <a:tailEnd type="none" w="med" len="med"/>
+                    </a:lnR>
+                    <a:lnT w="9525" cap="flat" cmpd="sng" algn="ctr">
+                      <a:solidFill>
+                        <a:srgbClr val="D5DCE3"/>
+                      </a:solidFill>
+                      <a:prstDash val="solid"/>
+                      <a:round/>
+                      <a:headEnd type="none" w="med" len="med"/>
+                      <a:tailEnd type="none" w="med" len="med"/>
+                    </a:lnT>
+                    <a:lnB w="9525" cap="flat" cmpd="sng" algn="ctr">
+                      <a:solidFill>
+                        <a:srgbClr val="D5DCE3"/>
+                      </a:solidFill>
+                      <a:prstDash val="solid"/>
+                      <a:round/>
+                      <a:headEnd type="none" w="med" len="med"/>
+                      <a:tailEnd type="none" w="med" len="med"/>
+                    </a:lnB>
+                    <a:solidFill>
+                      <a:srgbClr val="FFFFFF"/>
+                    </a:solidFill>
+                  </a:tcPr>
+                </a:tc>
+                <a:tc>
+                  <a:txBody>
+                    <a:bodyPr/>
+                    <a:lstStyle/>
+                    <a:p>
+                      <a:pPr indent="0" marL="0">
+                        <a:buNone/>
+                      </a:pPr>
+                      <a:r>
+                        <a:rPr lang="en-US" sz="1300" dirty="0">
+                          <a:solidFill>
+                            <a:srgbClr val="1F2A36"/>
+                          </a:solidFill>
+                          <a:latin typeface="Calibri" pitchFamily="34" charset="0"/>
+                          <a:ea typeface="Calibri" pitchFamily="34" charset="-122"/>
+                          <a:cs typeface="Calibri" pitchFamily="34" charset="-120"/>
+                        </a:rPr>
+                        <a:t>1.40 / 22.3 ms</a:t>
+                      </a:r>
+                      <a:endParaRPr lang="en-US" sz="1300" dirty="0">
+                        <a:latin typeface="Calibri" charset="0"/>
+                        <a:ea typeface="Calibri" charset="0"/>
+                        <a:cs typeface="Calibri" charset="0"/>
+                      </a:endParaRPr>
+                    </a:p>
+                  </a:txBody>
+                  <a:tcPr marL="91440" marR="91440" marT="45720" marB="45720" anchor="ctr">
+                    <a:lnL w="9525" cap="flat" cmpd="sng" algn="ctr">
+                      <a:solidFill>
+                        <a:srgbClr val="D5DCE3"/>
+                      </a:solidFill>
+                      <a:prstDash val="solid"/>
+                      <a:round/>
+                      <a:headEnd type="none" w="med" len="med"/>
+                      <a:tailEnd type="none" w="med" len="med"/>
+                    </a:lnL>
+                    <a:lnR w="9525" cap="flat" cmpd="sng" algn="ctr">
+                      <a:solidFill>
+                        <a:srgbClr val="D5DCE3"/>
+                      </a:solidFill>
+                      <a:prstDash val="solid"/>
+                      <a:round/>
+                      <a:headEnd type="none" w="med" len="med"/>
+                      <a:tailEnd type="none" w="med" len="med"/>
+                    </a:lnR>
+                    <a:lnT w="9525" cap="flat" cmpd="sng" algn="ctr">
+                      <a:solidFill>
+                        <a:srgbClr val="D5DCE3"/>
+                      </a:solidFill>
+                      <a:prstDash val="solid"/>
+                      <a:round/>
+                      <a:headEnd type="none" w="med" len="med"/>
+                      <a:tailEnd type="none" w="med" len="med"/>
+                    </a:lnT>
+                    <a:lnB w="9525" cap="flat" cmpd="sng" algn="ctr">
+                      <a:solidFill>
+                        <a:srgbClr val="D5DCE3"/>
+                      </a:solidFill>
+                      <a:prstDash val="solid"/>
+                      <a:round/>
+                      <a:headEnd type="none" w="med" len="med"/>
+                      <a:tailEnd type="none" w="med" len="med"/>
+                    </a:lnB>
+                    <a:solidFill>
+                      <a:srgbClr val="FFFFFF"/>
+                    </a:solidFill>
+                  </a:tcPr>
+                </a:tc>
+              </a:tr>
+              <a:tr h="411480">
+                <a:tc>
+                  <a:txBody>
+                    <a:bodyPr/>
+                    <a:lstStyle/>
+                    <a:p>
+                      <a:pPr indent="0" marL="0">
+                        <a:buNone/>
+                      </a:pPr>
+                      <a:r>
+                        <a:rPr lang="en-US" sz="1300" dirty="0">
+                          <a:solidFill>
+                            <a:srgbClr val="1F2A36"/>
+                          </a:solidFill>
+                          <a:latin typeface="Calibri" pitchFamily="34" charset="0"/>
+                          <a:ea typeface="Calibri" pitchFamily="34" charset="-122"/>
+                          <a:cs typeface="Calibri" pitchFamily="34" charset="-120"/>
+                        </a:rPr>
+                        <a:t>Handover success</a:t>
+                      </a:r>
+                      <a:endParaRPr lang="en-US" sz="1300" dirty="0">
+                        <a:latin typeface="Calibri" charset="0"/>
+                        <a:ea typeface="Calibri" charset="0"/>
+                        <a:cs typeface="Calibri" charset="0"/>
+                      </a:endParaRPr>
+                    </a:p>
+                  </a:txBody>
+                  <a:tcPr marL="91440" marR="91440" marT="45720" marB="45720" anchor="ctr">
+                    <a:lnL w="9525" cap="flat" cmpd="sng" algn="ctr">
+                      <a:solidFill>
+                        <a:srgbClr val="D5DCE3"/>
+                      </a:solidFill>
+                      <a:prstDash val="solid"/>
+                      <a:round/>
+                      <a:headEnd type="none" w="med" len="med"/>
+                      <a:tailEnd type="none" w="med" len="med"/>
+                    </a:lnL>
+                    <a:lnR w="9525" cap="flat" cmpd="sng" algn="ctr">
+                      <a:solidFill>
+                        <a:srgbClr val="D5DCE3"/>
+                      </a:solidFill>
+                      <a:prstDash val="solid"/>
+                      <a:round/>
+                      <a:headEnd type="none" w="med" len="med"/>
+                      <a:tailEnd type="none" w="med" len="med"/>
+                    </a:lnR>
+                    <a:lnT w="9525" cap="flat" cmpd="sng" algn="ctr">
+                      <a:solidFill>
+                        <a:srgbClr val="D5DCE3"/>
+                      </a:solidFill>
+                      <a:prstDash val="solid"/>
+                      <a:round/>
+                      <a:headEnd type="none" w="med" len="med"/>
+                      <a:tailEnd type="none" w="med" len="med"/>
+                    </a:lnT>
+                    <a:lnB w="9525" cap="flat" cmpd="sng" algn="ctr">
+                      <a:solidFill>
+                        <a:srgbClr val="D5DCE3"/>
+                      </a:solidFill>
+                      <a:prstDash val="solid"/>
+                      <a:round/>
+                      <a:headEnd type="none" w="med" len="med"/>
+                      <a:tailEnd type="none" w="med" len="med"/>
+                    </a:lnB>
+                    <a:solidFill>
+                      <a:srgbClr val="FFFFFF"/>
+                    </a:solidFill>
+                  </a:tcPr>
+                </a:tc>
+                <a:tc>
+                  <a:txBody>
+                    <a:bodyPr/>
+                    <a:lstStyle/>
+                    <a:p>
+                      <a:pPr indent="0" marL="0">
+                        <a:buNone/>
+                      </a:pPr>
+                      <a:r>
+                        <a:rPr lang="en-US" sz="1300" dirty="0">
+                          <a:solidFill>
+                            <a:srgbClr val="1F2A36"/>
+                          </a:solidFill>
+                          <a:latin typeface="Calibri" pitchFamily="34" charset="0"/>
+                          <a:ea typeface="Calibri" pitchFamily="34" charset="-122"/>
+                          <a:cs typeface="Calibri" pitchFamily="34" charset="-120"/>
+                        </a:rPr>
+                        <a:t>98.6 %</a:t>
+                      </a:r>
+                      <a:endParaRPr lang="en-US" sz="1300" dirty="0">
+                        <a:latin typeface="Calibri" charset="0"/>
+                        <a:ea typeface="Calibri" charset="0"/>
+                        <a:cs typeface="Calibri" charset="0"/>
+                      </a:endParaRPr>
+                    </a:p>
+                  </a:txBody>
+                  <a:tcPr marL="91440" marR="91440" marT="45720" marB="45720" anchor="ctr">
+                    <a:lnL w="9525" cap="flat" cmpd="sng" algn="ctr">
+                      <a:solidFill>
+                        <a:srgbClr val="D5DCE3"/>
+                      </a:solidFill>
+                      <a:prstDash val="solid"/>
+                      <a:round/>
+                      <a:headEnd type="none" w="med" len="med"/>
+                      <a:tailEnd type="none" w="med" len="med"/>
+                    </a:lnL>
+                    <a:lnR w="9525" cap="flat" cmpd="sng" algn="ctr">
+                      <a:solidFill>
+                        <a:srgbClr val="D5DCE3"/>
+                      </a:solidFill>
+                      <a:prstDash val="solid"/>
+                      <a:round/>
+                      <a:headEnd type="none" w="med" len="med"/>
+                      <a:tailEnd type="none" w="med" len="med"/>
+                    </a:lnR>
+                    <a:lnT w="9525" cap="flat" cmpd="sng" algn="ctr">
+                      <a:solidFill>
+                        <a:srgbClr val="D5DCE3"/>
+                      </a:solidFill>
+                      <a:prstDash val="solid"/>
+                      <a:round/>
+                      <a:headEnd type="none" w="med" len="med"/>
+                      <a:tailEnd type="none" w="med" len="med"/>
+                    </a:lnT>
+                    <a:lnB w="9525" cap="flat" cmpd="sng" algn="ctr">
+                      <a:solidFill>
+                        <a:srgbClr val="D5DCE3"/>
+                      </a:solidFill>
+                      <a:prstDash val="solid"/>
+                      <a:round/>
+                      <a:headEnd type="none" w="med" len="med"/>
+                      <a:tailEnd type="none" w="med" len="med"/>
+                    </a:lnB>
+                    <a:solidFill>
+                      <a:srgbClr val="FFFFFF"/>
+                    </a:solidFill>
+                  </a:tcPr>
+                </a:tc>
+                <a:tc>
+                  <a:txBody>
+                    <a:bodyPr/>
+                    <a:lstStyle/>
+                    <a:p>
+                      <a:pPr indent="0" marL="0">
+                        <a:buNone/>
+                      </a:pPr>
+                      <a:r>
+                        <a:rPr lang="en-US" sz="1300" dirty="0">
+                          <a:solidFill>
+                            <a:srgbClr val="1F2A36"/>
+                          </a:solidFill>
+                          <a:latin typeface="Calibri" pitchFamily="34" charset="0"/>
+                          <a:ea typeface="Calibri" pitchFamily="34" charset="-122"/>
+                          <a:cs typeface="Calibri" pitchFamily="34" charset="-120"/>
+                        </a:rPr>
+                        <a:t>99.0 %</a:t>
+                      </a:r>
+                      <a:endParaRPr lang="en-US" sz="1300" dirty="0">
+                        <a:latin typeface="Calibri" charset="0"/>
+                        <a:ea typeface="Calibri" charset="0"/>
+                        <a:cs typeface="Calibri" charset="0"/>
+                      </a:endParaRPr>
+                    </a:p>
+                  </a:txBody>
+                  <a:tcPr marL="91440" marR="91440" marT="45720" marB="45720" anchor="ctr">
+                    <a:lnL w="9525" cap="flat" cmpd="sng" algn="ctr">
+                      <a:solidFill>
+                        <a:srgbClr val="D5DCE3"/>
+                      </a:solidFill>
+                      <a:prstDash val="solid"/>
+                      <a:round/>
+                      <a:headEnd type="none" w="med" len="med"/>
+                      <a:tailEnd type="none" w="med" len="med"/>
+                    </a:lnL>
+                    <a:lnR w="9525" cap="flat" cmpd="sng" algn="ctr">
+                      <a:solidFill>
+                        <a:srgbClr val="D5DCE3"/>
+                      </a:solidFill>
+                      <a:prstDash val="solid"/>
+                      <a:round/>
+                      <a:headEnd type="none" w="med" len="med"/>
+                      <a:tailEnd type="none" w="med" len="med"/>
+                    </a:lnR>
+                    <a:lnT w="9525" cap="flat" cmpd="sng" algn="ctr">
+                      <a:solidFill>
+                        <a:srgbClr val="D5DCE3"/>
+                      </a:solidFill>
+                      <a:prstDash val="solid"/>
+                      <a:round/>
+                      <a:headEnd type="none" w="med" len="med"/>
+                      <a:tailEnd type="none" w="med" len="med"/>
+                    </a:lnT>
+                    <a:lnB w="9525" cap="flat" cmpd="sng" algn="ctr">
+                      <a:solidFill>
+                        <a:srgbClr val="D5DCE3"/>
+                      </a:solidFill>
+                      <a:prstDash val="solid"/>
+                      <a:round/>
+                      <a:headEnd type="none" w="med" len="med"/>
+                      <a:tailEnd type="none" w="med" len="med"/>
+                    </a:lnB>
+                    <a:solidFill>
+                      <a:srgbClr val="FFFFFF"/>
+                    </a:solidFill>
+                  </a:tcPr>
+                </a:tc>
+              </a:tr>
+              <a:tr h="411480">
+                <a:tc>
+                  <a:txBody>
+                    <a:bodyPr/>
+                    <a:lstStyle/>
+                    <a:p>
+                      <a:pPr indent="0" marL="0">
+                        <a:buNone/>
+                      </a:pPr>
+                      <a:r>
+                        <a:rPr lang="en-US" sz="1300" dirty="0">
+                          <a:solidFill>
+                            <a:srgbClr val="1F2A36"/>
+                          </a:solidFill>
+                          <a:latin typeface="Calibri" pitchFamily="34" charset="0"/>
+                          <a:ea typeface="Calibri" pitchFamily="34" charset="-122"/>
+                          <a:cs typeface="Calibri" pitchFamily="34" charset="-120"/>
+                        </a:rPr>
+                        <a:t>BSM delivery ratio</a:t>
+                      </a:r>
+                      <a:endParaRPr lang="en-US" sz="1300" dirty="0">
+                        <a:latin typeface="Calibri" charset="0"/>
+                        <a:ea typeface="Calibri" charset="0"/>
+                        <a:cs typeface="Calibri" charset="0"/>
+                      </a:endParaRPr>
+                    </a:p>
+                  </a:txBody>
+                  <a:tcPr marL="91440" marR="91440" marT="45720" marB="45720" anchor="ctr">
+                    <a:lnL w="9525" cap="flat" cmpd="sng" algn="ctr">
+                      <a:solidFill>
+                        <a:srgbClr val="D5DCE3"/>
+                      </a:solidFill>
+                      <a:prstDash val="solid"/>
+                      <a:round/>
+                      <a:headEnd type="none" w="med" len="med"/>
+                      <a:tailEnd type="none" w="med" len="med"/>
+                    </a:lnL>
+                    <a:lnR w="9525" cap="flat" cmpd="sng" algn="ctr">
+                      <a:solidFill>
+                        <a:srgbClr val="D5DCE3"/>
+                      </a:solidFill>
+                      <a:prstDash val="solid"/>
+                      <a:round/>
+                      <a:headEnd type="none" w="med" len="med"/>
+                      <a:tailEnd type="none" w="med" len="med"/>
+                    </a:lnR>
+                    <a:lnT w="9525" cap="flat" cmpd="sng" algn="ctr">
+                      <a:solidFill>
+                        <a:srgbClr val="D5DCE3"/>
+                      </a:solidFill>
+                      <a:prstDash val="solid"/>
+                      <a:round/>
+                      <a:headEnd type="none" w="med" len="med"/>
+                      <a:tailEnd type="none" w="med" len="med"/>
+                    </a:lnT>
+                    <a:lnB w="9525" cap="flat" cmpd="sng" algn="ctr">
+                      <a:solidFill>
+                        <a:srgbClr val="D5DCE3"/>
+                      </a:solidFill>
+                      <a:prstDash val="solid"/>
+                      <a:round/>
+                      <a:headEnd type="none" w="med" len="med"/>
+                      <a:tailEnd type="none" w="med" len="med"/>
+                    </a:lnB>
+                    <a:solidFill>
+                      <a:srgbClr val="FFFFFF"/>
+                    </a:solidFill>
+                  </a:tcPr>
+                </a:tc>
+                <a:tc>
+                  <a:txBody>
+                    <a:bodyPr/>
+                    <a:lstStyle/>
+                    <a:p>
+                      <a:pPr indent="0" marL="0">
+                        <a:buNone/>
+                      </a:pPr>
+                      <a:r>
+                        <a:rPr lang="en-US" sz="1300" dirty="0">
+                          <a:solidFill>
+                            <a:srgbClr val="1F2A36"/>
+                          </a:solidFill>
+                          <a:latin typeface="Calibri" pitchFamily="34" charset="0"/>
+                          <a:ea typeface="Calibri" pitchFamily="34" charset="-122"/>
+                          <a:cs typeface="Calibri" pitchFamily="34" charset="-120"/>
+                        </a:rPr>
+                        <a:t>0.961</a:t>
+                      </a:r>
+                      <a:endParaRPr lang="en-US" sz="1300" dirty="0">
+                        <a:latin typeface="Calibri" charset="0"/>
+                        <a:ea typeface="Calibri" charset="0"/>
+                        <a:cs typeface="Calibri" charset="0"/>
+                      </a:endParaRPr>
+                    </a:p>
+                  </a:txBody>
+                  <a:tcPr marL="91440" marR="91440" marT="45720" marB="45720" anchor="ctr">
+                    <a:lnL w="9525" cap="flat" cmpd="sng" algn="ctr">
+                      <a:solidFill>
+                        <a:srgbClr val="D5DCE3"/>
+                      </a:solidFill>
+                      <a:prstDash val="solid"/>
+                      <a:round/>
+                      <a:headEnd type="none" w="med" len="med"/>
+                      <a:tailEnd type="none" w="med" len="med"/>
+                    </a:lnL>
+                    <a:lnR w="9525" cap="flat" cmpd="sng" algn="ctr">
+                      <a:solidFill>
+                        <a:srgbClr val="D5DCE3"/>
+                      </a:solidFill>
+                      <a:prstDash val="solid"/>
+                      <a:round/>
+                      <a:headEnd type="none" w="med" len="med"/>
+                      <a:tailEnd type="none" w="med" len="med"/>
+                    </a:lnR>
+                    <a:lnT w="9525" cap="flat" cmpd="sng" algn="ctr">
+                      <a:solidFill>
+                        <a:srgbClr val="D5DCE3"/>
+                      </a:solidFill>
+                      <a:prstDash val="solid"/>
+                      <a:round/>
+                      <a:headEnd type="none" w="med" len="med"/>
+                      <a:tailEnd type="none" w="med" len="med"/>
+                    </a:lnT>
+                    <a:lnB w="9525" cap="flat" cmpd="sng" algn="ctr">
+                      <a:solidFill>
+                        <a:srgbClr val="D5DCE3"/>
+                      </a:solidFill>
+                      <a:prstDash val="solid"/>
+                      <a:round/>
+                      <a:headEnd type="none" w="med" len="med"/>
+                      <a:tailEnd type="none" w="med" len="med"/>
+                    </a:lnB>
+                    <a:solidFill>
+                      <a:srgbClr val="FFFFFF"/>
+                    </a:solidFill>
+                  </a:tcPr>
+                </a:tc>
+                <a:tc>
+                  <a:txBody>
+                    <a:bodyPr/>
+                    <a:lstStyle/>
+                    <a:p>
+                      <a:pPr indent="0" marL="0">
+                        <a:buNone/>
+                      </a:pPr>
+                      <a:r>
+                        <a:rPr lang="en-US" sz="1300" dirty="0">
+                          <a:solidFill>
+                            <a:srgbClr val="1F2A36"/>
+                          </a:solidFill>
+                          <a:latin typeface="Calibri" pitchFamily="34" charset="0"/>
+                          <a:ea typeface="Calibri" pitchFamily="34" charset="-122"/>
+                          <a:cs typeface="Calibri" pitchFamily="34" charset="-120"/>
+                        </a:rPr>
+                        <a:t>0.919</a:t>
+                      </a:r>
+                      <a:endParaRPr lang="en-US" sz="1300" dirty="0">
+                        <a:latin typeface="Calibri" charset="0"/>
+                        <a:ea typeface="Calibri" charset="0"/>
+                        <a:cs typeface="Calibri" charset="0"/>
+                      </a:endParaRPr>
+                    </a:p>
+                  </a:txBody>
+                  <a:tcPr marL="91440" marR="91440" marT="45720" marB="45720" anchor="ctr">
+                    <a:lnL w="9525" cap="flat" cmpd="sng" algn="ctr">
+                      <a:solidFill>
+                        <a:srgbClr val="D5DCE3"/>
+                      </a:solidFill>
+                      <a:prstDash val="solid"/>
+                      <a:round/>
+                      <a:headEnd type="none" w="med" len="med"/>
+                      <a:tailEnd type="none" w="med" len="med"/>
+                    </a:lnL>
+                    <a:lnR w="9525" cap="flat" cmpd="sng" algn="ctr">
+                      <a:solidFill>
+                        <a:srgbClr val="D5DCE3"/>
+                      </a:solidFill>
+                      <a:prstDash val="solid"/>
+                      <a:round/>
+                      <a:headEnd type="none" w="med" len="med"/>
+                      <a:tailEnd type="none" w="med" len="med"/>
+                    </a:lnR>
+                    <a:lnT w="9525" cap="flat" cmpd="sng" algn="ctr">
+                      <a:solidFill>
+                        <a:srgbClr val="D5DCE3"/>
+                      </a:solidFill>
+                      <a:prstDash val="solid"/>
+                      <a:round/>
+                      <a:headEnd type="none" w="med" len="med"/>
+                      <a:tailEnd type="none" w="med" len="med"/>
+                    </a:lnT>
+                    <a:lnB w="9525" cap="flat" cmpd="sng" algn="ctr">
+                      <a:solidFill>
+                        <a:srgbClr val="D5DCE3"/>
+                      </a:solidFill>
+                      <a:prstDash val="solid"/>
+                      <a:round/>
+                      <a:headEnd type="none" w="med" len="med"/>
+                      <a:tailEnd type="none" w="med" len="med"/>
+                    </a:lnB>
+                    <a:solidFill>
+                      <a:srgbClr val="FFFFFF"/>
+                    </a:solidFill>
+                  </a:tcPr>
+                </a:tc>
+              </a:tr>
+              <a:tr h="411480">
+                <a:tc>
+                  <a:txBody>
+                    <a:bodyPr/>
+                    <a:lstStyle/>
+                    <a:p>
+                      <a:pPr indent="0" marL="0">
+                        <a:buNone/>
+                      </a:pPr>
+                      <a:r>
+                        <a:rPr lang="en-US" sz="1300" dirty="0">
+                          <a:solidFill>
+                            <a:srgbClr val="1F2A36"/>
+                          </a:solidFill>
+                          <a:latin typeface="Calibri" pitchFamily="34" charset="0"/>
+                          <a:ea typeface="Calibri" pitchFamily="34" charset="-122"/>
+                          <a:cs typeface="Calibri" pitchFamily="34" charset="-120"/>
+                        </a:rPr>
+                        <a:t>Attackers reported / revoked</a:t>
+                      </a:r>
+                      <a:endParaRPr lang="en-US" sz="1300" dirty="0">
+                        <a:latin typeface="Calibri" charset="0"/>
+                        <a:ea typeface="Calibri" charset="0"/>
+                        <a:cs typeface="Calibri" charset="0"/>
+                      </a:endParaRPr>
+                    </a:p>
+                  </a:txBody>
+                  <a:tcPr marL="91440" marR="91440" marT="45720" marB="45720" anchor="ctr">
+                    <a:lnL w="9525" cap="flat" cmpd="sng" algn="ctr">
+                      <a:solidFill>
+                        <a:srgbClr val="D5DCE3"/>
+                      </a:solidFill>
+                      <a:prstDash val="solid"/>
+                      <a:round/>
+                      <a:headEnd type="none" w="med" len="med"/>
+                      <a:tailEnd type="none" w="med" len="med"/>
+                    </a:lnL>
+                    <a:lnR w="9525" cap="flat" cmpd="sng" algn="ctr">
+                      <a:solidFill>
+                        <a:srgbClr val="D5DCE3"/>
+                      </a:solidFill>
+                      <a:prstDash val="solid"/>
+                      <a:round/>
+                      <a:headEnd type="none" w="med" len="med"/>
+                      <a:tailEnd type="none" w="med" len="med"/>
+                    </a:lnR>
+                    <a:lnT w="9525" cap="flat" cmpd="sng" algn="ctr">
+                      <a:solidFill>
+                        <a:srgbClr val="D5DCE3"/>
+                      </a:solidFill>
+                      <a:prstDash val="solid"/>
+                      <a:round/>
+                      <a:headEnd type="none" w="med" len="med"/>
+                      <a:tailEnd type="none" w="med" len="med"/>
+                    </a:lnT>
+                    <a:lnB w="9525" cap="flat" cmpd="sng" algn="ctr">
+                      <a:solidFill>
+                        <a:srgbClr val="D5DCE3"/>
+                      </a:solidFill>
+                      <a:prstDash val="solid"/>
+                      <a:round/>
+                      <a:headEnd type="none" w="med" len="med"/>
+                      <a:tailEnd type="none" w="med" len="med"/>
+                    </a:lnB>
+                    <a:solidFill>
+                      <a:srgbClr val="FFFFFF"/>
+                    </a:solidFill>
+                  </a:tcPr>
+                </a:tc>
+                <a:tc>
+                  <a:txBody>
+                    <a:bodyPr/>
+                    <a:lstStyle/>
+                    <a:p>
+                      <a:pPr indent="0" marL="0">
+                        <a:buNone/>
+                      </a:pPr>
+                      <a:r>
+                        <a:rPr lang="en-US" sz="1300" dirty="0">
+                          <a:solidFill>
+                            <a:srgbClr val="1F2A36"/>
+                          </a:solidFill>
+                          <a:latin typeface="Calibri" pitchFamily="34" charset="0"/>
+                          <a:ea typeface="Calibri" pitchFamily="34" charset="-122"/>
+                          <a:cs typeface="Calibri" pitchFamily="34" charset="-120"/>
+                        </a:rPr>
+                        <a:t>100 / 100 %</a:t>
+                      </a:r>
+                      <a:endParaRPr lang="en-US" sz="1300" dirty="0">
+                        <a:latin typeface="Calibri" charset="0"/>
+                        <a:ea typeface="Calibri" charset="0"/>
+                        <a:cs typeface="Calibri" charset="0"/>
+                      </a:endParaRPr>
+                    </a:p>
+                  </a:txBody>
+                  <a:tcPr marL="91440" marR="91440" marT="45720" marB="45720" anchor="ctr">
+                    <a:lnL w="9525" cap="flat" cmpd="sng" algn="ctr">
+                      <a:solidFill>
+                        <a:srgbClr val="D5DCE3"/>
+                      </a:solidFill>
+                      <a:prstDash val="solid"/>
+                      <a:round/>
+                      <a:headEnd type="none" w="med" len="med"/>
+                      <a:tailEnd type="none" w="med" len="med"/>
+                    </a:lnL>
+                    <a:lnR w="9525" cap="flat" cmpd="sng" algn="ctr">
+                      <a:solidFill>
+                        <a:srgbClr val="D5DCE3"/>
+                      </a:solidFill>
+                      <a:prstDash val="solid"/>
+                      <a:round/>
+                      <a:headEnd type="none" w="med" len="med"/>
+                      <a:tailEnd type="none" w="med" len="med"/>
+                    </a:lnR>
+                    <a:lnT w="9525" cap="flat" cmpd="sng" algn="ctr">
+                      <a:solidFill>
+                        <a:srgbClr val="D5DCE3"/>
+                      </a:solidFill>
+                      <a:prstDash val="solid"/>
+                      <a:round/>
+                      <a:headEnd type="none" w="med" len="med"/>
+                      <a:tailEnd type="none" w="med" len="med"/>
+                    </a:lnT>
+                    <a:lnB w="9525" cap="flat" cmpd="sng" algn="ctr">
+                      <a:solidFill>
+                        <a:srgbClr val="D5DCE3"/>
+                      </a:solidFill>
+                      <a:prstDash val="solid"/>
+                      <a:round/>
+                      <a:headEnd type="none" w="med" len="med"/>
+                      <a:tailEnd type="none" w="med" len="med"/>
+                    </a:lnB>
+                    <a:solidFill>
+                      <a:srgbClr val="FFFFFF"/>
+                    </a:solidFill>
+                  </a:tcPr>
+                </a:tc>
+                <a:tc>
+                  <a:txBody>
+                    <a:bodyPr/>
+                    <a:lstStyle/>
+                    <a:p>
+                      <a:pPr indent="0" marL="0">
+                        <a:buNone/>
+                      </a:pPr>
+                      <a:r>
+                        <a:rPr lang="en-US" sz="1300" dirty="0">
+                          <a:solidFill>
+                            <a:srgbClr val="1F2A36"/>
+                          </a:solidFill>
+                          <a:latin typeface="Calibri" pitchFamily="34" charset="0"/>
+                          <a:ea typeface="Calibri" pitchFamily="34" charset="-122"/>
+                          <a:cs typeface="Calibri" pitchFamily="34" charset="-120"/>
+                        </a:rPr>
+                        <a:t>100 / 100 %</a:t>
+                      </a:r>
+                      <a:endParaRPr lang="en-US" sz="1300" dirty="0">
+                        <a:latin typeface="Calibri" charset="0"/>
+                        <a:ea typeface="Calibri" charset="0"/>
+                        <a:cs typeface="Calibri" charset="0"/>
+                      </a:endParaRPr>
+                    </a:p>
+                  </a:txBody>
+                  <a:tcPr marL="91440" marR="91440" marT="45720" marB="45720" anchor="ctr">
+                    <a:lnL w="9525" cap="flat" cmpd="sng" algn="ctr">
+                      <a:solidFill>
+                        <a:srgbClr val="D5DCE3"/>
+                      </a:solidFill>
+                      <a:prstDash val="solid"/>
+                      <a:round/>
+                      <a:headEnd type="none" w="med" len="med"/>
+                      <a:tailEnd type="none" w="med" len="med"/>
+                    </a:lnL>
+                    <a:lnR w="9525" cap="flat" cmpd="sng" algn="ctr">
+                      <a:solidFill>
+                        <a:srgbClr val="D5DCE3"/>
+                      </a:solidFill>
+                      <a:prstDash val="solid"/>
+                      <a:round/>
+                      <a:headEnd type="none" w="med" len="med"/>
+                      <a:tailEnd type="none" w="med" len="med"/>
+                    </a:lnR>
+                    <a:lnT w="9525" cap="flat" cmpd="sng" algn="ctr">
+                      <a:solidFill>
+                        <a:srgbClr val="D5DCE3"/>
+                      </a:solidFill>
+                      <a:prstDash val="solid"/>
+                      <a:round/>
+                      <a:headEnd type="none" w="med" len="med"/>
+                      <a:tailEnd type="none" w="med" len="med"/>
+                    </a:lnT>
+                    <a:lnB w="9525" cap="flat" cmpd="sng" algn="ctr">
+                      <a:solidFill>
+                        <a:srgbClr val="D5DCE3"/>
+                      </a:solidFill>
+                      <a:prstDash val="solid"/>
+                      <a:round/>
+                      <a:headEnd type="none" w="med" len="med"/>
+                      <a:tailEnd type="none" w="med" len="med"/>
+                    </a:lnB>
+                    <a:solidFill>
+                      <a:srgbClr val="FFFFFF"/>
+                    </a:solidFill>
+                  </a:tcPr>
+                </a:tc>
+              </a:tr>
+            </a:tbl>
+          </a:graphicData>
+        </a:graphic>
+      </p:graphicFrame>
+      <p:sp>
+        <p:nvSpPr>
+          <p:cNvPr id="5" name="Text 1"/>
+          <p:cNvSpPr txBox="1"/>
+          <p:nvPr/>
+        </p:nvSpPr>
+        <p:spPr>
+          <a:xfrm>
+            <a:off x="5669280" y="4069080"/>
+            <a:ext cx="5943600" cy="1828800"/>
+          </a:xfrm>
+          <a:prstGeom prst="rect">
+            <a:avLst/>
+          </a:prstGeom>
+          <a:noFill/>
+          <a:ln/>
+        </p:spPr>
+        <p:txBody>
+          <a:bodyPr wrap="square" lIns="0" tIns="0" rIns="0" bIns="0" rtlCol="0" anchor="t"/>
+          <a:lstStyle/>
+          <a:p>
+            <a:pPr indent="0" marL="0">
+              <a:spcAft>
+                <a:spcPts val="800"/>
+              </a:spcAft>
+              <a:buNone/>
+            </a:pPr>
+            <a:r>
+              <a:rPr lang="en-US" sz="1400" dirty="0">
+                <a:solidFill>
+                  <a:srgbClr val="1F2A36"/>
+                </a:solidFill>
+              </a:rPr>
+              <a:t>All 6 attack types (100 vehicles): 100 % reported, 100 % revoked, 0 honest vehicles revoked.</a:t>
+            </a:r>
+            <a:endParaRPr lang="en-US" sz="1400" dirty="0"/>
+          </a:p>
+          <a:p>
+            <a:pPr indent="0" marL="0">
+              <a:spcAft>
+                <a:spcPts val="800"/>
+              </a:spcAft>
+              <a:buNone/>
+            </a:pPr>
+            <a:r>
+              <a:rPr lang="en-US" sz="1400" dirty="0">
+                <a:solidFill>
+                  <a:srgbClr val="1F2A36"/>
+                </a:solidFill>
+              </a:rPr>
+              <a:t>New on the real map: hairpins and U-turns make the heading check flag a few honest cars; K-of-W reporting and the two-RSU rule stop every one of them before revocation.</a:t>
+            </a:r>
+            <a:endParaRPr lang="en-US" sz="1400" dirty="0"/>
+          </a:p>
+        </p:txBody>
+      </p:sp>
+      <p:sp>
+        <p:nvSpPr>
+          <p:cNvPr id="6" name="Text 2"/>
+          <p:cNvSpPr txBox="1"/>
+          <p:nvPr/>
+        </p:nvSpPr>
+        <p:spPr>
+          <a:xfrm>
+            <a:off x="548640" y="6263640"/>
+            <a:ext cx="10515600" cy="320040"/>
+          </a:xfrm>
+          <a:prstGeom prst="rect">
+            <a:avLst/>
+          </a:prstGeom>
+          <a:noFill/>
+          <a:ln/>
+        </p:spPr>
+        <p:txBody>
+          <a:bodyPr wrap="square" lIns="0" tIns="0" rIns="0" bIns="0" rtlCol="0" anchor="ctr"/>
+          <a:lstStyle/>
+          <a:p>
+            <a:pPr indent="0" marL="0">
+              <a:buNone/>
+            </a:pPr>
+            <a:r>
+              <a:rPr lang="en-US" sz="1100" i="1" dirty="0">
+                <a:solidFill>
+                  <a:srgbClr val="5B6B7A"/>
+                </a:solidFill>
+              </a:rPr>
+              <a:t>1.9 × 2.3 km, 437 junctions, 27 RSUs. OSM data © OpenStreetMap contributors via the MoST scenario (Codecá &amp; Härri, 2017).</a:t>
+            </a:r>
+            <a:endParaRPr lang="en-US" sz="1100" dirty="0"/>
+          </a:p>
+        </p:txBody>
+      </p:sp>
+      <p:sp>
+        <p:nvSpPr>
+          <p:cNvPr id="25" name="Slide Number Placeholder 0"/>
+          <p:cNvSpPr>
+            <a:spLocks noGrp="1"/>
+          </p:cNvSpPr>
+          <p:nvPr>
+            <p:ph type="sldNum" sz="quarter" idx="4294967295"/>
+          </p:nvPr>
+        </p:nvSpPr>
+        <p:spPr>
+          <a:xfrm>
+            <a:off x="11247120" y="6400800"/>
+            <a:ext cx="548640" cy="274320"/>
+          </a:xfrm>
+          <a:prstGeom prst="rect">
+            <a:avLst/>
+          </a:prstGeom>
+          <a:extLst>
+            <a:ext uri="{C572A759-6A51-4108-AA02-DFA0A04FC94B}">
+              <ma14:wrappingTextBoxFlag xmlns:ma14="http://schemas.microsoft.com/office/mac/drawingml/2011/main" val="0"/>
+            </a:ext>
+          </a:extLst>
+        </p:spPr>
+        <p:txBody>
+          <a:bodyPr/>
+          <a:lstStyle>
+            <a:lvl1pPr>
+              <a:defRPr sz="1000">
+                <a:solidFill>
+                  <a:srgbClr val="5B6B7A"/>
+                </a:solidFill>
+                <a:latin typeface="Calibri"/>
+                <a:ea typeface="Calibri"/>
+                <a:cs typeface="Calibri"/>
+              </a:defRPr>
+            </a:lvl1pPr>
+          </a:lstStyle>
+          <a:p>
+            <a:pPr algn="l"/>
+            <a:fld id="{F7021451-1387-4CA6-816F-3879F97B5CBC}" type="slidenum">
+              <a:rPr b="0" lang="en-US"/>
+              <a:t>12</a:t>
+            </a:fld>
+            <a:endParaRPr lang="en-US"/>
+          </a:p>
+        </p:txBody>
+      </p:sp>
+    </p:spTree>
+  </p:cSld>
+  <p:clrMapOvr>
+    <a:masterClrMapping/>
+  </p:clrMapOvr>
+</p:sld>
+</file>
+
+<file path=ppt/slides/slide13.xml><?xml version="1.0" encoding="utf-8"?>
+<p:sld xmlns:a="http://schemas.openxmlformats.org/drawingml/2006/main" xmlns:r="http://schemas.openxmlformats.org/officeDocument/2006/relationships" xmlns:p="http://schemas.openxmlformats.org/presentationml/2006/main">
+  <p:cSld name="Slide 13">
+    <p:spTree>
+      <p:nvGrpSpPr>
+        <p:cNvPr id="1" name=""/>
+        <p:cNvGrpSpPr/>
+        <p:nvPr/>
+      </p:nvGrpSpPr>
+      <p:grpSpPr>
+        <a:xfrm>
+          <a:off x="0" y="0"/>
+          <a:ext cx="0" cy="0"/>
+          <a:chOff x="0" y="0"/>
+          <a:chExt cx="0" cy="0"/>
+        </a:xfrm>
+      </p:grpSpPr>
+      <p:sp>
+        <p:nvSpPr>
+          <p:cNvPr id="2" name="Text 0"/>
+          <p:cNvSpPr/>
+          <p:nvPr>
+            <p:ph idx="100" type="title" hasCustomPrompt="1"/>
+          </p:nvPr>
+        </p:nvSpPr>
+        <p:spPr>
+          <a:xfrm>
+            <a:off x="548640" y="320040"/>
+            <a:ext cx="11064240" cy="822960"/>
+          </a:xfrm>
+          <a:prstGeom prst="rect">
+            <a:avLst/>
+          </a:prstGeom>
+          <a:noFill/>
+          <a:ln/>
+        </p:spPr>
+        <p:txBody>
+          <a:bodyPr wrap="square" lIns="0" tIns="0" rIns="0" bIns="0" rtlCol="0" anchor="ctr"/>
+          <a:lstStyle/>
+          <a:p>
+            <a:pPr indent="0" marL="0">
+              <a:buNone/>
+            </a:pPr>
+            <a:r>
+              <a:rPr lang="en-US" sz="3200" b="1" dirty="0">
+                <a:solidFill>
+                  <a:srgbClr val="1F2A36"/>
+                </a:solidFill>
+                <a:latin typeface="Cambria" pitchFamily="34" charset="0"/>
+                <a:ea typeface="Cambria" pitchFamily="34" charset="-122"/>
+                <a:cs typeface="Cambria" pitchFamily="34" charset="-120"/>
+              </a:rPr>
               <a:t>What we fixed to get trustworthy numbers</a:t>
             </a:r>
             <a:endParaRPr lang="en-US" sz="3200" dirty="0"/>
@@ -7287,7 +8862,7 @@
       </p:sp>
       <p:graphicFrame>
         <p:nvGraphicFramePr>
-          <p:cNvPr id="13" name="Table 0"/>
+          <p:cNvPr id="14" name="Table 0"/>
           <p:cNvGraphicFramePr>
             <a:graphicFrameLocks noGrp="1"/>
           </p:cNvGraphicFramePr>
@@ -8836,7 +10411,7 @@
             <a:pPr algn="l"/>
             <a:fld id="{F7021451-1387-4CA6-816F-3879F97B5CBC}" type="slidenum">
               <a:rPr b="0" lang="en-US"/>
-              <a:t>12</a:t>
+              <a:t>13</a:t>
             </a:fld>
             <a:endParaRPr lang="en-US"/>
           </a:p>
@@ -8850,9 +10425,9 @@
 </p:sld>
 </file>
 
-<file path=ppt/slides/slide13.xml><?xml version="1.0" encoding="utf-8"?>
+<file path=ppt/slides/slide14.xml><?xml version="1.0" encoding="utf-8"?>
 <p:sld xmlns:a="http://schemas.openxmlformats.org/drawingml/2006/main" xmlns:r="http://schemas.openxmlformats.org/officeDocument/2006/relationships" xmlns:p="http://schemas.openxmlformats.org/presentationml/2006/main">
-  <p:cSld name="Slide 13">
+  <p:cSld name="Slide 14">
     <p:spTree>
       <p:nvGrpSpPr>
         <p:cNvPr id="1" name=""/>
@@ -9308,7 +10883,7 @@
             <a:pPr algn="l"/>
             <a:fld id="{F7021451-1387-4CA6-816F-3879F97B5CBC}" type="slidenum">
               <a:rPr b="0" lang="en-US"/>
-              <a:t>13</a:t>
+              <a:t>14</a:t>
             </a:fld>
             <a:endParaRPr lang="en-US"/>
           </a:p>
@@ -9322,9 +10897,9 @@
 </p:sld>
 </file>
 
-<file path=ppt/slides/slide14.xml><?xml version="1.0" encoding="utf-8"?>
+<file path=ppt/slides/slide15.xml><?xml version="1.0" encoding="utf-8"?>
 <p:sld xmlns:a="http://schemas.openxmlformats.org/drawingml/2006/main" xmlns:r="http://schemas.openxmlformats.org/officeDocument/2006/relationships" xmlns:p="http://schemas.openxmlformats.org/presentationml/2006/main">
-  <p:cSld name="Slide 14">
+  <p:cSld name="Slide 15">
     <p:spTree>
       <p:nvGrpSpPr>
         <p:cNvPr id="1" name=""/>

</xml_diff>

<commit_message>
Final results on ns-3 and real Hyperledger Fabric
45 runs (three schemes at 30/60/90 vehicles, six attacks), ns-3 802.11p
and Fabric 2.5.9 with TA + 9 RSU identities, 0 ledger errors.
Fabric commit ~350 ms median / ~550 ms p95; auth 1.6 ms; ~40 % of
handovers accepted via PREAUTH before the ledger record was visible;
every attacker reported, 0 honest vehicles revoked.

Results page, mechanism guide and deck (new slide 7) updated.

Co-Authored-By: Claude Opus 5.5 <noreply@anthropic.com>
Claude-Session: https://claude.ai/code/session_01RhJ9dStThAs6ZjKvaWLus4
</commit_message>
<xml_diff>
--- a/docs/presentation/vanet_results.pptx
+++ b/docs/presentation/vanet_results.pptx
@@ -20,9 +20,10 @@
     <p:sldId id="268" r:id="rId14"/>
     <p:sldId id="269" r:id="rId15"/>
     <p:sldId id="270" r:id="rId16"/>
+    <p:sldId id="271" r:id="rId17"/>
   </p:sldIdLst>
   <p:notesMasterIdLst>
-    <p:notesMasterId r:id="rId17"/>
+    <p:notesMasterId r:id="rId18"/>
   </p:notesMasterIdLst>
   <p:sldSz cx="12192000" cy="6858000"/>
   <p:notesSz cx="6858000" cy="12192000"/>
@@ -3896,6 +3897,94 @@
 </p:notes>
 </file>
 
+<file path=ppt/notesSlides/notesSlide16.xml><?xml version="1.0" encoding="utf-8"?>
+<p:notes xmlns:a="http://schemas.openxmlformats.org/drawingml/2006/main" xmlns:r="http://schemas.openxmlformats.org/officeDocument/2006/relationships" xmlns:p="http://schemas.openxmlformats.org/presentationml/2006/main">
+  <p:cSld>
+    <p:spTree>
+      <p:nvGrpSpPr>
+        <p:cNvPr id="1" name=""/>
+        <p:cNvGrpSpPr/>
+        <p:nvPr/>
+      </p:nvGrpSpPr>
+      <p:grpSpPr>
+        <a:xfrm>
+          <a:off x="0" y="0"/>
+          <a:ext cx="0" cy="0"/>
+          <a:chOff x="0" y="0"/>
+          <a:chExt cx="0" cy="0"/>
+        </a:xfrm>
+      </p:grpSpPr>
+      <p:sp>
+        <p:nvSpPr>
+          <p:cNvPr id="2" name="Slide Image Placeholder 1"/>
+          <p:cNvSpPr>
+            <a:spLocks noGrp="1" noRot="1" noChangeAspect="1"/>
+          </p:cNvSpPr>
+          <p:nvPr>
+            <p:ph type="sldImg"/>
+          </p:nvPr>
+        </p:nvSpPr>
+        <p:spPr/>
+      </p:sp>
+      <p:sp>
+        <p:nvSpPr>
+          <p:cNvPr id="3" name="Notes Placeholder 2"/>
+          <p:cNvSpPr>
+            <a:spLocks noGrp="1"/>
+          </p:cNvSpPr>
+          <p:nvPr>
+            <p:ph type="body" idx="1"/>
+          </p:nvPr>
+        </p:nvSpPr>
+        <p:spPr/>
+        <p:txBody>
+          <a:bodyPr/>
+          <a:lstStyle/>
+          <a:p>
+            <a:r>
+              <a:rPr lang="en-US" dirty="0"/>
+              <a:t/>
+            </a:r>
+            <a:endParaRPr lang="en-US" dirty="0"/>
+          </a:p>
+        </p:txBody>
+      </p:sp>
+      <p:sp>
+        <p:nvSpPr>
+          <p:cNvPr id="4" name="Slide Number Placeholder 3"/>
+          <p:cNvSpPr>
+            <a:spLocks noGrp="1"/>
+          </p:cNvSpPr>
+          <p:nvPr>
+            <p:ph type="sldNum" sz="quarter" idx="10"/>
+          </p:nvPr>
+        </p:nvSpPr>
+        <p:spPr/>
+        <p:txBody>
+          <a:bodyPr/>
+          <a:lstStyle/>
+          <a:p>
+            <a:fld id="{F7021451-1387-4CA6-816F-3879F97B5CBC}" type="slidenum">
+              <a:rPr lang="en-US"/>
+              <a:t>16</a:t>
+            </a:fld>
+            <a:endParaRPr lang="en-US"/>
+          </a:p>
+        </p:txBody>
+      </p:sp>
+    </p:spTree>
+    <p:extLst>
+      <p:ext uri="{BB962C8B-B14F-4D97-AF65-F5344CB8AC3E}">
+        <p14:creationId xmlns:p14="http://schemas.microsoft.com/office/powerpoint/2010/main" val="1024086991"/>
+      </p:ext>
+    </p:extLst>
+  </p:cSld>
+  <p:clrMapOvr>
+    <a:masterClrMapping/>
+  </p:clrMapOvr>
+</p:notes>
+</file>
+
 <file path=ppt/notesSlides/notesSlide2.xml><?xml version="1.0" encoding="utf-8"?>
 <p:notes xmlns:a="http://schemas.openxmlformats.org/drawingml/2006/main" xmlns:r="http://schemas.openxmlformats.org/officeDocument/2006/relationships" xmlns:p="http://schemas.openxmlformats.org/presentationml/2006/main">
   <p:cSld>
@@ -5319,6 +5408,188 @@
                 <a:ea typeface="Cambria" pitchFamily="34" charset="-122"/>
                 <a:cs typeface="Cambria" pitchFamily="34" charset="-120"/>
               </a:rPr>
+              <a:t>Every attack type is caught within about a second</a:t>
+            </a:r>
+            <a:endParaRPr lang="en-US" sz="3200" dirty="0"/>
+          </a:p>
+        </p:txBody>
+      </p:sp>
+      <p:graphicFrame>
+        <p:nvGraphicFramePr>
+          <p:cNvPr id="3" name="Chart 0" descr=""/>
+          <p:cNvGraphicFramePr/>
+          <p:nvPr/>
+        </p:nvGraphicFramePr>
+        <p:xfrm>
+          <a:off x="548640" y="1325880"/>
+          <a:ext cx="5669280" cy="4754880"/>
+        </p:xfrm>
+        <a:graphic xmlns:a="http://schemas.openxmlformats.org/drawingml/2006/main">
+          <a:graphicData uri="http://schemas.openxmlformats.org/drawingml/2006/chart">
+            <c:chart xmlns:c="http://schemas.openxmlformats.org/drawingml/2006/chart" r:id="rId1"/>
+          </a:graphicData>
+        </a:graphic>
+      </p:graphicFrame>
+      <p:graphicFrame>
+        <p:nvGraphicFramePr>
+          <p:cNvPr id="4" name="Chart 1" descr=""/>
+          <p:cNvGraphicFramePr/>
+          <p:nvPr/>
+        </p:nvGraphicFramePr>
+        <p:xfrm>
+          <a:off x="6400800" y="1325880"/>
+          <a:ext cx="5212080" cy="4754880"/>
+        </p:xfrm>
+        <a:graphic xmlns:a="http://schemas.openxmlformats.org/drawingml/2006/main">
+          <a:graphicData uri="http://schemas.openxmlformats.org/drawingml/2006/chart">
+            <c:chart xmlns:c="http://schemas.openxmlformats.org/drawingml/2006/chart" r:id="rId2"/>
+          </a:graphicData>
+        </a:graphic>
+      </p:graphicFrame>
+      <p:sp>
+        <p:nvSpPr>
+          <p:cNvPr id="5" name="Text 1"/>
+          <p:cNvSpPr txBox="1"/>
+          <p:nvPr/>
+        </p:nvSpPr>
+        <p:spPr>
+          <a:xfrm>
+            <a:off x="548640" y="6263640"/>
+            <a:ext cx="10515600" cy="320040"/>
+          </a:xfrm>
+          <a:prstGeom prst="rect">
+            <a:avLst/>
+          </a:prstGeom>
+          <a:noFill/>
+          <a:ln/>
+        </p:spPr>
+        <p:txBody>
+          <a:bodyPr wrap="square" lIns="0" tIns="0" rIns="0" bIns="0" rtlCol="0" anchor="ctr"/>
+          <a:lstStyle/>
+          <a:p>
+            <a:pPr indent="0" marL="0">
+              <a:buNone/>
+            </a:pPr>
+            <a:r>
+              <a:rPr lang="en-US" sz="1100" i="1" dirty="0">
+                <a:solidFill>
+                  <a:srgbClr val="5B6B7A"/>
+                </a:solidFill>
+              </a:rPr>
+              <a:t>const_pos is the hard case: a constant offset is only implausible once it crosses the radio range, and a car seen by one RSU only is reported but not revoked.</a:t>
+            </a:r>
+            <a:endParaRPr lang="en-US" sz="1100" dirty="0"/>
+          </a:p>
+        </p:txBody>
+      </p:sp>
+      <p:sp>
+        <p:nvSpPr>
+          <p:cNvPr id="25" name="Slide Number Placeholder 0"/>
+          <p:cNvSpPr>
+            <a:spLocks noGrp="1"/>
+          </p:cNvSpPr>
+          <p:nvPr>
+            <p:ph type="sldNum" sz="quarter" idx="4294967295"/>
+          </p:nvPr>
+        </p:nvSpPr>
+        <p:spPr>
+          <a:xfrm>
+            <a:off x="11247120" y="6400800"/>
+            <a:ext cx="548640" cy="274320"/>
+          </a:xfrm>
+          <a:prstGeom prst="rect">
+            <a:avLst/>
+          </a:prstGeom>
+          <a:extLst>
+            <a:ext uri="{C572A759-6A51-4108-AA02-DFA0A04FC94B}">
+              <ma14:wrappingTextBoxFlag xmlns:ma14="http://schemas.microsoft.com/office/mac/drawingml/2011/main" val="0"/>
+            </a:ext>
+          </a:extLst>
+        </p:spPr>
+        <p:txBody>
+          <a:bodyPr/>
+          <a:lstStyle>
+            <a:lvl1pPr>
+              <a:defRPr sz="1000">
+                <a:solidFill>
+                  <a:srgbClr val="5B6B7A"/>
+                </a:solidFill>
+                <a:latin typeface="Calibri"/>
+                <a:ea typeface="Calibri"/>
+                <a:cs typeface="Calibri"/>
+              </a:defRPr>
+            </a:lvl1pPr>
+          </a:lstStyle>
+          <a:p>
+            <a:pPr algn="l"/>
+            <a:fld id="{F7021451-1387-4CA6-816F-3879F97B5CBC}" type="slidenum">
+              <a:rPr b="0" lang="en-US"/>
+              <a:t>10</a:t>
+            </a:fld>
+            <a:endParaRPr lang="en-US"/>
+          </a:p>
+        </p:txBody>
+      </p:sp>
+    </p:spTree>
+  </p:cSld>
+  <p:clrMapOvr>
+    <a:masterClrMapping/>
+  </p:clrMapOvr>
+</p:sld>
+</file>
+
+<file path=ppt/slides/slide11.xml><?xml version="1.0" encoding="utf-8"?>
+<p:sld xmlns:a="http://schemas.openxmlformats.org/drawingml/2006/main" xmlns:r="http://schemas.openxmlformats.org/officeDocument/2006/relationships" xmlns:p="http://schemas.openxmlformats.org/presentationml/2006/main">
+  <p:cSld name="Slide 11">
+    <p:spTree>
+      <p:nvGrpSpPr>
+        <p:cNvPr id="1" name=""/>
+        <p:cNvGrpSpPr/>
+        <p:nvPr/>
+      </p:nvGrpSpPr>
+      <p:grpSpPr>
+        <a:xfrm>
+          <a:off x="0" y="0"/>
+          <a:ext cx="0" cy="0"/>
+          <a:chOff x="0" y="0"/>
+          <a:chExt cx="0" cy="0"/>
+        </a:xfrm>
+      </p:grpSpPr>
+      <p:sp>
+        <p:nvSpPr>
+          <p:cNvPr id="2" name="Text 0"/>
+          <p:cNvSpPr/>
+          <p:nvPr>
+            <p:ph idx="100" type="title" hasCustomPrompt="1"/>
+          </p:nvPr>
+        </p:nvSpPr>
+        <p:spPr>
+          <a:xfrm>
+            <a:off x="548640" y="320040"/>
+            <a:ext cx="11064240" cy="822960"/>
+          </a:xfrm>
+          <a:prstGeom prst="rect">
+            <a:avLst/>
+          </a:prstGeom>
+          <a:noFill/>
+          <a:ln/>
+        </p:spPr>
+        <p:txBody>
+          <a:bodyPr wrap="square" lIns="0" tIns="0" rIns="0" bIns="0" rtlCol="0" anchor="ctr"/>
+          <a:lstStyle/>
+          <a:p>
+            <a:pPr indent="0" marL="0">
+              <a:buNone/>
+            </a:pPr>
+            <a:r>
+              <a:rPr lang="en-US" sz="3200" b="1" dirty="0">
+                <a:solidFill>
+                  <a:srgbClr val="1F2A36"/>
+                </a:solidFill>
+                <a:latin typeface="Cambria" pitchFamily="34" charset="0"/>
+                <a:ea typeface="Cambria" pitchFamily="34" charset="-122"/>
+                <a:cs typeface="Cambria" pitchFamily="34" charset="-120"/>
+              </a:rPr>
               <a:t>How many RSUs must agree? Speed against trust</a:t>
             </a:r>
             <a:endParaRPr lang="en-US" sz="3200" dirty="0"/>
@@ -5435,7 +5706,7 @@
             <a:pPr algn="l"/>
             <a:fld id="{F7021451-1387-4CA6-816F-3879F97B5CBC}" type="slidenum">
               <a:rPr b="0" lang="en-US"/>
-              <a:t>10</a:t>
+              <a:t>11</a:t>
             </a:fld>
             <a:endParaRPr lang="en-US"/>
           </a:p>
@@ -5449,9 +5720,9 @@
 </p:sld>
 </file>
 
-<file path=ppt/slides/slide11.xml><?xml version="1.0" encoding="utf-8"?>
+<file path=ppt/slides/slide12.xml><?xml version="1.0" encoding="utf-8"?>
 <p:sld xmlns:a="http://schemas.openxmlformats.org/drawingml/2006/main" xmlns:r="http://schemas.openxmlformats.org/officeDocument/2006/relationships" xmlns:p="http://schemas.openxmlformats.org/presentationml/2006/main">
-  <p:cSld name="Slide 11">
+  <p:cSld name="Slide 12">
     <p:spTree>
       <p:nvGrpSpPr>
         <p:cNvPr id="1" name=""/>
@@ -5525,7 +5796,7 @@
       </p:graphicFrame>
       <p:graphicFrame>
         <p:nvGraphicFramePr>
-          <p:cNvPr id="12" name="Table 0"/>
+          <p:cNvPr id="13" name="Table 0"/>
           <p:cNvGraphicFramePr>
             <a:graphicFrameLocks noGrp="1"/>
           </p:cNvGraphicFramePr>
@@ -7302,7 +7573,7 @@
             <a:pPr algn="l"/>
             <a:fld id="{F7021451-1387-4CA6-816F-3879F97B5CBC}" type="slidenum">
               <a:rPr b="0" lang="en-US"/>
-              <a:t>11</a:t>
+              <a:t>12</a:t>
             </a:fld>
             <a:endParaRPr lang="en-US"/>
           </a:p>
@@ -7316,9 +7587,9 @@
 </p:sld>
 </file>
 
-<file path=ppt/slides/slide12.xml><?xml version="1.0" encoding="utf-8"?>
+<file path=ppt/slides/slide13.xml><?xml version="1.0" encoding="utf-8"?>
 <p:sld xmlns:a="http://schemas.openxmlformats.org/drawingml/2006/main" xmlns:r="http://schemas.openxmlformats.org/officeDocument/2006/relationships" xmlns:p="http://schemas.openxmlformats.org/presentationml/2006/main">
-  <p:cSld name="Slide 12">
+  <p:cSld name="Slide 13">
     <p:spTree>
       <p:nvGrpSpPr>
         <p:cNvPr id="1" name=""/>
@@ -7400,7 +7671,7 @@
       </p:pic>
       <p:graphicFrame>
         <p:nvGraphicFramePr>
-          <p:cNvPr id="13" name="Table 0"/>
+          <p:cNvPr id="14" name="Table 0"/>
           <p:cNvGraphicFramePr>
             <a:graphicFrameLocks noGrp="1"/>
           </p:cNvGraphicFramePr>
@@ -8788,7 +9059,7 @@
             <a:pPr algn="l"/>
             <a:fld id="{F7021451-1387-4CA6-816F-3879F97B5CBC}" type="slidenum">
               <a:rPr b="0" lang="en-US"/>
-              <a:t>12</a:t>
+              <a:t>13</a:t>
             </a:fld>
             <a:endParaRPr lang="en-US"/>
           </a:p>
@@ -8802,9 +9073,9 @@
 </p:sld>
 </file>
 
-<file path=ppt/slides/slide13.xml><?xml version="1.0" encoding="utf-8"?>
+<file path=ppt/slides/slide14.xml><?xml version="1.0" encoding="utf-8"?>
 <p:sld xmlns:a="http://schemas.openxmlformats.org/drawingml/2006/main" xmlns:r="http://schemas.openxmlformats.org/officeDocument/2006/relationships" xmlns:p="http://schemas.openxmlformats.org/presentationml/2006/main">
-  <p:cSld name="Slide 13">
+  <p:cSld name="Slide 14">
     <p:spTree>
       <p:nvGrpSpPr>
         <p:cNvPr id="1" name=""/>
@@ -8862,7 +9133,7 @@
       </p:sp>
       <p:graphicFrame>
         <p:nvGraphicFramePr>
-          <p:cNvPr id="14" name="Table 0"/>
+          <p:cNvPr id="15" name="Table 0"/>
           <p:cNvGraphicFramePr>
             <a:graphicFrameLocks noGrp="1"/>
           </p:cNvGraphicFramePr>
@@ -10411,478 +10682,6 @@
             <a:pPr algn="l"/>
             <a:fld id="{F7021451-1387-4CA6-816F-3879F97B5CBC}" type="slidenum">
               <a:rPr b="0" lang="en-US"/>
-              <a:t>13</a:t>
-            </a:fld>
-            <a:endParaRPr lang="en-US"/>
-          </a:p>
-        </p:txBody>
-      </p:sp>
-    </p:spTree>
-  </p:cSld>
-  <p:clrMapOvr>
-    <a:masterClrMapping/>
-  </p:clrMapOvr>
-</p:sld>
-</file>
-
-<file path=ppt/slides/slide14.xml><?xml version="1.0" encoding="utf-8"?>
-<p:sld xmlns:a="http://schemas.openxmlformats.org/drawingml/2006/main" xmlns:r="http://schemas.openxmlformats.org/officeDocument/2006/relationships" xmlns:p="http://schemas.openxmlformats.org/presentationml/2006/main">
-  <p:cSld name="Slide 14">
-    <p:spTree>
-      <p:nvGrpSpPr>
-        <p:cNvPr id="1" name=""/>
-        <p:cNvGrpSpPr/>
-        <p:nvPr/>
-      </p:nvGrpSpPr>
-      <p:grpSpPr>
-        <a:xfrm>
-          <a:off x="0" y="0"/>
-          <a:ext cx="0" cy="0"/>
-          <a:chOff x="0" y="0"/>
-          <a:chExt cx="0" cy="0"/>
-        </a:xfrm>
-      </p:grpSpPr>
-      <p:sp>
-        <p:nvSpPr>
-          <p:cNvPr id="2" name="Text 0"/>
-          <p:cNvSpPr/>
-          <p:nvPr>
-            <p:ph idx="100" type="title" hasCustomPrompt="1"/>
-          </p:nvPr>
-        </p:nvSpPr>
-        <p:spPr>
-          <a:xfrm>
-            <a:off x="548640" y="320040"/>
-            <a:ext cx="11064240" cy="822960"/>
-          </a:xfrm>
-          <a:prstGeom prst="rect">
-            <a:avLst/>
-          </a:prstGeom>
-          <a:noFill/>
-          <a:ln/>
-        </p:spPr>
-        <p:txBody>
-          <a:bodyPr wrap="square" lIns="0" tIns="0" rIns="0" bIns="0" rtlCol="0" anchor="ctr"/>
-          <a:lstStyle/>
-          <a:p>
-            <a:pPr indent="0" marL="0">
-              <a:buNone/>
-            </a:pPr>
-            <a:r>
-              <a:rPr lang="en-US" sz="3200" b="1" dirty="0">
-                <a:solidFill>
-                  <a:srgbClr val="1F2A36"/>
-                </a:solidFill>
-                <a:latin typeface="Cambria" pitchFamily="34" charset="0"/>
-                <a:ea typeface="Cambria" pitchFamily="34" charset="-122"/>
-                <a:cs typeface="Cambria" pitchFamily="34" charset="-120"/>
-              </a:rPr>
-              <a:t>Limitations and next steps</a:t>
-            </a:r>
-            <a:endParaRPr lang="en-US" sz="3200" dirty="0"/>
-          </a:p>
-        </p:txBody>
-      </p:sp>
-      <p:sp>
-        <p:nvSpPr>
-          <p:cNvPr id="3" name="Shape 1"/>
-          <p:cNvSpPr/>
-          <p:nvPr/>
-        </p:nvSpPr>
-        <p:spPr>
-          <a:xfrm>
-            <a:off x="548640" y="1417320"/>
-            <a:ext cx="5394960" cy="3566160"/>
-          </a:xfrm>
-          <a:prstGeom prst="roundRect">
-            <a:avLst>
-              <a:gd name="adj" fmla="val 2051"/>
-            </a:avLst>
-          </a:prstGeom>
-          <a:solidFill>
-            <a:srgbClr val="EEF2F5"/>
-          </a:solidFill>
-          <a:ln w="12700">
-            <a:solidFill>
-              <a:srgbClr val="EEF2F5"/>
-            </a:solidFill>
-            <a:prstDash val="solid"/>
-          </a:ln>
-        </p:spPr>
-      </p:sp>
-      <p:sp>
-        <p:nvSpPr>
-          <p:cNvPr id="4" name="Shape 2"/>
-          <p:cNvSpPr/>
-          <p:nvPr/>
-        </p:nvSpPr>
-        <p:spPr>
-          <a:xfrm>
-            <a:off x="777240" y="1645920"/>
-            <a:ext cx="384048" cy="384048"/>
-          </a:xfrm>
-          <a:prstGeom prst="ellipse">
-            <a:avLst/>
-          </a:prstGeom>
-          <a:solidFill>
-            <a:srgbClr val="C8463D"/>
-          </a:solidFill>
-          <a:ln/>
-        </p:spPr>
-      </p:sp>
-      <p:sp>
-        <p:nvSpPr>
-          <p:cNvPr id="5" name="Text 3"/>
-          <p:cNvSpPr txBox="1"/>
-          <p:nvPr/>
-        </p:nvSpPr>
-        <p:spPr>
-          <a:xfrm>
-            <a:off x="1280160" y="1581912"/>
-            <a:ext cx="4480560" cy="512064"/>
-          </a:xfrm>
-          <a:prstGeom prst="rect">
-            <a:avLst/>
-          </a:prstGeom>
-          <a:noFill/>
-          <a:ln/>
-        </p:spPr>
-        <p:txBody>
-          <a:bodyPr wrap="square" lIns="0" tIns="0" rIns="0" bIns="0" rtlCol="0" anchor="ctr"/>
-          <a:lstStyle/>
-          <a:p>
-            <a:pPr indent="0" marL="0">
-              <a:buNone/>
-            </a:pPr>
-            <a:r>
-              <a:rPr lang="en-US" sz="1700" b="1" dirty="0">
-                <a:solidFill>
-                  <a:srgbClr val="1F2A36"/>
-                </a:solidFill>
-              </a:rPr>
-              <a:t>Limitations we state up front</a:t>
-            </a:r>
-            <a:endParaRPr lang="en-US" sz="1700" dirty="0"/>
-          </a:p>
-        </p:txBody>
-      </p:sp>
-      <p:sp>
-        <p:nvSpPr>
-          <p:cNvPr id="6" name="Text 4"/>
-          <p:cNvSpPr txBox="1"/>
-          <p:nvPr/>
-        </p:nvSpPr>
-        <p:spPr>
-          <a:xfrm>
-            <a:off x="777240" y="2194560"/>
-            <a:ext cx="4937760" cy="2651760"/>
-          </a:xfrm>
-          <a:prstGeom prst="rect">
-            <a:avLst/>
-          </a:prstGeom>
-          <a:noFill/>
-          <a:ln/>
-        </p:spPr>
-        <p:txBody>
-          <a:bodyPr wrap="square" lIns="0" tIns="0" rIns="0" bIns="0" rtlCol="0" anchor="t"/>
-          <a:lstStyle/>
-          <a:p>
-            <a:pPr indent="0" marL="0">
-              <a:buNone/>
-            </a:pPr>
-            <a:r>
-              <a:rPr lang="en-US" sz="1400" dirty="0">
-                <a:solidFill>
-                  <a:srgbClr val="1F2A36"/>
-                </a:solidFill>
-              </a:rPr>
-              <a:t>Mock ledger commit time is a setting (500 ms); Fabric numbers come from the gateway benchmark.</a:t>
-            </a:r>
-            <a:endParaRPr lang="en-US" sz="1400" dirty="0"/>
-          </a:p>
-          <a:p>
-            <a:pPr indent="0" marL="0">
-              <a:buNone/>
-            </a:pPr>
-            <a:endParaRPr lang="en-US" sz="1400" dirty="0"/>
-          </a:p>
-          <a:p>
-            <a:pPr indent="0" marL="0">
-              <a:buNone/>
-            </a:pPr>
-            <a:r>
-              <a:rPr lang="en-US" sz="1400" dirty="0">
-                <a:solidFill>
-                  <a:srgbClr val="1F2A36"/>
-                </a:solidFill>
-              </a:rPr>
-              <a:t>Lite radio for these runs; final numbers with ns-3.</a:t>
-            </a:r>
-            <a:endParaRPr lang="en-US" sz="1400" dirty="0"/>
-          </a:p>
-          <a:p>
-            <a:pPr indent="0" marL="0">
-              <a:buNone/>
-            </a:pPr>
-            <a:endParaRPr lang="en-US" sz="1400" dirty="0"/>
-          </a:p>
-          <a:p>
-            <a:pPr indent="0" marL="0">
-              <a:buNone/>
-            </a:pPr>
-            <a:r>
-              <a:rPr lang="en-US" sz="1400" dirty="0">
-                <a:solidFill>
-                  <a:srgbClr val="1F2A36"/>
-                </a:solidFill>
-              </a:rPr>
-              <a:t>Detector tuned on generated data; VeReMi NextGen not yet run.</a:t>
-            </a:r>
-            <a:endParaRPr lang="en-US" sz="1400" dirty="0"/>
-          </a:p>
-          <a:p>
-            <a:pPr indent="0" marL="0">
-              <a:buNone/>
-            </a:pPr>
-            <a:endParaRPr lang="en-US" sz="1400" dirty="0"/>
-          </a:p>
-          <a:p>
-            <a:pPr indent="0" marL="0">
-              <a:buNone/>
-            </a:pPr>
-            <a:r>
-              <a:rPr lang="en-US" sz="1400" dirty="0">
-                <a:solidFill>
-                  <a:srgbClr val="1F2A36"/>
-                </a:solidFill>
-              </a:rPr>
-              <a:t>The RSU that sees a pseudonym change can link old and new pid.</a:t>
-            </a:r>
-            <a:endParaRPr lang="en-US" sz="1400" dirty="0"/>
-          </a:p>
-        </p:txBody>
-      </p:sp>
-      <p:sp>
-        <p:nvSpPr>
-          <p:cNvPr id="7" name="Shape 5"/>
-          <p:cNvSpPr/>
-          <p:nvPr/>
-        </p:nvSpPr>
-        <p:spPr>
-          <a:xfrm>
-            <a:off x="6217920" y="1417320"/>
-            <a:ext cx="5394960" cy="3566160"/>
-          </a:xfrm>
-          <a:prstGeom prst="roundRect">
-            <a:avLst>
-              <a:gd name="adj" fmla="val 2051"/>
-            </a:avLst>
-          </a:prstGeom>
-          <a:solidFill>
-            <a:srgbClr val="EEF2F5"/>
-          </a:solidFill>
-          <a:ln w="12700">
-            <a:solidFill>
-              <a:srgbClr val="EEF2F5"/>
-            </a:solidFill>
-            <a:prstDash val="solid"/>
-          </a:ln>
-        </p:spPr>
-      </p:sp>
-      <p:sp>
-        <p:nvSpPr>
-          <p:cNvPr id="8" name="Shape 6"/>
-          <p:cNvSpPr/>
-          <p:nvPr/>
-        </p:nvSpPr>
-        <p:spPr>
-          <a:xfrm>
-            <a:off x="6446520" y="1645920"/>
-            <a:ext cx="384048" cy="384048"/>
-          </a:xfrm>
-          <a:prstGeom prst="ellipse">
-            <a:avLst/>
-          </a:prstGeom>
-          <a:solidFill>
-            <a:srgbClr val="1F9E8F"/>
-          </a:solidFill>
-          <a:ln/>
-        </p:spPr>
-      </p:sp>
-      <p:sp>
-        <p:nvSpPr>
-          <p:cNvPr id="9" name="Text 7"/>
-          <p:cNvSpPr txBox="1"/>
-          <p:nvPr/>
-        </p:nvSpPr>
-        <p:spPr>
-          <a:xfrm>
-            <a:off x="6949440" y="1581912"/>
-            <a:ext cx="4480560" cy="512064"/>
-          </a:xfrm>
-          <a:prstGeom prst="rect">
-            <a:avLst/>
-          </a:prstGeom>
-          <a:noFill/>
-          <a:ln/>
-        </p:spPr>
-        <p:txBody>
-          <a:bodyPr wrap="square" lIns="0" tIns="0" rIns="0" bIns="0" rtlCol="0" anchor="ctr"/>
-          <a:lstStyle/>
-          <a:p>
-            <a:pPr indent="0" marL="0">
-              <a:buNone/>
-            </a:pPr>
-            <a:r>
-              <a:rPr lang="en-US" sz="1700" b="1" dirty="0">
-                <a:solidFill>
-                  <a:srgbClr val="1F2A36"/>
-                </a:solidFill>
-              </a:rPr>
-              <a:t>Next steps</a:t>
-            </a:r>
-            <a:endParaRPr lang="en-US" sz="1700" dirty="0"/>
-          </a:p>
-        </p:txBody>
-      </p:sp>
-      <p:sp>
-        <p:nvSpPr>
-          <p:cNvPr id="10" name="Text 8"/>
-          <p:cNvSpPr txBox="1"/>
-          <p:nvPr/>
-        </p:nvSpPr>
-        <p:spPr>
-          <a:xfrm>
-            <a:off x="6446520" y="2194560"/>
-            <a:ext cx="4937760" cy="2651760"/>
-          </a:xfrm>
-          <a:prstGeom prst="rect">
-            <a:avLst/>
-          </a:prstGeom>
-          <a:noFill/>
-          <a:ln/>
-        </p:spPr>
-        <p:txBody>
-          <a:bodyPr wrap="square" lIns="0" tIns="0" rIns="0" bIns="0" rtlCol="0" anchor="t"/>
-          <a:lstStyle/>
-          <a:p>
-            <a:pPr indent="0" marL="0">
-              <a:buNone/>
-            </a:pPr>
-            <a:r>
-              <a:rPr lang="en-US" sz="1400" dirty="0">
-                <a:solidFill>
-                  <a:srgbClr val="1F2A36"/>
-                </a:solidFill>
-              </a:rPr>
-              <a:t>Run the same configs with --backend ns3 and --ledger on real Fabric.</a:t>
-            </a:r>
-            <a:endParaRPr lang="en-US" sz="1400" dirty="0"/>
-          </a:p>
-          <a:p>
-            <a:pPr indent="0" marL="0">
-              <a:buNone/>
-            </a:pPr>
-            <a:endParaRPr lang="en-US" sz="1400" dirty="0"/>
-          </a:p>
-          <a:p>
-            <a:pPr indent="0" marL="0">
-              <a:buNone/>
-            </a:pPr>
-            <a:r>
-              <a:rPr lang="en-US" sz="1400" dirty="0">
-                <a:solidFill>
-                  <a:srgbClr val="1F2A36"/>
-                </a:solidFill>
-              </a:rPr>
-              <a:t>Evaluate the detector on VeReMi NextGen test split.</a:t>
-            </a:r>
-            <a:endParaRPr lang="en-US" sz="1400" dirty="0"/>
-          </a:p>
-          <a:p>
-            <a:pPr indent="0" marL="0">
-              <a:buNone/>
-            </a:pPr>
-            <a:endParaRPr lang="en-US" sz="1400" dirty="0"/>
-          </a:p>
-          <a:p>
-            <a:pPr indent="0" marL="0">
-              <a:buNone/>
-            </a:pPr>
-            <a:r>
-              <a:rPr lang="en-US" sz="1400" dirty="0">
-                <a:solidFill>
-                  <a:srgbClr val="1F2A36"/>
-                </a:solidFill>
-              </a:rPr>
-              <a:t>RSSI / angle-of-arrival check for constant-offset attacks.</a:t>
-            </a:r>
-            <a:endParaRPr lang="en-US" sz="1400" dirty="0"/>
-          </a:p>
-          <a:p>
-            <a:pPr indent="0" marL="0">
-              <a:buNone/>
-            </a:pPr>
-            <a:endParaRPr lang="en-US" sz="1400" dirty="0"/>
-          </a:p>
-          <a:p>
-            <a:pPr indent="0" marL="0">
-              <a:buNone/>
-            </a:pPr>
-            <a:r>
-              <a:rPr lang="en-US" sz="1400" dirty="0">
-                <a:solidFill>
-                  <a:srgbClr val="1F2A36"/>
-                </a:solidFill>
-              </a:rPr>
-              <a:t>Compare against ECDSA certificates and a central authority (compare_schemes.json).</a:t>
-            </a:r>
-            <a:endParaRPr lang="en-US" sz="1400" dirty="0"/>
-          </a:p>
-        </p:txBody>
-      </p:sp>
-      <p:sp>
-        <p:nvSpPr>
-          <p:cNvPr id="25" name="Slide Number Placeholder 0"/>
-          <p:cNvSpPr>
-            <a:spLocks noGrp="1"/>
-          </p:cNvSpPr>
-          <p:nvPr>
-            <p:ph type="sldNum" sz="quarter" idx="4294967295"/>
-          </p:nvPr>
-        </p:nvSpPr>
-        <p:spPr>
-          <a:xfrm>
-            <a:off x="11247120" y="6400800"/>
-            <a:ext cx="548640" cy="274320"/>
-          </a:xfrm>
-          <a:prstGeom prst="rect">
-            <a:avLst/>
-          </a:prstGeom>
-          <a:extLst>
-            <a:ext uri="{C572A759-6A51-4108-AA02-DFA0A04FC94B}">
-              <ma14:wrappingTextBoxFlag xmlns:ma14="http://schemas.microsoft.com/office/mac/drawingml/2011/main" val="0"/>
-            </a:ext>
-          </a:extLst>
-        </p:spPr>
-        <p:txBody>
-          <a:bodyPr/>
-          <a:lstStyle>
-            <a:lvl1pPr>
-              <a:defRPr sz="1000">
-                <a:solidFill>
-                  <a:srgbClr val="5B6B7A"/>
-                </a:solidFill>
-                <a:latin typeface="Calibri"/>
-                <a:ea typeface="Calibri"/>
-                <a:cs typeface="Calibri"/>
-              </a:defRPr>
-            </a:lvl1pPr>
-          </a:lstStyle>
-          <a:p>
-            <a:pPr algn="l"/>
-            <a:fld id="{F7021451-1387-4CA6-816F-3879F97B5CBC}" type="slidenum">
-              <a:rPr b="0" lang="en-US"/>
               <a:t>14</a:t>
             </a:fld>
             <a:endParaRPr lang="en-US"/>
@@ -10917,6 +10716,478 @@
       <p:sp>
         <p:nvSpPr>
           <p:cNvPr id="2" name="Text 0"/>
+          <p:cNvSpPr/>
+          <p:nvPr>
+            <p:ph idx="100" type="title" hasCustomPrompt="1"/>
+          </p:nvPr>
+        </p:nvSpPr>
+        <p:spPr>
+          <a:xfrm>
+            <a:off x="548640" y="320040"/>
+            <a:ext cx="11064240" cy="822960"/>
+          </a:xfrm>
+          <a:prstGeom prst="rect">
+            <a:avLst/>
+          </a:prstGeom>
+          <a:noFill/>
+          <a:ln/>
+        </p:spPr>
+        <p:txBody>
+          <a:bodyPr wrap="square" lIns="0" tIns="0" rIns="0" bIns="0" rtlCol="0" anchor="ctr"/>
+          <a:lstStyle/>
+          <a:p>
+            <a:pPr indent="0" marL="0">
+              <a:buNone/>
+            </a:pPr>
+            <a:r>
+              <a:rPr lang="en-US" sz="3200" b="1" dirty="0">
+                <a:solidFill>
+                  <a:srgbClr val="1F2A36"/>
+                </a:solidFill>
+                <a:latin typeface="Cambria" pitchFamily="34" charset="0"/>
+                <a:ea typeface="Cambria" pitchFamily="34" charset="-122"/>
+                <a:cs typeface="Cambria" pitchFamily="34" charset="-120"/>
+              </a:rPr>
+              <a:t>Limitations and next steps</a:t>
+            </a:r>
+            <a:endParaRPr lang="en-US" sz="3200" dirty="0"/>
+          </a:p>
+        </p:txBody>
+      </p:sp>
+      <p:sp>
+        <p:nvSpPr>
+          <p:cNvPr id="3" name="Shape 1"/>
+          <p:cNvSpPr/>
+          <p:nvPr/>
+        </p:nvSpPr>
+        <p:spPr>
+          <a:xfrm>
+            <a:off x="548640" y="1417320"/>
+            <a:ext cx="5394960" cy="3566160"/>
+          </a:xfrm>
+          <a:prstGeom prst="roundRect">
+            <a:avLst>
+              <a:gd name="adj" fmla="val 2051"/>
+            </a:avLst>
+          </a:prstGeom>
+          <a:solidFill>
+            <a:srgbClr val="EEF2F5"/>
+          </a:solidFill>
+          <a:ln w="12700">
+            <a:solidFill>
+              <a:srgbClr val="EEF2F5"/>
+            </a:solidFill>
+            <a:prstDash val="solid"/>
+          </a:ln>
+        </p:spPr>
+      </p:sp>
+      <p:sp>
+        <p:nvSpPr>
+          <p:cNvPr id="4" name="Shape 2"/>
+          <p:cNvSpPr/>
+          <p:nvPr/>
+        </p:nvSpPr>
+        <p:spPr>
+          <a:xfrm>
+            <a:off x="777240" y="1645920"/>
+            <a:ext cx="384048" cy="384048"/>
+          </a:xfrm>
+          <a:prstGeom prst="ellipse">
+            <a:avLst/>
+          </a:prstGeom>
+          <a:solidFill>
+            <a:srgbClr val="C8463D"/>
+          </a:solidFill>
+          <a:ln/>
+        </p:spPr>
+      </p:sp>
+      <p:sp>
+        <p:nvSpPr>
+          <p:cNvPr id="5" name="Text 3"/>
+          <p:cNvSpPr txBox="1"/>
+          <p:nvPr/>
+        </p:nvSpPr>
+        <p:spPr>
+          <a:xfrm>
+            <a:off x="1280160" y="1581912"/>
+            <a:ext cx="4480560" cy="512064"/>
+          </a:xfrm>
+          <a:prstGeom prst="rect">
+            <a:avLst/>
+          </a:prstGeom>
+          <a:noFill/>
+          <a:ln/>
+        </p:spPr>
+        <p:txBody>
+          <a:bodyPr wrap="square" lIns="0" tIns="0" rIns="0" bIns="0" rtlCol="0" anchor="ctr"/>
+          <a:lstStyle/>
+          <a:p>
+            <a:pPr indent="0" marL="0">
+              <a:buNone/>
+            </a:pPr>
+            <a:r>
+              <a:rPr lang="en-US" sz="1700" b="1" dirty="0">
+                <a:solidFill>
+                  <a:srgbClr val="1F2A36"/>
+                </a:solidFill>
+              </a:rPr>
+              <a:t>Limitations we state up front</a:t>
+            </a:r>
+            <a:endParaRPr lang="en-US" sz="1700" dirty="0"/>
+          </a:p>
+        </p:txBody>
+      </p:sp>
+      <p:sp>
+        <p:nvSpPr>
+          <p:cNvPr id="6" name="Text 4"/>
+          <p:cNvSpPr txBox="1"/>
+          <p:nvPr/>
+        </p:nvSpPr>
+        <p:spPr>
+          <a:xfrm>
+            <a:off x="777240" y="2194560"/>
+            <a:ext cx="4937760" cy="2651760"/>
+          </a:xfrm>
+          <a:prstGeom prst="rect">
+            <a:avLst/>
+          </a:prstGeom>
+          <a:noFill/>
+          <a:ln/>
+        </p:spPr>
+        <p:txBody>
+          <a:bodyPr wrap="square" lIns="0" tIns="0" rIns="0" bIns="0" rtlCol="0" anchor="t"/>
+          <a:lstStyle/>
+          <a:p>
+            <a:pPr indent="0" marL="0">
+              <a:buNone/>
+            </a:pPr>
+            <a:r>
+              <a:rPr lang="en-US" sz="1400" dirty="0">
+                <a:solidFill>
+                  <a:srgbClr val="1F2A36"/>
+                </a:solidFill>
+              </a:rPr>
+              <a:t>Traffic is SUMO random trips (real roads for Monaco, not recorded traffic).</a:t>
+            </a:r>
+            <a:endParaRPr lang="en-US" sz="1400" dirty="0"/>
+          </a:p>
+          <a:p>
+            <a:pPr indent="0" marL="0">
+              <a:buNone/>
+            </a:pPr>
+            <a:endParaRPr lang="en-US" sz="1400" dirty="0"/>
+          </a:p>
+          <a:p>
+            <a:pPr indent="0" marL="0">
+              <a:buNone/>
+            </a:pPr>
+            <a:r>
+              <a:rPr lang="en-US" sz="1400" dirty="0">
+                <a:solidFill>
+                  <a:srgbClr val="1F2A36"/>
+                </a:solidFill>
+              </a:rPr>
+              <a:t>Detector tuned on generated data; VeReMi NextGen not yet run; heading check fires at real-map U-turns.</a:t>
+            </a:r>
+            <a:endParaRPr lang="en-US" sz="1400" dirty="0"/>
+          </a:p>
+          <a:p>
+            <a:pPr indent="0" marL="0">
+              <a:buNone/>
+            </a:pPr>
+            <a:endParaRPr lang="en-US" sz="1400" dirty="0"/>
+          </a:p>
+          <a:p>
+            <a:pPr indent="0" marL="0">
+              <a:buNone/>
+            </a:pPr>
+            <a:r>
+              <a:rPr lang="en-US" sz="1400" dirty="0">
+                <a:solidFill>
+                  <a:srgbClr val="1F2A36"/>
+                </a:solidFill>
+              </a:rPr>
+              <a:t>const_pos seen by one RSU only is reported but not revoked (the two-RSU rule).</a:t>
+            </a:r>
+            <a:endParaRPr lang="en-US" sz="1400" dirty="0"/>
+          </a:p>
+          <a:p>
+            <a:pPr indent="0" marL="0">
+              <a:buNone/>
+            </a:pPr>
+            <a:endParaRPr lang="en-US" sz="1400" dirty="0"/>
+          </a:p>
+          <a:p>
+            <a:pPr indent="0" marL="0">
+              <a:buNone/>
+            </a:pPr>
+            <a:r>
+              <a:rPr lang="en-US" sz="1400" dirty="0">
+                <a:solidFill>
+                  <a:srgbClr val="1F2A36"/>
+                </a:solidFill>
+              </a:rPr>
+              <a:t>The RSU that sees a pseudonym change can link old and new pid.</a:t>
+            </a:r>
+            <a:endParaRPr lang="en-US" sz="1400" dirty="0"/>
+          </a:p>
+        </p:txBody>
+      </p:sp>
+      <p:sp>
+        <p:nvSpPr>
+          <p:cNvPr id="7" name="Shape 5"/>
+          <p:cNvSpPr/>
+          <p:nvPr/>
+        </p:nvSpPr>
+        <p:spPr>
+          <a:xfrm>
+            <a:off x="6217920" y="1417320"/>
+            <a:ext cx="5394960" cy="3566160"/>
+          </a:xfrm>
+          <a:prstGeom prst="roundRect">
+            <a:avLst>
+              <a:gd name="adj" fmla="val 2051"/>
+            </a:avLst>
+          </a:prstGeom>
+          <a:solidFill>
+            <a:srgbClr val="EEF2F5"/>
+          </a:solidFill>
+          <a:ln w="12700">
+            <a:solidFill>
+              <a:srgbClr val="EEF2F5"/>
+            </a:solidFill>
+            <a:prstDash val="solid"/>
+          </a:ln>
+        </p:spPr>
+      </p:sp>
+      <p:sp>
+        <p:nvSpPr>
+          <p:cNvPr id="8" name="Shape 6"/>
+          <p:cNvSpPr/>
+          <p:nvPr/>
+        </p:nvSpPr>
+        <p:spPr>
+          <a:xfrm>
+            <a:off x="6446520" y="1645920"/>
+            <a:ext cx="384048" cy="384048"/>
+          </a:xfrm>
+          <a:prstGeom prst="ellipse">
+            <a:avLst/>
+          </a:prstGeom>
+          <a:solidFill>
+            <a:srgbClr val="1F9E8F"/>
+          </a:solidFill>
+          <a:ln/>
+        </p:spPr>
+      </p:sp>
+      <p:sp>
+        <p:nvSpPr>
+          <p:cNvPr id="9" name="Text 7"/>
+          <p:cNvSpPr txBox="1"/>
+          <p:nvPr/>
+        </p:nvSpPr>
+        <p:spPr>
+          <a:xfrm>
+            <a:off x="6949440" y="1581912"/>
+            <a:ext cx="4480560" cy="512064"/>
+          </a:xfrm>
+          <a:prstGeom prst="rect">
+            <a:avLst/>
+          </a:prstGeom>
+          <a:noFill/>
+          <a:ln/>
+        </p:spPr>
+        <p:txBody>
+          <a:bodyPr wrap="square" lIns="0" tIns="0" rIns="0" bIns="0" rtlCol="0" anchor="ctr"/>
+          <a:lstStyle/>
+          <a:p>
+            <a:pPr indent="0" marL="0">
+              <a:buNone/>
+            </a:pPr>
+            <a:r>
+              <a:rPr lang="en-US" sz="1700" b="1" dirty="0">
+                <a:solidFill>
+                  <a:srgbClr val="1F2A36"/>
+                </a:solidFill>
+              </a:rPr>
+              <a:t>Next steps</a:t>
+            </a:r>
+            <a:endParaRPr lang="en-US" sz="1700" dirty="0"/>
+          </a:p>
+        </p:txBody>
+      </p:sp>
+      <p:sp>
+        <p:nvSpPr>
+          <p:cNvPr id="10" name="Text 8"/>
+          <p:cNvSpPr txBox="1"/>
+          <p:nvPr/>
+        </p:nvSpPr>
+        <p:spPr>
+          <a:xfrm>
+            <a:off x="6446520" y="2194560"/>
+            <a:ext cx="4937760" cy="2651760"/>
+          </a:xfrm>
+          <a:prstGeom prst="rect">
+            <a:avLst/>
+          </a:prstGeom>
+          <a:noFill/>
+          <a:ln/>
+        </p:spPr>
+        <p:txBody>
+          <a:bodyPr wrap="square" lIns="0" tIns="0" rIns="0" bIns="0" rtlCol="0" anchor="t"/>
+          <a:lstStyle/>
+          <a:p>
+            <a:pPr indent="0" marL="0">
+              <a:buNone/>
+            </a:pPr>
+            <a:r>
+              <a:rPr lang="en-US" sz="1400" dirty="0">
+                <a:solidFill>
+                  <a:srgbClr val="1F2A36"/>
+                </a:solidFill>
+              </a:rPr>
+              <a:t>Evaluate the detector on the VeReMi NextGen test split.</a:t>
+            </a:r>
+            <a:endParaRPr lang="en-US" sz="1400" dirty="0"/>
+          </a:p>
+          <a:p>
+            <a:pPr indent="0" marL="0">
+              <a:buNone/>
+            </a:pPr>
+            <a:endParaRPr lang="en-US" sz="1400" dirty="0"/>
+          </a:p>
+          <a:p>
+            <a:pPr indent="0" marL="0">
+              <a:buNone/>
+            </a:pPr>
+            <a:r>
+              <a:rPr lang="en-US" sz="1400" dirty="0">
+                <a:solidFill>
+                  <a:srgbClr val="1F2A36"/>
+                </a:solidFill>
+              </a:rPr>
+              <a:t>RSSI / angle-of-arrival check for constant-offset attacks.</a:t>
+            </a:r>
+            <a:endParaRPr lang="en-US" sz="1400" dirty="0"/>
+          </a:p>
+          <a:p>
+            <a:pPr indent="0" marL="0">
+              <a:buNone/>
+            </a:pPr>
+            <a:endParaRPr lang="en-US" sz="1400" dirty="0"/>
+          </a:p>
+          <a:p>
+            <a:pPr indent="0" marL="0">
+              <a:buNone/>
+            </a:pPr>
+            <a:r>
+              <a:rPr lang="en-US" sz="1400" dirty="0">
+                <a:solidFill>
+                  <a:srgbClr val="1F2A36"/>
+                </a:solidFill>
+              </a:rPr>
+              <a:t>Monaco on ns-3 + Fabric (27 RSUs needs a chaincode trace threshold above 10).</a:t>
+            </a:r>
+            <a:endParaRPr lang="en-US" sz="1400" dirty="0"/>
+          </a:p>
+          <a:p>
+            <a:pPr indent="0" marL="0">
+              <a:buNone/>
+            </a:pPr>
+            <a:endParaRPr lang="en-US" sz="1400" dirty="0"/>
+          </a:p>
+          <a:p>
+            <a:pPr indent="0" marL="0">
+              <a:buNone/>
+            </a:pPr>
+            <a:r>
+              <a:rPr lang="en-US" sz="1400" dirty="0">
+                <a:solidFill>
+                  <a:srgbClr val="1F2A36"/>
+                </a:solidFill>
+              </a:rPr>
+              <a:t>Fabric throughput at city scale (more peers, more organisations).</a:t>
+            </a:r>
+            <a:endParaRPr lang="en-US" sz="1400" dirty="0"/>
+          </a:p>
+        </p:txBody>
+      </p:sp>
+      <p:sp>
+        <p:nvSpPr>
+          <p:cNvPr id="25" name="Slide Number Placeholder 0"/>
+          <p:cNvSpPr>
+            <a:spLocks noGrp="1"/>
+          </p:cNvSpPr>
+          <p:nvPr>
+            <p:ph type="sldNum" sz="quarter" idx="4294967295"/>
+          </p:nvPr>
+        </p:nvSpPr>
+        <p:spPr>
+          <a:xfrm>
+            <a:off x="11247120" y="6400800"/>
+            <a:ext cx="548640" cy="274320"/>
+          </a:xfrm>
+          <a:prstGeom prst="rect">
+            <a:avLst/>
+          </a:prstGeom>
+          <a:extLst>
+            <a:ext uri="{C572A759-6A51-4108-AA02-DFA0A04FC94B}">
+              <ma14:wrappingTextBoxFlag xmlns:ma14="http://schemas.microsoft.com/office/mac/drawingml/2011/main" val="0"/>
+            </a:ext>
+          </a:extLst>
+        </p:spPr>
+        <p:txBody>
+          <a:bodyPr/>
+          <a:lstStyle>
+            <a:lvl1pPr>
+              <a:defRPr sz="1000">
+                <a:solidFill>
+                  <a:srgbClr val="5B6B7A"/>
+                </a:solidFill>
+                <a:latin typeface="Calibri"/>
+                <a:ea typeface="Calibri"/>
+                <a:cs typeface="Calibri"/>
+              </a:defRPr>
+            </a:lvl1pPr>
+          </a:lstStyle>
+          <a:p>
+            <a:pPr algn="l"/>
+            <a:fld id="{F7021451-1387-4CA6-816F-3879F97B5CBC}" type="slidenum">
+              <a:rPr b="0" lang="en-US"/>
+              <a:t>15</a:t>
+            </a:fld>
+            <a:endParaRPr lang="en-US"/>
+          </a:p>
+        </p:txBody>
+      </p:sp>
+    </p:spTree>
+  </p:cSld>
+  <p:clrMapOvr>
+    <a:masterClrMapping/>
+  </p:clrMapOvr>
+</p:sld>
+</file>
+
+<file path=ppt/slides/slide16.xml><?xml version="1.0" encoding="utf-8"?>
+<p:sld xmlns:a="http://schemas.openxmlformats.org/drawingml/2006/main" xmlns:r="http://schemas.openxmlformats.org/officeDocument/2006/relationships" xmlns:p="http://schemas.openxmlformats.org/presentationml/2006/main">
+  <p:cSld name="Slide 16">
+    <p:spTree>
+      <p:nvGrpSpPr>
+        <p:cNvPr id="1" name=""/>
+        <p:cNvGrpSpPr/>
+        <p:nvPr/>
+      </p:nvGrpSpPr>
+      <p:grpSpPr>
+        <a:xfrm>
+          <a:off x="0" y="0"/>
+          <a:ext cx="0" cy="0"/>
+          <a:chOff x="0" y="0"/>
+          <a:chExt cx="0" cy="0"/>
+        </a:xfrm>
+      </p:grpSpPr>
+      <p:sp>
+        <p:nvSpPr>
+          <p:cNvPr id="2" name="Text 0"/>
           <p:cNvSpPr txBox="1"/>
           <p:nvPr/>
         </p:nvSpPr>
@@ -15337,6 +15608,1620 @@
                 <a:ea typeface="Cambria" pitchFamily="34" charset="-122"/>
                 <a:cs typeface="Cambria" pitchFamily="34" charset="-120"/>
               </a:rPr>
+              <a:t>Final run: ns-3 radio and real Hyperledger Fabric</a:t>
+            </a:r>
+            <a:endParaRPr lang="en-US" sz="3200" dirty="0"/>
+          </a:p>
+        </p:txBody>
+      </p:sp>
+      <p:sp>
+        <p:nvSpPr>
+          <p:cNvPr id="3" name="Text 1"/>
+          <p:cNvSpPr txBox="1"/>
+          <p:nvPr/>
+        </p:nvSpPr>
+        <p:spPr>
+          <a:xfrm>
+            <a:off x="548640" y="1371600"/>
+            <a:ext cx="2651760" cy="914400"/>
+          </a:xfrm>
+          <a:prstGeom prst="rect">
+            <a:avLst/>
+          </a:prstGeom>
+          <a:noFill/>
+          <a:ln/>
+        </p:spPr>
+        <p:txBody>
+          <a:bodyPr wrap="square" lIns="0" tIns="0" rIns="0" bIns="0" rtlCol="0" anchor="ctr"/>
+          <a:lstStyle/>
+          <a:p>
+            <a:pPr indent="0" marL="0">
+              <a:buNone/>
+            </a:pPr>
+            <a:r>
+              <a:rPr lang="en-US" sz="4000" b="1" dirty="0">
+                <a:solidFill>
+                  <a:srgbClr val="1F2A36"/>
+                </a:solidFill>
+                <a:latin typeface="Cambria" pitchFamily="34" charset="0"/>
+                <a:ea typeface="Cambria" pitchFamily="34" charset="-122"/>
+                <a:cs typeface="Cambria" pitchFamily="34" charset="-120"/>
+              </a:rPr>
+              <a:t>350 ms</a:t>
+            </a:r>
+            <a:endParaRPr lang="en-US" sz="4000" dirty="0"/>
+          </a:p>
+        </p:txBody>
+      </p:sp>
+      <p:sp>
+        <p:nvSpPr>
+          <p:cNvPr id="4" name="Text 2"/>
+          <p:cNvSpPr txBox="1"/>
+          <p:nvPr/>
+        </p:nvSpPr>
+        <p:spPr>
+          <a:xfrm>
+            <a:off x="548640" y="2286000"/>
+            <a:ext cx="2560320" cy="822960"/>
+          </a:xfrm>
+          <a:prstGeom prst="rect">
+            <a:avLst/>
+          </a:prstGeom>
+          <a:noFill/>
+          <a:ln/>
+        </p:spPr>
+        <p:txBody>
+          <a:bodyPr wrap="square" lIns="0" tIns="0" rIns="0" bIns="0" rtlCol="0" anchor="t"/>
+          <a:lstStyle/>
+          <a:p>
+            <a:pPr indent="0" marL="0">
+              <a:buNone/>
+            </a:pPr>
+            <a:r>
+              <a:rPr lang="en-US" sz="1400" dirty="0">
+                <a:solidFill>
+                  <a:srgbClr val="5B6B7A"/>
+                </a:solidFill>
+              </a:rPr>
+              <a:t>Fabric commit, median (p95 547 ms)</a:t>
+            </a:r>
+            <a:endParaRPr lang="en-US" sz="1400" dirty="0"/>
+          </a:p>
+        </p:txBody>
+      </p:sp>
+      <p:sp>
+        <p:nvSpPr>
+          <p:cNvPr id="5" name="Text 3"/>
+          <p:cNvSpPr txBox="1"/>
+          <p:nvPr/>
+        </p:nvSpPr>
+        <p:spPr>
+          <a:xfrm>
+            <a:off x="3364992" y="1371600"/>
+            <a:ext cx="2651760" cy="914400"/>
+          </a:xfrm>
+          <a:prstGeom prst="rect">
+            <a:avLst/>
+          </a:prstGeom>
+          <a:noFill/>
+          <a:ln/>
+        </p:spPr>
+        <p:txBody>
+          <a:bodyPr wrap="square" lIns="0" tIns="0" rIns="0" bIns="0" rtlCol="0" anchor="ctr"/>
+          <a:lstStyle/>
+          <a:p>
+            <a:pPr indent="0" marL="0">
+              <a:buNone/>
+            </a:pPr>
+            <a:r>
+              <a:rPr lang="en-US" sz="4000" b="1" dirty="0">
+                <a:solidFill>
+                  <a:srgbClr val="1F2A36"/>
+                </a:solidFill>
+                <a:latin typeface="Cambria" pitchFamily="34" charset="0"/>
+                <a:ea typeface="Cambria" pitchFamily="34" charset="-122"/>
+                <a:cs typeface="Cambria" pitchFamily="34" charset="-120"/>
+              </a:rPr>
+              <a:t>1.60 ms</a:t>
+            </a:r>
+            <a:endParaRPr lang="en-US" sz="4000" dirty="0"/>
+          </a:p>
+        </p:txBody>
+      </p:sp>
+      <p:sp>
+        <p:nvSpPr>
+          <p:cNvPr id="6" name="Text 4"/>
+          <p:cNvSpPr txBox="1"/>
+          <p:nvPr/>
+        </p:nvSpPr>
+        <p:spPr>
+          <a:xfrm>
+            <a:off x="3364992" y="2286000"/>
+            <a:ext cx="2560320" cy="822960"/>
+          </a:xfrm>
+          <a:prstGeom prst="rect">
+            <a:avLst/>
+          </a:prstGeom>
+          <a:noFill/>
+          <a:ln/>
+        </p:spPr>
+        <p:txBody>
+          <a:bodyPr wrap="square" lIns="0" tIns="0" rIns="0" bIns="0" rtlCol="0" anchor="t"/>
+          <a:lstStyle/>
+          <a:p>
+            <a:pPr indent="0" marL="0">
+              <a:buNone/>
+            </a:pPr>
+            <a:r>
+              <a:rPr lang="en-US" sz="1400" dirty="0">
+                <a:solidFill>
+                  <a:srgbClr val="5B6B7A"/>
+                </a:solidFill>
+              </a:rPr>
+              <a:t>authentication latency, median</a:t>
+            </a:r>
+            <a:endParaRPr lang="en-US" sz="1400" dirty="0"/>
+          </a:p>
+        </p:txBody>
+      </p:sp>
+      <p:sp>
+        <p:nvSpPr>
+          <p:cNvPr id="7" name="Text 5"/>
+          <p:cNvSpPr txBox="1"/>
+          <p:nvPr/>
+        </p:nvSpPr>
+        <p:spPr>
+          <a:xfrm>
+            <a:off x="6181344" y="1371600"/>
+            <a:ext cx="2651760" cy="914400"/>
+          </a:xfrm>
+          <a:prstGeom prst="rect">
+            <a:avLst/>
+          </a:prstGeom>
+          <a:noFill/>
+          <a:ln/>
+        </p:spPr>
+        <p:txBody>
+          <a:bodyPr wrap="square" lIns="0" tIns="0" rIns="0" bIns="0" rtlCol="0" anchor="ctr"/>
+          <a:lstStyle/>
+          <a:p>
+            <a:pPr indent="0" marL="0">
+              <a:buNone/>
+            </a:pPr>
+            <a:r>
+              <a:rPr lang="en-US" sz="4000" b="1" dirty="0">
+                <a:solidFill>
+                  <a:srgbClr val="1F2A36"/>
+                </a:solidFill>
+                <a:latin typeface="Cambria" pitchFamily="34" charset="0"/>
+                <a:ea typeface="Cambria" pitchFamily="34" charset="-122"/>
+                <a:cs typeface="Cambria" pitchFamily="34" charset="-120"/>
+              </a:rPr>
+              <a:t>40 %</a:t>
+            </a:r>
+            <a:endParaRPr lang="en-US" sz="4000" dirty="0"/>
+          </a:p>
+        </p:txBody>
+      </p:sp>
+      <p:sp>
+        <p:nvSpPr>
+          <p:cNvPr id="8" name="Text 6"/>
+          <p:cNvSpPr txBox="1"/>
+          <p:nvPr/>
+        </p:nvSpPr>
+        <p:spPr>
+          <a:xfrm>
+            <a:off x="6181344" y="2286000"/>
+            <a:ext cx="2560320" cy="822960"/>
+          </a:xfrm>
+          <a:prstGeom prst="rect">
+            <a:avLst/>
+          </a:prstGeom>
+          <a:noFill/>
+          <a:ln/>
+        </p:spPr>
+        <p:txBody>
+          <a:bodyPr wrap="square" lIns="0" tIns="0" rIns="0" bIns="0" rtlCol="0" anchor="t"/>
+          <a:lstStyle/>
+          <a:p>
+            <a:pPr indent="0" marL="0">
+              <a:buNone/>
+            </a:pPr>
+            <a:r>
+              <a:rPr lang="en-US" sz="1400" dirty="0">
+                <a:solidFill>
+                  <a:srgbClr val="5B6B7A"/>
+                </a:solidFill>
+              </a:rPr>
+              <a:t>handovers accepted before the ledger record was visible (PREAUTH)</a:t>
+            </a:r>
+            <a:endParaRPr lang="en-US" sz="1400" dirty="0"/>
+          </a:p>
+        </p:txBody>
+      </p:sp>
+      <p:sp>
+        <p:nvSpPr>
+          <p:cNvPr id="9" name="Text 7"/>
+          <p:cNvSpPr txBox="1"/>
+          <p:nvPr/>
+        </p:nvSpPr>
+        <p:spPr>
+          <a:xfrm>
+            <a:off x="8997696" y="1371600"/>
+            <a:ext cx="2651760" cy="914400"/>
+          </a:xfrm>
+          <a:prstGeom prst="rect">
+            <a:avLst/>
+          </a:prstGeom>
+          <a:noFill/>
+          <a:ln/>
+        </p:spPr>
+        <p:txBody>
+          <a:bodyPr wrap="square" lIns="0" tIns="0" rIns="0" bIns="0" rtlCol="0" anchor="ctr"/>
+          <a:lstStyle/>
+          <a:p>
+            <a:pPr indent="0" marL="0">
+              <a:buNone/>
+            </a:pPr>
+            <a:r>
+              <a:rPr lang="en-US" sz="4000" b="1" dirty="0">
+                <a:solidFill>
+                  <a:srgbClr val="1F2A36"/>
+                </a:solidFill>
+                <a:latin typeface="Cambria" pitchFamily="34" charset="0"/>
+                <a:ea typeface="Cambria" pitchFamily="34" charset="-122"/>
+                <a:cs typeface="Cambria" pitchFamily="34" charset="-120"/>
+              </a:rPr>
+              <a:t>3.9 s</a:t>
+            </a:r>
+            <a:endParaRPr lang="en-US" sz="4000" dirty="0"/>
+          </a:p>
+        </p:txBody>
+      </p:sp>
+      <p:sp>
+        <p:nvSpPr>
+          <p:cNvPr id="10" name="Text 8"/>
+          <p:cNvSpPr txBox="1"/>
+          <p:nvPr/>
+        </p:nvSpPr>
+        <p:spPr>
+          <a:xfrm>
+            <a:off x="8997696" y="2286000"/>
+            <a:ext cx="2560320" cy="822960"/>
+          </a:xfrm>
+          <a:prstGeom prst="rect">
+            <a:avLst/>
+          </a:prstGeom>
+          <a:noFill/>
+          <a:ln/>
+        </p:spPr>
+        <p:txBody>
+          <a:bodyPr wrap="square" lIns="0" tIns="0" rIns="0" bIns="0" rtlCol="0" anchor="t"/>
+          <a:lstStyle/>
+          <a:p>
+            <a:pPr indent="0" marL="0">
+              <a:buNone/>
+            </a:pPr>
+            <a:r>
+              <a:rPr lang="en-US" sz="1400" dirty="0">
+                <a:solidFill>
+                  <a:srgbClr val="5B6B7A"/>
+                </a:solidFill>
+              </a:rPr>
+              <a:t>first lie to identity revealed and all pseudonyms revoked</a:t>
+            </a:r>
+            <a:endParaRPr lang="en-US" sz="1400" dirty="0"/>
+          </a:p>
+        </p:txBody>
+      </p:sp>
+      <p:graphicFrame>
+        <p:nvGraphicFramePr>
+          <p:cNvPr id="8" name="Table 0"/>
+          <p:cNvGraphicFramePr>
+            <a:graphicFrameLocks noGrp="1"/>
+          </p:cNvGraphicFramePr>
+          <p:nvPr>
+            <p:extLst>
+              <p:ext uri="{D42A27DB-BD31-4B8C-83A1-F6EECF244321}">
+                <p14:modId xmlns:p14="http://schemas.microsoft.com/office/powerpoint/2010/main" val="1579011935"/>
+              </p:ext>
+            </p:extLst>
+          </p:nvPr>
+        </p:nvGraphicFramePr>
+        <p:xfrm>
+          <a:off x="548640" y="3337560"/>
+          <a:ext cx="11064240" cy="914400"/>
+        </p:xfrm>
+        <a:graphic>
+          <a:graphicData uri="http://schemas.openxmlformats.org/drawingml/2006/table">
+            <a:tbl>
+              <a:tblPr/>
+              <a:tblGrid>
+                <a:gridCol w="3931920"/>
+                <a:gridCol w="2377440"/>
+                <a:gridCol w="2377440"/>
+                <a:gridCol w="2377440"/>
+              </a:tblGrid>
+              <a:tr h="457200">
+                <a:tc>
+                  <a:txBody>
+                    <a:bodyPr/>
+                    <a:lstStyle/>
+                    <a:p>
+                      <a:pPr indent="0" marL="0">
+                        <a:buNone/>
+                      </a:pPr>
+                      <a:r>
+                        <a:rPr lang="en-US" sz="1400" b="1" dirty="0">
+                          <a:solidFill>
+                            <a:srgbClr val="FFFFFF"/>
+                          </a:solidFill>
+                          <a:latin typeface="Calibri" pitchFamily="34" charset="0"/>
+                          <a:ea typeface="Calibri" pitchFamily="34" charset="-122"/>
+                          <a:cs typeface="Calibri" pitchFamily="34" charset="-120"/>
+                        </a:rPr>
+                        <a:t>60 vehicles, 3 seeds</a:t>
+                      </a:r>
+                      <a:endParaRPr lang="en-US" sz="1400" dirty="0">
+                        <a:latin typeface="Calibri" charset="0"/>
+                        <a:ea typeface="Calibri" charset="0"/>
+                        <a:cs typeface="Calibri" charset="0"/>
+                      </a:endParaRPr>
+                    </a:p>
+                  </a:txBody>
+                  <a:tcPr marL="91440" marR="91440" marT="45720" marB="45720" anchor="ctr">
+                    <a:lnL w="9525" cap="flat" cmpd="sng" algn="ctr">
+                      <a:solidFill>
+                        <a:srgbClr val="D5DCE3"/>
+                      </a:solidFill>
+                      <a:prstDash val="solid"/>
+                      <a:round/>
+                      <a:headEnd type="none" w="med" len="med"/>
+                      <a:tailEnd type="none" w="med" len="med"/>
+                    </a:lnL>
+                    <a:lnR w="9525" cap="flat" cmpd="sng" algn="ctr">
+                      <a:solidFill>
+                        <a:srgbClr val="D5DCE3"/>
+                      </a:solidFill>
+                      <a:prstDash val="solid"/>
+                      <a:round/>
+                      <a:headEnd type="none" w="med" len="med"/>
+                      <a:tailEnd type="none" w="med" len="med"/>
+                    </a:lnR>
+                    <a:lnT w="9525" cap="flat" cmpd="sng" algn="ctr">
+                      <a:solidFill>
+                        <a:srgbClr val="D5DCE3"/>
+                      </a:solidFill>
+                      <a:prstDash val="solid"/>
+                      <a:round/>
+                      <a:headEnd type="none" w="med" len="med"/>
+                      <a:tailEnd type="none" w="med" len="med"/>
+                    </a:lnT>
+                    <a:lnB w="9525" cap="flat" cmpd="sng" algn="ctr">
+                      <a:solidFill>
+                        <a:srgbClr val="D5DCE3"/>
+                      </a:solidFill>
+                      <a:prstDash val="solid"/>
+                      <a:round/>
+                      <a:headEnd type="none" w="med" len="med"/>
+                      <a:tailEnd type="none" w="med" len="med"/>
+                    </a:lnB>
+                    <a:solidFill>
+                      <a:srgbClr val="1F2A36"/>
+                    </a:solidFill>
+                  </a:tcPr>
+                </a:tc>
+                <a:tc>
+                  <a:txBody>
+                    <a:bodyPr/>
+                    <a:lstStyle/>
+                    <a:p>
+                      <a:pPr indent="0" marL="0">
+                        <a:buNone/>
+                      </a:pPr>
+                      <a:r>
+                        <a:rPr lang="en-US" sz="1400" b="1" dirty="0">
+                          <a:solidFill>
+                            <a:srgbClr val="FFFFFF"/>
+                          </a:solidFill>
+                          <a:latin typeface="Calibri" pitchFamily="34" charset="0"/>
+                          <a:ea typeface="Calibri" pitchFamily="34" charset="-122"/>
+                          <a:cs typeface="Calibri" pitchFamily="34" charset="-120"/>
+                        </a:rPr>
+                        <a:t>Ours</a:t>
+                      </a:r>
+                      <a:endParaRPr lang="en-US" sz="1400" dirty="0">
+                        <a:latin typeface="Calibri" charset="0"/>
+                        <a:ea typeface="Calibri" charset="0"/>
+                        <a:cs typeface="Calibri" charset="0"/>
+                      </a:endParaRPr>
+                    </a:p>
+                  </a:txBody>
+                  <a:tcPr marL="91440" marR="91440" marT="45720" marB="45720" anchor="ctr">
+                    <a:lnL w="9525" cap="flat" cmpd="sng" algn="ctr">
+                      <a:solidFill>
+                        <a:srgbClr val="D5DCE3"/>
+                      </a:solidFill>
+                      <a:prstDash val="solid"/>
+                      <a:round/>
+                      <a:headEnd type="none" w="med" len="med"/>
+                      <a:tailEnd type="none" w="med" len="med"/>
+                    </a:lnL>
+                    <a:lnR w="9525" cap="flat" cmpd="sng" algn="ctr">
+                      <a:solidFill>
+                        <a:srgbClr val="D5DCE3"/>
+                      </a:solidFill>
+                      <a:prstDash val="solid"/>
+                      <a:round/>
+                      <a:headEnd type="none" w="med" len="med"/>
+                      <a:tailEnd type="none" w="med" len="med"/>
+                    </a:lnR>
+                    <a:lnT w="9525" cap="flat" cmpd="sng" algn="ctr">
+                      <a:solidFill>
+                        <a:srgbClr val="D5DCE3"/>
+                      </a:solidFill>
+                      <a:prstDash val="solid"/>
+                      <a:round/>
+                      <a:headEnd type="none" w="med" len="med"/>
+                      <a:tailEnd type="none" w="med" len="med"/>
+                    </a:lnT>
+                    <a:lnB w="9525" cap="flat" cmpd="sng" algn="ctr">
+                      <a:solidFill>
+                        <a:srgbClr val="D5DCE3"/>
+                      </a:solidFill>
+                      <a:prstDash val="solid"/>
+                      <a:round/>
+                      <a:headEnd type="none" w="med" len="med"/>
+                      <a:tailEnd type="none" w="med" len="med"/>
+                    </a:lnB>
+                    <a:solidFill>
+                      <a:srgbClr val="1F2A36"/>
+                    </a:solidFill>
+                  </a:tcPr>
+                </a:tc>
+                <a:tc>
+                  <a:txBody>
+                    <a:bodyPr/>
+                    <a:lstStyle/>
+                    <a:p>
+                      <a:pPr indent="0" marL="0">
+                        <a:buNone/>
+                      </a:pPr>
+                      <a:r>
+                        <a:rPr lang="en-US" sz="1400" b="1" dirty="0">
+                          <a:solidFill>
+                            <a:srgbClr val="FFFFFF"/>
+                          </a:solidFill>
+                          <a:latin typeface="Calibri" pitchFamily="34" charset="0"/>
+                          <a:ea typeface="Calibri" pitchFamily="34" charset="-122"/>
+                          <a:cs typeface="Calibri" pitchFamily="34" charset="-120"/>
+                        </a:rPr>
+                        <a:t>ECDSA</a:t>
+                      </a:r>
+                      <a:endParaRPr lang="en-US" sz="1400" dirty="0">
+                        <a:latin typeface="Calibri" charset="0"/>
+                        <a:ea typeface="Calibri" charset="0"/>
+                        <a:cs typeface="Calibri" charset="0"/>
+                      </a:endParaRPr>
+                    </a:p>
+                  </a:txBody>
+                  <a:tcPr marL="91440" marR="91440" marT="45720" marB="45720" anchor="ctr">
+                    <a:lnL w="9525" cap="flat" cmpd="sng" algn="ctr">
+                      <a:solidFill>
+                        <a:srgbClr val="D5DCE3"/>
+                      </a:solidFill>
+                      <a:prstDash val="solid"/>
+                      <a:round/>
+                      <a:headEnd type="none" w="med" len="med"/>
+                      <a:tailEnd type="none" w="med" len="med"/>
+                    </a:lnL>
+                    <a:lnR w="9525" cap="flat" cmpd="sng" algn="ctr">
+                      <a:solidFill>
+                        <a:srgbClr val="D5DCE3"/>
+                      </a:solidFill>
+                      <a:prstDash val="solid"/>
+                      <a:round/>
+                      <a:headEnd type="none" w="med" len="med"/>
+                      <a:tailEnd type="none" w="med" len="med"/>
+                    </a:lnR>
+                    <a:lnT w="9525" cap="flat" cmpd="sng" algn="ctr">
+                      <a:solidFill>
+                        <a:srgbClr val="D5DCE3"/>
+                      </a:solidFill>
+                      <a:prstDash val="solid"/>
+                      <a:round/>
+                      <a:headEnd type="none" w="med" len="med"/>
+                      <a:tailEnd type="none" w="med" len="med"/>
+                    </a:lnT>
+                    <a:lnB w="9525" cap="flat" cmpd="sng" algn="ctr">
+                      <a:solidFill>
+                        <a:srgbClr val="D5DCE3"/>
+                      </a:solidFill>
+                      <a:prstDash val="solid"/>
+                      <a:round/>
+                      <a:headEnd type="none" w="med" len="med"/>
+                      <a:tailEnd type="none" w="med" len="med"/>
+                    </a:lnB>
+                    <a:solidFill>
+                      <a:srgbClr val="1F2A36"/>
+                    </a:solidFill>
+                  </a:tcPr>
+                </a:tc>
+                <a:tc>
+                  <a:txBody>
+                    <a:bodyPr/>
+                    <a:lstStyle/>
+                    <a:p>
+                      <a:pPr indent="0" marL="0">
+                        <a:buNone/>
+                      </a:pPr>
+                      <a:r>
+                        <a:rPr lang="en-US" sz="1400" b="1" dirty="0">
+                          <a:solidFill>
+                            <a:srgbClr val="FFFFFF"/>
+                          </a:solidFill>
+                          <a:latin typeface="Calibri" pitchFamily="34" charset="0"/>
+                          <a:ea typeface="Calibri" pitchFamily="34" charset="-122"/>
+                          <a:cs typeface="Calibri" pitchFamily="34" charset="-120"/>
+                        </a:rPr>
+                        <a:t>Central</a:t>
+                      </a:r>
+                      <a:endParaRPr lang="en-US" sz="1400" dirty="0">
+                        <a:latin typeface="Calibri" charset="0"/>
+                        <a:ea typeface="Calibri" charset="0"/>
+                        <a:cs typeface="Calibri" charset="0"/>
+                      </a:endParaRPr>
+                    </a:p>
+                  </a:txBody>
+                  <a:tcPr marL="91440" marR="91440" marT="45720" marB="45720" anchor="ctr">
+                    <a:lnL w="9525" cap="flat" cmpd="sng" algn="ctr">
+                      <a:solidFill>
+                        <a:srgbClr val="D5DCE3"/>
+                      </a:solidFill>
+                      <a:prstDash val="solid"/>
+                      <a:round/>
+                      <a:headEnd type="none" w="med" len="med"/>
+                      <a:tailEnd type="none" w="med" len="med"/>
+                    </a:lnL>
+                    <a:lnR w="9525" cap="flat" cmpd="sng" algn="ctr">
+                      <a:solidFill>
+                        <a:srgbClr val="D5DCE3"/>
+                      </a:solidFill>
+                      <a:prstDash val="solid"/>
+                      <a:round/>
+                      <a:headEnd type="none" w="med" len="med"/>
+                      <a:tailEnd type="none" w="med" len="med"/>
+                    </a:lnR>
+                    <a:lnT w="9525" cap="flat" cmpd="sng" algn="ctr">
+                      <a:solidFill>
+                        <a:srgbClr val="D5DCE3"/>
+                      </a:solidFill>
+                      <a:prstDash val="solid"/>
+                      <a:round/>
+                      <a:headEnd type="none" w="med" len="med"/>
+                      <a:tailEnd type="none" w="med" len="med"/>
+                    </a:lnT>
+                    <a:lnB w="9525" cap="flat" cmpd="sng" algn="ctr">
+                      <a:solidFill>
+                        <a:srgbClr val="D5DCE3"/>
+                      </a:solidFill>
+                      <a:prstDash val="solid"/>
+                      <a:round/>
+                      <a:headEnd type="none" w="med" len="med"/>
+                      <a:tailEnd type="none" w="med" len="med"/>
+                    </a:lnB>
+                    <a:solidFill>
+                      <a:srgbClr val="1F2A36"/>
+                    </a:solidFill>
+                  </a:tcPr>
+                </a:tc>
+              </a:tr>
+              <a:tr h="457200">
+                <a:tc>
+                  <a:txBody>
+                    <a:bodyPr/>
+                    <a:lstStyle/>
+                    <a:p>
+                      <a:pPr indent="0" marL="0">
+                        <a:buNone/>
+                      </a:pPr>
+                      <a:r>
+                        <a:rPr lang="en-US" sz="1400" dirty="0">
+                          <a:solidFill>
+                            <a:srgbClr val="1F2A36"/>
+                          </a:solidFill>
+                          <a:latin typeface="Calibri" pitchFamily="34" charset="0"/>
+                          <a:ea typeface="Calibri" pitchFamily="34" charset="-122"/>
+                          <a:cs typeface="Calibri" pitchFamily="34" charset="-120"/>
+                        </a:rPr>
+                        <a:t>Auth / handover latency, median</a:t>
+                      </a:r>
+                      <a:endParaRPr lang="en-US" sz="1400" dirty="0">
+                        <a:latin typeface="Calibri" charset="0"/>
+                        <a:ea typeface="Calibri" charset="0"/>
+                        <a:cs typeface="Calibri" charset="0"/>
+                      </a:endParaRPr>
+                    </a:p>
+                  </a:txBody>
+                  <a:tcPr marL="91440" marR="91440" marT="45720" marB="45720" anchor="ctr">
+                    <a:lnL w="9525" cap="flat" cmpd="sng" algn="ctr">
+                      <a:solidFill>
+                        <a:srgbClr val="D5DCE3"/>
+                      </a:solidFill>
+                      <a:prstDash val="solid"/>
+                      <a:round/>
+                      <a:headEnd type="none" w="med" len="med"/>
+                      <a:tailEnd type="none" w="med" len="med"/>
+                    </a:lnL>
+                    <a:lnR w="9525" cap="flat" cmpd="sng" algn="ctr">
+                      <a:solidFill>
+                        <a:srgbClr val="D5DCE3"/>
+                      </a:solidFill>
+                      <a:prstDash val="solid"/>
+                      <a:round/>
+                      <a:headEnd type="none" w="med" len="med"/>
+                      <a:tailEnd type="none" w="med" len="med"/>
+                    </a:lnR>
+                    <a:lnT w="9525" cap="flat" cmpd="sng" algn="ctr">
+                      <a:solidFill>
+                        <a:srgbClr val="D5DCE3"/>
+                      </a:solidFill>
+                      <a:prstDash val="solid"/>
+                      <a:round/>
+                      <a:headEnd type="none" w="med" len="med"/>
+                      <a:tailEnd type="none" w="med" len="med"/>
+                    </a:lnT>
+                    <a:lnB w="9525" cap="flat" cmpd="sng" algn="ctr">
+                      <a:solidFill>
+                        <a:srgbClr val="D5DCE3"/>
+                      </a:solidFill>
+                      <a:prstDash val="solid"/>
+                      <a:round/>
+                      <a:headEnd type="none" w="med" len="med"/>
+                      <a:tailEnd type="none" w="med" len="med"/>
+                    </a:lnB>
+                    <a:solidFill>
+                      <a:srgbClr val="FFFFFF"/>
+                    </a:solidFill>
+                  </a:tcPr>
+                </a:tc>
+                <a:tc>
+                  <a:txBody>
+                    <a:bodyPr/>
+                    <a:lstStyle/>
+                    <a:p>
+                      <a:pPr indent="0" marL="0">
+                        <a:buNone/>
+                      </a:pPr>
+                      <a:r>
+                        <a:rPr lang="en-US" sz="1400" dirty="0">
+                          <a:solidFill>
+                            <a:srgbClr val="1F2A36"/>
+                          </a:solidFill>
+                          <a:latin typeface="Calibri" pitchFamily="34" charset="0"/>
+                          <a:ea typeface="Calibri" pitchFamily="34" charset="-122"/>
+                          <a:cs typeface="Calibri" pitchFamily="34" charset="-120"/>
+                        </a:rPr>
+                        <a:t>1.60 / 1.06 ms</a:t>
+                      </a:r>
+                      <a:endParaRPr lang="en-US" sz="1400" dirty="0">
+                        <a:latin typeface="Calibri" charset="0"/>
+                        <a:ea typeface="Calibri" charset="0"/>
+                        <a:cs typeface="Calibri" charset="0"/>
+                      </a:endParaRPr>
+                    </a:p>
+                  </a:txBody>
+                  <a:tcPr marL="91440" marR="91440" marT="45720" marB="45720" anchor="ctr">
+                    <a:lnL w="9525" cap="flat" cmpd="sng" algn="ctr">
+                      <a:solidFill>
+                        <a:srgbClr val="D5DCE3"/>
+                      </a:solidFill>
+                      <a:prstDash val="solid"/>
+                      <a:round/>
+                      <a:headEnd type="none" w="med" len="med"/>
+                      <a:tailEnd type="none" w="med" len="med"/>
+                    </a:lnL>
+                    <a:lnR w="9525" cap="flat" cmpd="sng" algn="ctr">
+                      <a:solidFill>
+                        <a:srgbClr val="D5DCE3"/>
+                      </a:solidFill>
+                      <a:prstDash val="solid"/>
+                      <a:round/>
+                      <a:headEnd type="none" w="med" len="med"/>
+                      <a:tailEnd type="none" w="med" len="med"/>
+                    </a:lnR>
+                    <a:lnT w="9525" cap="flat" cmpd="sng" algn="ctr">
+                      <a:solidFill>
+                        <a:srgbClr val="D5DCE3"/>
+                      </a:solidFill>
+                      <a:prstDash val="solid"/>
+                      <a:round/>
+                      <a:headEnd type="none" w="med" len="med"/>
+                      <a:tailEnd type="none" w="med" len="med"/>
+                    </a:lnT>
+                    <a:lnB w="9525" cap="flat" cmpd="sng" algn="ctr">
+                      <a:solidFill>
+                        <a:srgbClr val="D5DCE3"/>
+                      </a:solidFill>
+                      <a:prstDash val="solid"/>
+                      <a:round/>
+                      <a:headEnd type="none" w="med" len="med"/>
+                      <a:tailEnd type="none" w="med" len="med"/>
+                    </a:lnB>
+                    <a:solidFill>
+                      <a:srgbClr val="FFFFFF"/>
+                    </a:solidFill>
+                  </a:tcPr>
+                </a:tc>
+                <a:tc>
+                  <a:txBody>
+                    <a:bodyPr/>
+                    <a:lstStyle/>
+                    <a:p>
+                      <a:pPr indent="0" marL="0">
+                        <a:buNone/>
+                      </a:pPr>
+                      <a:r>
+                        <a:rPr lang="en-US" sz="1400" dirty="0">
+                          <a:solidFill>
+                            <a:srgbClr val="1F2A36"/>
+                          </a:solidFill>
+                          <a:latin typeface="Calibri" pitchFamily="34" charset="0"/>
+                          <a:ea typeface="Calibri" pitchFamily="34" charset="-122"/>
+                          <a:cs typeface="Calibri" pitchFamily="34" charset="-120"/>
+                        </a:rPr>
+                        <a:t>1.08 / 0.94 ms</a:t>
+                      </a:r>
+                      <a:endParaRPr lang="en-US" sz="1400" dirty="0">
+                        <a:latin typeface="Calibri" charset="0"/>
+                        <a:ea typeface="Calibri" charset="0"/>
+                        <a:cs typeface="Calibri" charset="0"/>
+                      </a:endParaRPr>
+                    </a:p>
+                  </a:txBody>
+                  <a:tcPr marL="91440" marR="91440" marT="45720" marB="45720" anchor="ctr">
+                    <a:lnL w="9525" cap="flat" cmpd="sng" algn="ctr">
+                      <a:solidFill>
+                        <a:srgbClr val="D5DCE3"/>
+                      </a:solidFill>
+                      <a:prstDash val="solid"/>
+                      <a:round/>
+                      <a:headEnd type="none" w="med" len="med"/>
+                      <a:tailEnd type="none" w="med" len="med"/>
+                    </a:lnL>
+                    <a:lnR w="9525" cap="flat" cmpd="sng" algn="ctr">
+                      <a:solidFill>
+                        <a:srgbClr val="D5DCE3"/>
+                      </a:solidFill>
+                      <a:prstDash val="solid"/>
+                      <a:round/>
+                      <a:headEnd type="none" w="med" len="med"/>
+                      <a:tailEnd type="none" w="med" len="med"/>
+                    </a:lnR>
+                    <a:lnT w="9525" cap="flat" cmpd="sng" algn="ctr">
+                      <a:solidFill>
+                        <a:srgbClr val="D5DCE3"/>
+                      </a:solidFill>
+                      <a:prstDash val="solid"/>
+                      <a:round/>
+                      <a:headEnd type="none" w="med" len="med"/>
+                      <a:tailEnd type="none" w="med" len="med"/>
+                    </a:lnT>
+                    <a:lnB w="9525" cap="flat" cmpd="sng" algn="ctr">
+                      <a:solidFill>
+                        <a:srgbClr val="D5DCE3"/>
+                      </a:solidFill>
+                      <a:prstDash val="solid"/>
+                      <a:round/>
+                      <a:headEnd type="none" w="med" len="med"/>
+                      <a:tailEnd type="none" w="med" len="med"/>
+                    </a:lnB>
+                    <a:solidFill>
+                      <a:srgbClr val="FFFFFF"/>
+                    </a:solidFill>
+                  </a:tcPr>
+                </a:tc>
+                <a:tc>
+                  <a:txBody>
+                    <a:bodyPr/>
+                    <a:lstStyle/>
+                    <a:p>
+                      <a:pPr indent="0" marL="0">
+                        <a:buNone/>
+                      </a:pPr>
+                      <a:r>
+                        <a:rPr lang="en-US" sz="1400" dirty="0">
+                          <a:solidFill>
+                            <a:srgbClr val="1F2A36"/>
+                          </a:solidFill>
+                          <a:latin typeface="Calibri" pitchFamily="34" charset="0"/>
+                          <a:ea typeface="Calibri" pitchFamily="34" charset="-122"/>
+                          <a:cs typeface="Calibri" pitchFamily="34" charset="-120"/>
+                        </a:rPr>
+                        <a:t>21.9 / 21.8 ms</a:t>
+                      </a:r>
+                      <a:endParaRPr lang="en-US" sz="1400" dirty="0">
+                        <a:latin typeface="Calibri" charset="0"/>
+                        <a:ea typeface="Calibri" charset="0"/>
+                        <a:cs typeface="Calibri" charset="0"/>
+                      </a:endParaRPr>
+                    </a:p>
+                  </a:txBody>
+                  <a:tcPr marL="91440" marR="91440" marT="45720" marB="45720" anchor="ctr">
+                    <a:lnL w="9525" cap="flat" cmpd="sng" algn="ctr">
+                      <a:solidFill>
+                        <a:srgbClr val="D5DCE3"/>
+                      </a:solidFill>
+                      <a:prstDash val="solid"/>
+                      <a:round/>
+                      <a:headEnd type="none" w="med" len="med"/>
+                      <a:tailEnd type="none" w="med" len="med"/>
+                    </a:lnL>
+                    <a:lnR w="9525" cap="flat" cmpd="sng" algn="ctr">
+                      <a:solidFill>
+                        <a:srgbClr val="D5DCE3"/>
+                      </a:solidFill>
+                      <a:prstDash val="solid"/>
+                      <a:round/>
+                      <a:headEnd type="none" w="med" len="med"/>
+                      <a:tailEnd type="none" w="med" len="med"/>
+                    </a:lnR>
+                    <a:lnT w="9525" cap="flat" cmpd="sng" algn="ctr">
+                      <a:solidFill>
+                        <a:srgbClr val="D5DCE3"/>
+                      </a:solidFill>
+                      <a:prstDash val="solid"/>
+                      <a:round/>
+                      <a:headEnd type="none" w="med" len="med"/>
+                      <a:tailEnd type="none" w="med" len="med"/>
+                    </a:lnT>
+                    <a:lnB w="9525" cap="flat" cmpd="sng" algn="ctr">
+                      <a:solidFill>
+                        <a:srgbClr val="D5DCE3"/>
+                      </a:solidFill>
+                      <a:prstDash val="solid"/>
+                      <a:round/>
+                      <a:headEnd type="none" w="med" len="med"/>
+                      <a:tailEnd type="none" w="med" len="med"/>
+                    </a:lnB>
+                    <a:solidFill>
+                      <a:srgbClr val="FFFFFF"/>
+                    </a:solidFill>
+                  </a:tcPr>
+                </a:tc>
+              </a:tr>
+              <a:tr h="457200">
+                <a:tc>
+                  <a:txBody>
+                    <a:bodyPr/>
+                    <a:lstStyle/>
+                    <a:p>
+                      <a:pPr indent="0" marL="0">
+                        <a:buNone/>
+                      </a:pPr>
+                      <a:r>
+                        <a:rPr lang="en-US" sz="1400" dirty="0">
+                          <a:solidFill>
+                            <a:srgbClr val="1F2A36"/>
+                          </a:solidFill>
+                          <a:latin typeface="Calibri" pitchFamily="34" charset="0"/>
+                          <a:ea typeface="Calibri" pitchFamily="34" charset="-122"/>
+                          <a:cs typeface="Calibri" pitchFamily="34" charset="-120"/>
+                        </a:rPr>
+                        <a:t>BSM delivery / channel busy</a:t>
+                      </a:r>
+                      <a:endParaRPr lang="en-US" sz="1400" dirty="0">
+                        <a:latin typeface="Calibri" charset="0"/>
+                        <a:ea typeface="Calibri" charset="0"/>
+                        <a:cs typeface="Calibri" charset="0"/>
+                      </a:endParaRPr>
+                    </a:p>
+                  </a:txBody>
+                  <a:tcPr marL="91440" marR="91440" marT="45720" marB="45720" anchor="ctr">
+                    <a:lnL w="9525" cap="flat" cmpd="sng" algn="ctr">
+                      <a:solidFill>
+                        <a:srgbClr val="D5DCE3"/>
+                      </a:solidFill>
+                      <a:prstDash val="solid"/>
+                      <a:round/>
+                      <a:headEnd type="none" w="med" len="med"/>
+                      <a:tailEnd type="none" w="med" len="med"/>
+                    </a:lnL>
+                    <a:lnR w="9525" cap="flat" cmpd="sng" algn="ctr">
+                      <a:solidFill>
+                        <a:srgbClr val="D5DCE3"/>
+                      </a:solidFill>
+                      <a:prstDash val="solid"/>
+                      <a:round/>
+                      <a:headEnd type="none" w="med" len="med"/>
+                      <a:tailEnd type="none" w="med" len="med"/>
+                    </a:lnR>
+                    <a:lnT w="9525" cap="flat" cmpd="sng" algn="ctr">
+                      <a:solidFill>
+                        <a:srgbClr val="D5DCE3"/>
+                      </a:solidFill>
+                      <a:prstDash val="solid"/>
+                      <a:round/>
+                      <a:headEnd type="none" w="med" len="med"/>
+                      <a:tailEnd type="none" w="med" len="med"/>
+                    </a:lnT>
+                    <a:lnB w="9525" cap="flat" cmpd="sng" algn="ctr">
+                      <a:solidFill>
+                        <a:srgbClr val="D5DCE3"/>
+                      </a:solidFill>
+                      <a:prstDash val="solid"/>
+                      <a:round/>
+                      <a:headEnd type="none" w="med" len="med"/>
+                      <a:tailEnd type="none" w="med" len="med"/>
+                    </a:lnB>
+                    <a:solidFill>
+                      <a:srgbClr val="FFFFFF"/>
+                    </a:solidFill>
+                  </a:tcPr>
+                </a:tc>
+                <a:tc>
+                  <a:txBody>
+                    <a:bodyPr/>
+                    <a:lstStyle/>
+                    <a:p>
+                      <a:pPr indent="0" marL="0">
+                        <a:buNone/>
+                      </a:pPr>
+                      <a:r>
+                        <a:rPr lang="en-US" sz="1400" dirty="0">
+                          <a:solidFill>
+                            <a:srgbClr val="1F2A36"/>
+                          </a:solidFill>
+                          <a:latin typeface="Calibri" pitchFamily="34" charset="0"/>
+                          <a:ea typeface="Calibri" pitchFamily="34" charset="-122"/>
+                          <a:cs typeface="Calibri" pitchFamily="34" charset="-120"/>
+                        </a:rPr>
+                        <a:t>0.991 / 8.3 %</a:t>
+                      </a:r>
+                      <a:endParaRPr lang="en-US" sz="1400" dirty="0">
+                        <a:latin typeface="Calibri" charset="0"/>
+                        <a:ea typeface="Calibri" charset="0"/>
+                        <a:cs typeface="Calibri" charset="0"/>
+                      </a:endParaRPr>
+                    </a:p>
+                  </a:txBody>
+                  <a:tcPr marL="91440" marR="91440" marT="45720" marB="45720" anchor="ctr">
+                    <a:lnL w="9525" cap="flat" cmpd="sng" algn="ctr">
+                      <a:solidFill>
+                        <a:srgbClr val="D5DCE3"/>
+                      </a:solidFill>
+                      <a:prstDash val="solid"/>
+                      <a:round/>
+                      <a:headEnd type="none" w="med" len="med"/>
+                      <a:tailEnd type="none" w="med" len="med"/>
+                    </a:lnL>
+                    <a:lnR w="9525" cap="flat" cmpd="sng" algn="ctr">
+                      <a:solidFill>
+                        <a:srgbClr val="D5DCE3"/>
+                      </a:solidFill>
+                      <a:prstDash val="solid"/>
+                      <a:round/>
+                      <a:headEnd type="none" w="med" len="med"/>
+                      <a:tailEnd type="none" w="med" len="med"/>
+                    </a:lnR>
+                    <a:lnT w="9525" cap="flat" cmpd="sng" algn="ctr">
+                      <a:solidFill>
+                        <a:srgbClr val="D5DCE3"/>
+                      </a:solidFill>
+                      <a:prstDash val="solid"/>
+                      <a:round/>
+                      <a:headEnd type="none" w="med" len="med"/>
+                      <a:tailEnd type="none" w="med" len="med"/>
+                    </a:lnT>
+                    <a:lnB w="9525" cap="flat" cmpd="sng" algn="ctr">
+                      <a:solidFill>
+                        <a:srgbClr val="D5DCE3"/>
+                      </a:solidFill>
+                      <a:prstDash val="solid"/>
+                      <a:round/>
+                      <a:headEnd type="none" w="med" len="med"/>
+                      <a:tailEnd type="none" w="med" len="med"/>
+                    </a:lnB>
+                    <a:solidFill>
+                      <a:srgbClr val="FFFFFF"/>
+                    </a:solidFill>
+                  </a:tcPr>
+                </a:tc>
+                <a:tc>
+                  <a:txBody>
+                    <a:bodyPr/>
+                    <a:lstStyle/>
+                    <a:p>
+                      <a:pPr indent="0" marL="0">
+                        <a:buNone/>
+                      </a:pPr>
+                      <a:r>
+                        <a:rPr lang="en-US" sz="1400" dirty="0">
+                          <a:solidFill>
+                            <a:srgbClr val="1F2A36"/>
+                          </a:solidFill>
+                          <a:latin typeface="Calibri" pitchFamily="34" charset="0"/>
+                          <a:ea typeface="Calibri" pitchFamily="34" charset="-122"/>
+                          <a:cs typeface="Calibri" pitchFamily="34" charset="-120"/>
+                        </a:rPr>
+                        <a:t>0.992 / 6.7 %</a:t>
+                      </a:r>
+                      <a:endParaRPr lang="en-US" sz="1400" dirty="0">
+                        <a:latin typeface="Calibri" charset="0"/>
+                        <a:ea typeface="Calibri" charset="0"/>
+                        <a:cs typeface="Calibri" charset="0"/>
+                      </a:endParaRPr>
+                    </a:p>
+                  </a:txBody>
+                  <a:tcPr marL="91440" marR="91440" marT="45720" marB="45720" anchor="ctr">
+                    <a:lnL w="9525" cap="flat" cmpd="sng" algn="ctr">
+                      <a:solidFill>
+                        <a:srgbClr val="D5DCE3"/>
+                      </a:solidFill>
+                      <a:prstDash val="solid"/>
+                      <a:round/>
+                      <a:headEnd type="none" w="med" len="med"/>
+                      <a:tailEnd type="none" w="med" len="med"/>
+                    </a:lnL>
+                    <a:lnR w="9525" cap="flat" cmpd="sng" algn="ctr">
+                      <a:solidFill>
+                        <a:srgbClr val="D5DCE3"/>
+                      </a:solidFill>
+                      <a:prstDash val="solid"/>
+                      <a:round/>
+                      <a:headEnd type="none" w="med" len="med"/>
+                      <a:tailEnd type="none" w="med" len="med"/>
+                    </a:lnR>
+                    <a:lnT w="9525" cap="flat" cmpd="sng" algn="ctr">
+                      <a:solidFill>
+                        <a:srgbClr val="D5DCE3"/>
+                      </a:solidFill>
+                      <a:prstDash val="solid"/>
+                      <a:round/>
+                      <a:headEnd type="none" w="med" len="med"/>
+                      <a:tailEnd type="none" w="med" len="med"/>
+                    </a:lnT>
+                    <a:lnB w="9525" cap="flat" cmpd="sng" algn="ctr">
+                      <a:solidFill>
+                        <a:srgbClr val="D5DCE3"/>
+                      </a:solidFill>
+                      <a:prstDash val="solid"/>
+                      <a:round/>
+                      <a:headEnd type="none" w="med" len="med"/>
+                      <a:tailEnd type="none" w="med" len="med"/>
+                    </a:lnB>
+                    <a:solidFill>
+                      <a:srgbClr val="FFFFFF"/>
+                    </a:solidFill>
+                  </a:tcPr>
+                </a:tc>
+                <a:tc>
+                  <a:txBody>
+                    <a:bodyPr/>
+                    <a:lstStyle/>
+                    <a:p>
+                      <a:pPr indent="0" marL="0">
+                        <a:buNone/>
+                      </a:pPr>
+                      <a:r>
+                        <a:rPr lang="en-US" sz="1400" dirty="0">
+                          <a:solidFill>
+                            <a:srgbClr val="1F2A36"/>
+                          </a:solidFill>
+                          <a:latin typeface="Calibri" pitchFamily="34" charset="0"/>
+                          <a:ea typeface="Calibri" pitchFamily="34" charset="-122"/>
+                          <a:cs typeface="Calibri" pitchFamily="34" charset="-120"/>
+                        </a:rPr>
+                        <a:t>0.992 / 6.7 %</a:t>
+                      </a:r>
+                      <a:endParaRPr lang="en-US" sz="1400" dirty="0">
+                        <a:latin typeface="Calibri" charset="0"/>
+                        <a:ea typeface="Calibri" charset="0"/>
+                        <a:cs typeface="Calibri" charset="0"/>
+                      </a:endParaRPr>
+                    </a:p>
+                  </a:txBody>
+                  <a:tcPr marL="91440" marR="91440" marT="45720" marB="45720" anchor="ctr">
+                    <a:lnL w="9525" cap="flat" cmpd="sng" algn="ctr">
+                      <a:solidFill>
+                        <a:srgbClr val="D5DCE3"/>
+                      </a:solidFill>
+                      <a:prstDash val="solid"/>
+                      <a:round/>
+                      <a:headEnd type="none" w="med" len="med"/>
+                      <a:tailEnd type="none" w="med" len="med"/>
+                    </a:lnL>
+                    <a:lnR w="9525" cap="flat" cmpd="sng" algn="ctr">
+                      <a:solidFill>
+                        <a:srgbClr val="D5DCE3"/>
+                      </a:solidFill>
+                      <a:prstDash val="solid"/>
+                      <a:round/>
+                      <a:headEnd type="none" w="med" len="med"/>
+                      <a:tailEnd type="none" w="med" len="med"/>
+                    </a:lnR>
+                    <a:lnT w="9525" cap="flat" cmpd="sng" algn="ctr">
+                      <a:solidFill>
+                        <a:srgbClr val="D5DCE3"/>
+                      </a:solidFill>
+                      <a:prstDash val="solid"/>
+                      <a:round/>
+                      <a:headEnd type="none" w="med" len="med"/>
+                      <a:tailEnd type="none" w="med" len="med"/>
+                    </a:lnT>
+                    <a:lnB w="9525" cap="flat" cmpd="sng" algn="ctr">
+                      <a:solidFill>
+                        <a:srgbClr val="D5DCE3"/>
+                      </a:solidFill>
+                      <a:prstDash val="solid"/>
+                      <a:round/>
+                      <a:headEnd type="none" w="med" len="med"/>
+                      <a:tailEnd type="none" w="med" len="med"/>
+                    </a:lnB>
+                    <a:solidFill>
+                      <a:srgbClr val="FFFFFF"/>
+                    </a:solidFill>
+                  </a:tcPr>
+                </a:tc>
+              </a:tr>
+              <a:tr h="457200">
+                <a:tc>
+                  <a:txBody>
+                    <a:bodyPr/>
+                    <a:lstStyle/>
+                    <a:p>
+                      <a:pPr indent="0" marL="0">
+                        <a:buNone/>
+                      </a:pPr>
+                      <a:r>
+                        <a:rPr lang="en-US" sz="1400" dirty="0">
+                          <a:solidFill>
+                            <a:srgbClr val="1F2A36"/>
+                          </a:solidFill>
+                          <a:latin typeface="Calibri" pitchFamily="34" charset="0"/>
+                          <a:ea typeface="Calibri" pitchFamily="34" charset="-122"/>
+                          <a:cs typeface="Calibri" pitchFamily="34" charset="-120"/>
+                        </a:rPr>
+                        <a:t>Attackers reported / revoked, honest revoked</a:t>
+                      </a:r>
+                      <a:endParaRPr lang="en-US" sz="1400" dirty="0">
+                        <a:latin typeface="Calibri" charset="0"/>
+                        <a:ea typeface="Calibri" charset="0"/>
+                        <a:cs typeface="Calibri" charset="0"/>
+                      </a:endParaRPr>
+                    </a:p>
+                  </a:txBody>
+                  <a:tcPr marL="91440" marR="91440" marT="45720" marB="45720" anchor="ctr">
+                    <a:lnL w="9525" cap="flat" cmpd="sng" algn="ctr">
+                      <a:solidFill>
+                        <a:srgbClr val="D5DCE3"/>
+                      </a:solidFill>
+                      <a:prstDash val="solid"/>
+                      <a:round/>
+                      <a:headEnd type="none" w="med" len="med"/>
+                      <a:tailEnd type="none" w="med" len="med"/>
+                    </a:lnL>
+                    <a:lnR w="9525" cap="flat" cmpd="sng" algn="ctr">
+                      <a:solidFill>
+                        <a:srgbClr val="D5DCE3"/>
+                      </a:solidFill>
+                      <a:prstDash val="solid"/>
+                      <a:round/>
+                      <a:headEnd type="none" w="med" len="med"/>
+                      <a:tailEnd type="none" w="med" len="med"/>
+                    </a:lnR>
+                    <a:lnT w="9525" cap="flat" cmpd="sng" algn="ctr">
+                      <a:solidFill>
+                        <a:srgbClr val="D5DCE3"/>
+                      </a:solidFill>
+                      <a:prstDash val="solid"/>
+                      <a:round/>
+                      <a:headEnd type="none" w="med" len="med"/>
+                      <a:tailEnd type="none" w="med" len="med"/>
+                    </a:lnT>
+                    <a:lnB w="9525" cap="flat" cmpd="sng" algn="ctr">
+                      <a:solidFill>
+                        <a:srgbClr val="D5DCE3"/>
+                      </a:solidFill>
+                      <a:prstDash val="solid"/>
+                      <a:round/>
+                      <a:headEnd type="none" w="med" len="med"/>
+                      <a:tailEnd type="none" w="med" len="med"/>
+                    </a:lnB>
+                    <a:solidFill>
+                      <a:srgbClr val="FFFFFF"/>
+                    </a:solidFill>
+                  </a:tcPr>
+                </a:tc>
+                <a:tc>
+                  <a:txBody>
+                    <a:bodyPr/>
+                    <a:lstStyle/>
+                    <a:p>
+                      <a:pPr indent="0" marL="0">
+                        <a:buNone/>
+                      </a:pPr>
+                      <a:r>
+                        <a:rPr lang="en-US" sz="1400" dirty="0">
+                          <a:solidFill>
+                            <a:srgbClr val="1F2A36"/>
+                          </a:solidFill>
+                          <a:latin typeface="Calibri" pitchFamily="34" charset="0"/>
+                          <a:ea typeface="Calibri" pitchFamily="34" charset="-122"/>
+                          <a:cs typeface="Calibri" pitchFamily="34" charset="-120"/>
+                        </a:rPr>
+                        <a:t>100 / 100 %, 0</a:t>
+                      </a:r>
+                      <a:endParaRPr lang="en-US" sz="1400" dirty="0">
+                        <a:latin typeface="Calibri" charset="0"/>
+                        <a:ea typeface="Calibri" charset="0"/>
+                        <a:cs typeface="Calibri" charset="0"/>
+                      </a:endParaRPr>
+                    </a:p>
+                  </a:txBody>
+                  <a:tcPr marL="91440" marR="91440" marT="45720" marB="45720" anchor="ctr">
+                    <a:lnL w="9525" cap="flat" cmpd="sng" algn="ctr">
+                      <a:solidFill>
+                        <a:srgbClr val="D5DCE3"/>
+                      </a:solidFill>
+                      <a:prstDash val="solid"/>
+                      <a:round/>
+                      <a:headEnd type="none" w="med" len="med"/>
+                      <a:tailEnd type="none" w="med" len="med"/>
+                    </a:lnL>
+                    <a:lnR w="9525" cap="flat" cmpd="sng" algn="ctr">
+                      <a:solidFill>
+                        <a:srgbClr val="D5DCE3"/>
+                      </a:solidFill>
+                      <a:prstDash val="solid"/>
+                      <a:round/>
+                      <a:headEnd type="none" w="med" len="med"/>
+                      <a:tailEnd type="none" w="med" len="med"/>
+                    </a:lnR>
+                    <a:lnT w="9525" cap="flat" cmpd="sng" algn="ctr">
+                      <a:solidFill>
+                        <a:srgbClr val="D5DCE3"/>
+                      </a:solidFill>
+                      <a:prstDash val="solid"/>
+                      <a:round/>
+                      <a:headEnd type="none" w="med" len="med"/>
+                      <a:tailEnd type="none" w="med" len="med"/>
+                    </a:lnT>
+                    <a:lnB w="9525" cap="flat" cmpd="sng" algn="ctr">
+                      <a:solidFill>
+                        <a:srgbClr val="D5DCE3"/>
+                      </a:solidFill>
+                      <a:prstDash val="solid"/>
+                      <a:round/>
+                      <a:headEnd type="none" w="med" len="med"/>
+                      <a:tailEnd type="none" w="med" len="med"/>
+                    </a:lnB>
+                    <a:solidFill>
+                      <a:srgbClr val="FFFFFF"/>
+                    </a:solidFill>
+                  </a:tcPr>
+                </a:tc>
+                <a:tc>
+                  <a:txBody>
+                    <a:bodyPr/>
+                    <a:lstStyle/>
+                    <a:p>
+                      <a:pPr indent="0" marL="0">
+                        <a:buNone/>
+                      </a:pPr>
+                      <a:r>
+                        <a:rPr lang="en-US" sz="1400" dirty="0">
+                          <a:solidFill>
+                            <a:srgbClr val="1F2A36"/>
+                          </a:solidFill>
+                          <a:latin typeface="Calibri" pitchFamily="34" charset="0"/>
+                          <a:ea typeface="Calibri" pitchFamily="34" charset="-122"/>
+                          <a:cs typeface="Calibri" pitchFamily="34" charset="-120"/>
+                        </a:rPr>
+                        <a:t>100 / 100 %, 0</a:t>
+                      </a:r>
+                      <a:endParaRPr lang="en-US" sz="1400" dirty="0">
+                        <a:latin typeface="Calibri" charset="0"/>
+                        <a:ea typeface="Calibri" charset="0"/>
+                        <a:cs typeface="Calibri" charset="0"/>
+                      </a:endParaRPr>
+                    </a:p>
+                  </a:txBody>
+                  <a:tcPr marL="91440" marR="91440" marT="45720" marB="45720" anchor="ctr">
+                    <a:lnL w="9525" cap="flat" cmpd="sng" algn="ctr">
+                      <a:solidFill>
+                        <a:srgbClr val="D5DCE3"/>
+                      </a:solidFill>
+                      <a:prstDash val="solid"/>
+                      <a:round/>
+                      <a:headEnd type="none" w="med" len="med"/>
+                      <a:tailEnd type="none" w="med" len="med"/>
+                    </a:lnL>
+                    <a:lnR w="9525" cap="flat" cmpd="sng" algn="ctr">
+                      <a:solidFill>
+                        <a:srgbClr val="D5DCE3"/>
+                      </a:solidFill>
+                      <a:prstDash val="solid"/>
+                      <a:round/>
+                      <a:headEnd type="none" w="med" len="med"/>
+                      <a:tailEnd type="none" w="med" len="med"/>
+                    </a:lnR>
+                    <a:lnT w="9525" cap="flat" cmpd="sng" algn="ctr">
+                      <a:solidFill>
+                        <a:srgbClr val="D5DCE3"/>
+                      </a:solidFill>
+                      <a:prstDash val="solid"/>
+                      <a:round/>
+                      <a:headEnd type="none" w="med" len="med"/>
+                      <a:tailEnd type="none" w="med" len="med"/>
+                    </a:lnT>
+                    <a:lnB w="9525" cap="flat" cmpd="sng" algn="ctr">
+                      <a:solidFill>
+                        <a:srgbClr val="D5DCE3"/>
+                      </a:solidFill>
+                      <a:prstDash val="solid"/>
+                      <a:round/>
+                      <a:headEnd type="none" w="med" len="med"/>
+                      <a:tailEnd type="none" w="med" len="med"/>
+                    </a:lnB>
+                    <a:solidFill>
+                      <a:srgbClr val="FFFFFF"/>
+                    </a:solidFill>
+                  </a:tcPr>
+                </a:tc>
+                <a:tc>
+                  <a:txBody>
+                    <a:bodyPr/>
+                    <a:lstStyle/>
+                    <a:p>
+                      <a:pPr indent="0" marL="0">
+                        <a:buNone/>
+                      </a:pPr>
+                      <a:r>
+                        <a:rPr lang="en-US" sz="1400" dirty="0">
+                          <a:solidFill>
+                            <a:srgbClr val="1F2A36"/>
+                          </a:solidFill>
+                          <a:latin typeface="Calibri" pitchFamily="34" charset="0"/>
+                          <a:ea typeface="Calibri" pitchFamily="34" charset="-122"/>
+                          <a:cs typeface="Calibri" pitchFamily="34" charset="-120"/>
+                        </a:rPr>
+                        <a:t>100 / 100 %, 0</a:t>
+                      </a:r>
+                      <a:endParaRPr lang="en-US" sz="1400" dirty="0">
+                        <a:latin typeface="Calibri" charset="0"/>
+                        <a:ea typeface="Calibri" charset="0"/>
+                        <a:cs typeface="Calibri" charset="0"/>
+                      </a:endParaRPr>
+                    </a:p>
+                  </a:txBody>
+                  <a:tcPr marL="91440" marR="91440" marT="45720" marB="45720" anchor="ctr">
+                    <a:lnL w="9525" cap="flat" cmpd="sng" algn="ctr">
+                      <a:solidFill>
+                        <a:srgbClr val="D5DCE3"/>
+                      </a:solidFill>
+                      <a:prstDash val="solid"/>
+                      <a:round/>
+                      <a:headEnd type="none" w="med" len="med"/>
+                      <a:tailEnd type="none" w="med" len="med"/>
+                    </a:lnL>
+                    <a:lnR w="9525" cap="flat" cmpd="sng" algn="ctr">
+                      <a:solidFill>
+                        <a:srgbClr val="D5DCE3"/>
+                      </a:solidFill>
+                      <a:prstDash val="solid"/>
+                      <a:round/>
+                      <a:headEnd type="none" w="med" len="med"/>
+                      <a:tailEnd type="none" w="med" len="med"/>
+                    </a:lnR>
+                    <a:lnT w="9525" cap="flat" cmpd="sng" algn="ctr">
+                      <a:solidFill>
+                        <a:srgbClr val="D5DCE3"/>
+                      </a:solidFill>
+                      <a:prstDash val="solid"/>
+                      <a:round/>
+                      <a:headEnd type="none" w="med" len="med"/>
+                      <a:tailEnd type="none" w="med" len="med"/>
+                    </a:lnT>
+                    <a:lnB w="9525" cap="flat" cmpd="sng" algn="ctr">
+                      <a:solidFill>
+                        <a:srgbClr val="D5DCE3"/>
+                      </a:solidFill>
+                      <a:prstDash val="solid"/>
+                      <a:round/>
+                      <a:headEnd type="none" w="med" len="med"/>
+                      <a:tailEnd type="none" w="med" len="med"/>
+                    </a:lnB>
+                    <a:solidFill>
+                      <a:srgbClr val="FFFFFF"/>
+                    </a:solidFill>
+                  </a:tcPr>
+                </a:tc>
+              </a:tr>
+            </a:tbl>
+          </a:graphicData>
+        </a:graphic>
+      </p:graphicFrame>
+      <p:sp>
+        <p:nvSpPr>
+          <p:cNvPr id="12" name="Text 9"/>
+          <p:cNvSpPr txBox="1"/>
+          <p:nvPr/>
+        </p:nvSpPr>
+        <p:spPr>
+          <a:xfrm>
+            <a:off x="548640" y="5349240"/>
+            <a:ext cx="11064240" cy="548640"/>
+          </a:xfrm>
+          <a:prstGeom prst="rect">
+            <a:avLst/>
+          </a:prstGeom>
+          <a:noFill/>
+          <a:ln/>
+        </p:spPr>
+        <p:txBody>
+          <a:bodyPr wrap="square" lIns="0" tIns="0" rIns="0" bIns="0" rtlCol="0" anchor="ctr"/>
+          <a:lstStyle/>
+          <a:p>
+            <a:pPr indent="0" marL="0">
+              <a:buNone/>
+            </a:pPr>
+            <a:r>
+              <a:rPr lang="en-US" sz="1400" dirty="0">
+                <a:solidFill>
+                  <a:srgbClr val="1F2A36"/>
+                </a:solidFill>
+              </a:rPr>
+              <a:t>All six attacks on Fabric: 5 of 6 types fully revoked (const_pos 67 %, the two-RSU rule); 0 honest vehicles revoked; 45 runs, 0 ledger errors.</a:t>
+            </a:r>
+            <a:endParaRPr lang="en-US" sz="1400" dirty="0"/>
+          </a:p>
+        </p:txBody>
+      </p:sp>
+      <p:sp>
+        <p:nvSpPr>
+          <p:cNvPr id="13" name="Text 10"/>
+          <p:cNvSpPr txBox="1"/>
+          <p:nvPr/>
+        </p:nvSpPr>
+        <p:spPr>
+          <a:xfrm>
+            <a:off x="548640" y="6263640"/>
+            <a:ext cx="10515600" cy="320040"/>
+          </a:xfrm>
+          <a:prstGeom prst="rect">
+            <a:avLst/>
+          </a:prstGeom>
+          <a:noFill/>
+          <a:ln/>
+        </p:spPr>
+        <p:txBody>
+          <a:bodyPr wrap="square" lIns="0" tIns="0" rIns="0" bIns="0" rtlCol="0" anchor="ctr"/>
+          <a:lstStyle/>
+          <a:p>
+            <a:pPr indent="0" marL="0">
+              <a:buNone/>
+            </a:pPr>
+            <a:r>
+              <a:rPr lang="en-US" sz="1100" i="1" dirty="0">
+                <a:solidFill>
+                  <a:srgbClr val="5B6B7A"/>
+                </a:solidFill>
+              </a:rPr>
+              <a:t>Fabric 2.5.9, 2 organisations, Raft orderer, 500 ms batch timeout, TA + 9 RSU identities; ns-3 802.11p; grid, 120 s, 10 % attackers.</a:t>
+            </a:r>
+            <a:endParaRPr lang="en-US" sz="1100" dirty="0"/>
+          </a:p>
+        </p:txBody>
+      </p:sp>
+      <p:sp>
+        <p:nvSpPr>
+          <p:cNvPr id="25" name="Slide Number Placeholder 0"/>
+          <p:cNvSpPr>
+            <a:spLocks noGrp="1"/>
+          </p:cNvSpPr>
+          <p:nvPr>
+            <p:ph type="sldNum" sz="quarter" idx="4294967295"/>
+          </p:nvPr>
+        </p:nvSpPr>
+        <p:spPr>
+          <a:xfrm>
+            <a:off x="11247120" y="6400800"/>
+            <a:ext cx="548640" cy="274320"/>
+          </a:xfrm>
+          <a:prstGeom prst="rect">
+            <a:avLst/>
+          </a:prstGeom>
+          <a:extLst>
+            <a:ext uri="{C572A759-6A51-4108-AA02-DFA0A04FC94B}">
+              <ma14:wrappingTextBoxFlag xmlns:ma14="http://schemas.microsoft.com/office/mac/drawingml/2011/main" val="0"/>
+            </a:ext>
+          </a:extLst>
+        </p:spPr>
+        <p:txBody>
+          <a:bodyPr/>
+          <a:lstStyle>
+            <a:lvl1pPr>
+              <a:defRPr sz="1000">
+                <a:solidFill>
+                  <a:srgbClr val="5B6B7A"/>
+                </a:solidFill>
+                <a:latin typeface="Calibri"/>
+                <a:ea typeface="Calibri"/>
+                <a:cs typeface="Calibri"/>
+              </a:defRPr>
+            </a:lvl1pPr>
+          </a:lstStyle>
+          <a:p>
+            <a:pPr algn="l"/>
+            <a:fld id="{F7021451-1387-4CA6-816F-3879F97B5CBC}" type="slidenum">
+              <a:rPr b="0" lang="en-US"/>
+              <a:t>7</a:t>
+            </a:fld>
+            <a:endParaRPr lang="en-US"/>
+          </a:p>
+        </p:txBody>
+      </p:sp>
+    </p:spTree>
+  </p:cSld>
+  <p:clrMapOvr>
+    <a:masterClrMapping/>
+  </p:clrMapOvr>
+</p:sld>
+</file>
+
+<file path=ppt/slides/slide8.xml><?xml version="1.0" encoding="utf-8"?>
+<p:sld xmlns:a="http://schemas.openxmlformats.org/drawingml/2006/main" xmlns:r="http://schemas.openxmlformats.org/officeDocument/2006/relationships" xmlns:p="http://schemas.openxmlformats.org/presentationml/2006/main">
+  <p:cSld name="Slide 8">
+    <p:spTree>
+      <p:nvGrpSpPr>
+        <p:cNvPr id="1" name=""/>
+        <p:cNvGrpSpPr/>
+        <p:nvPr/>
+      </p:nvGrpSpPr>
+      <p:grpSpPr>
+        <a:xfrm>
+          <a:off x="0" y="0"/>
+          <a:ext cx="0" cy="0"/>
+          <a:chOff x="0" y="0"/>
+          <a:chExt cx="0" cy="0"/>
+        </a:xfrm>
+      </p:grpSpPr>
+      <p:sp>
+        <p:nvSpPr>
+          <p:cNvPr id="2" name="Text 0"/>
+          <p:cNvSpPr/>
+          <p:nvPr>
+            <p:ph idx="100" type="title" hasCustomPrompt="1"/>
+          </p:nvPr>
+        </p:nvSpPr>
+        <p:spPr>
+          <a:xfrm>
+            <a:off x="548640" y="320040"/>
+            <a:ext cx="11064240" cy="822960"/>
+          </a:xfrm>
+          <a:prstGeom prst="rect">
+            <a:avLst/>
+          </a:prstGeom>
+          <a:noFill/>
+          <a:ln/>
+        </p:spPr>
+        <p:txBody>
+          <a:bodyPr wrap="square" lIns="0" tIns="0" rIns="0" bIns="0" rtlCol="0" anchor="ctr"/>
+          <a:lstStyle/>
+          <a:p>
+            <a:pPr indent="0" marL="0">
+              <a:buNone/>
+            </a:pPr>
+            <a:r>
+              <a:rPr lang="en-US" sz="3200" b="1" dirty="0">
+                <a:solidFill>
+                  <a:srgbClr val="1F2A36"/>
+                </a:solidFill>
+                <a:latin typeface="Cambria" pitchFamily="34" charset="0"/>
+                <a:ea typeface="Cambria" pitchFamily="34" charset="-122"/>
+                <a:cs typeface="Cambria" pitchFamily="34" charset="-120"/>
+              </a:rPr>
               <a:t>Authentication stays at a few milliseconds as traffic grows</a:t>
             </a:r>
             <a:endParaRPr lang="en-US" sz="3200" dirty="0"/>
@@ -15494,7 +17379,7 @@
             <a:pPr algn="l"/>
             <a:fld id="{F7021451-1387-4CA6-816F-3879F97B5CBC}" type="slidenum">
               <a:rPr b="0" lang="en-US"/>
-              <a:t>7</a:t>
+              <a:t>8</a:t>
             </a:fld>
             <a:endParaRPr lang="en-US"/>
           </a:p>
@@ -15508,9 +17393,9 @@
 </p:sld>
 </file>
 
-<file path=ppt/slides/slide8.xml><?xml version="1.0" encoding="utf-8"?>
+<file path=ppt/slides/slide9.xml><?xml version="1.0" encoding="utf-8"?>
 <p:sld xmlns:a="http://schemas.openxmlformats.org/drawingml/2006/main" xmlns:r="http://schemas.openxmlformats.org/officeDocument/2006/relationships" xmlns:p="http://schemas.openxmlformats.org/presentationml/2006/main">
-  <p:cSld name="Slide 8">
+  <p:cSld name="Slide 9">
     <p:spTree>
       <p:nvGrpSpPr>
         <p:cNvPr id="1" name=""/>
@@ -15629,188 +17514,6 @@
                 </a:solidFill>
               </a:rPr>
               <a:t>Same idea as the IEEE 1609.2 certificate digest. The digest is inside the signed payload and maps only to a ticket the RSU verified itself.</a:t>
-            </a:r>
-            <a:endParaRPr lang="en-US" sz="1100" dirty="0"/>
-          </a:p>
-        </p:txBody>
-      </p:sp>
-      <p:sp>
-        <p:nvSpPr>
-          <p:cNvPr id="25" name="Slide Number Placeholder 0"/>
-          <p:cNvSpPr>
-            <a:spLocks noGrp="1"/>
-          </p:cNvSpPr>
-          <p:nvPr>
-            <p:ph type="sldNum" sz="quarter" idx="4294967295"/>
-          </p:nvPr>
-        </p:nvSpPr>
-        <p:spPr>
-          <a:xfrm>
-            <a:off x="11247120" y="6400800"/>
-            <a:ext cx="548640" cy="274320"/>
-          </a:xfrm>
-          <a:prstGeom prst="rect">
-            <a:avLst/>
-          </a:prstGeom>
-          <a:extLst>
-            <a:ext uri="{C572A759-6A51-4108-AA02-DFA0A04FC94B}">
-              <ma14:wrappingTextBoxFlag xmlns:ma14="http://schemas.microsoft.com/office/mac/drawingml/2011/main" val="0"/>
-            </a:ext>
-          </a:extLst>
-        </p:spPr>
-        <p:txBody>
-          <a:bodyPr/>
-          <a:lstStyle>
-            <a:lvl1pPr>
-              <a:defRPr sz="1000">
-                <a:solidFill>
-                  <a:srgbClr val="5B6B7A"/>
-                </a:solidFill>
-                <a:latin typeface="Calibri"/>
-                <a:ea typeface="Calibri"/>
-                <a:cs typeface="Calibri"/>
-              </a:defRPr>
-            </a:lvl1pPr>
-          </a:lstStyle>
-          <a:p>
-            <a:pPr algn="l"/>
-            <a:fld id="{F7021451-1387-4CA6-816F-3879F97B5CBC}" type="slidenum">
-              <a:rPr b="0" lang="en-US"/>
-              <a:t>8</a:t>
-            </a:fld>
-            <a:endParaRPr lang="en-US"/>
-          </a:p>
-        </p:txBody>
-      </p:sp>
-    </p:spTree>
-  </p:cSld>
-  <p:clrMapOvr>
-    <a:masterClrMapping/>
-  </p:clrMapOvr>
-</p:sld>
-</file>
-
-<file path=ppt/slides/slide9.xml><?xml version="1.0" encoding="utf-8"?>
-<p:sld xmlns:a="http://schemas.openxmlformats.org/drawingml/2006/main" xmlns:r="http://schemas.openxmlformats.org/officeDocument/2006/relationships" xmlns:p="http://schemas.openxmlformats.org/presentationml/2006/main">
-  <p:cSld name="Slide 9">
-    <p:spTree>
-      <p:nvGrpSpPr>
-        <p:cNvPr id="1" name=""/>
-        <p:cNvGrpSpPr/>
-        <p:nvPr/>
-      </p:nvGrpSpPr>
-      <p:grpSpPr>
-        <a:xfrm>
-          <a:off x="0" y="0"/>
-          <a:ext cx="0" cy="0"/>
-          <a:chOff x="0" y="0"/>
-          <a:chExt cx="0" cy="0"/>
-        </a:xfrm>
-      </p:grpSpPr>
-      <p:sp>
-        <p:nvSpPr>
-          <p:cNvPr id="2" name="Text 0"/>
-          <p:cNvSpPr/>
-          <p:nvPr>
-            <p:ph idx="100" type="title" hasCustomPrompt="1"/>
-          </p:nvPr>
-        </p:nvSpPr>
-        <p:spPr>
-          <a:xfrm>
-            <a:off x="548640" y="320040"/>
-            <a:ext cx="11064240" cy="822960"/>
-          </a:xfrm>
-          <a:prstGeom prst="rect">
-            <a:avLst/>
-          </a:prstGeom>
-          <a:noFill/>
-          <a:ln/>
-        </p:spPr>
-        <p:txBody>
-          <a:bodyPr wrap="square" lIns="0" tIns="0" rIns="0" bIns="0" rtlCol="0" anchor="ctr"/>
-          <a:lstStyle/>
-          <a:p>
-            <a:pPr indent="0" marL="0">
-              <a:buNone/>
-            </a:pPr>
-            <a:r>
-              <a:rPr lang="en-US" sz="3200" b="1" dirty="0">
-                <a:solidFill>
-                  <a:srgbClr val="1F2A36"/>
-                </a:solidFill>
-                <a:latin typeface="Cambria" pitchFamily="34" charset="0"/>
-                <a:ea typeface="Cambria" pitchFamily="34" charset="-122"/>
-                <a:cs typeface="Cambria" pitchFamily="34" charset="-120"/>
-              </a:rPr>
-              <a:t>Every attack type is caught within about a second</a:t>
-            </a:r>
-            <a:endParaRPr lang="en-US" sz="3200" dirty="0"/>
-          </a:p>
-        </p:txBody>
-      </p:sp>
-      <p:graphicFrame>
-        <p:nvGraphicFramePr>
-          <p:cNvPr id="3" name="Chart 0" descr=""/>
-          <p:cNvGraphicFramePr/>
-          <p:nvPr/>
-        </p:nvGraphicFramePr>
-        <p:xfrm>
-          <a:off x="548640" y="1325880"/>
-          <a:ext cx="5669280" cy="4754880"/>
-        </p:xfrm>
-        <a:graphic xmlns:a="http://schemas.openxmlformats.org/drawingml/2006/main">
-          <a:graphicData uri="http://schemas.openxmlformats.org/drawingml/2006/chart">
-            <c:chart xmlns:c="http://schemas.openxmlformats.org/drawingml/2006/chart" r:id="rId1"/>
-          </a:graphicData>
-        </a:graphic>
-      </p:graphicFrame>
-      <p:graphicFrame>
-        <p:nvGraphicFramePr>
-          <p:cNvPr id="4" name="Chart 1" descr=""/>
-          <p:cNvGraphicFramePr/>
-          <p:nvPr/>
-        </p:nvGraphicFramePr>
-        <p:xfrm>
-          <a:off x="6400800" y="1325880"/>
-          <a:ext cx="5212080" cy="4754880"/>
-        </p:xfrm>
-        <a:graphic xmlns:a="http://schemas.openxmlformats.org/drawingml/2006/main">
-          <a:graphicData uri="http://schemas.openxmlformats.org/drawingml/2006/chart">
-            <c:chart xmlns:c="http://schemas.openxmlformats.org/drawingml/2006/chart" r:id="rId2"/>
-          </a:graphicData>
-        </a:graphic>
-      </p:graphicFrame>
-      <p:sp>
-        <p:nvSpPr>
-          <p:cNvPr id="5" name="Text 1"/>
-          <p:cNvSpPr txBox="1"/>
-          <p:nvPr/>
-        </p:nvSpPr>
-        <p:spPr>
-          <a:xfrm>
-            <a:off x="548640" y="6263640"/>
-            <a:ext cx="10515600" cy="320040"/>
-          </a:xfrm>
-          <a:prstGeom prst="rect">
-            <a:avLst/>
-          </a:prstGeom>
-          <a:noFill/>
-          <a:ln/>
-        </p:spPr>
-        <p:txBody>
-          <a:bodyPr wrap="square" lIns="0" tIns="0" rIns="0" bIns="0" rtlCol="0" anchor="ctr"/>
-          <a:lstStyle/>
-          <a:p>
-            <a:pPr indent="0" marL="0">
-              <a:buNone/>
-            </a:pPr>
-            <a:r>
-              <a:rPr lang="en-US" sz="1100" i="1" dirty="0">
-                <a:solidFill>
-                  <a:srgbClr val="5B6B7A"/>
-                </a:solidFill>
-              </a:rPr>
-              <a:t>const_pos is the hard case: a constant offset is only implausible once it crosses the radio range, and a car seen by one RSU only is reported but not revoked.</a:t>
             </a:r>
             <a:endParaRPr lang="en-US" sz="1100" dirty="0"/>
           </a:p>

</xml_diff>